<commit_message>
docs(unidad-04): add platform timeline chart to class 1 v2 slide 6
Requested by the course lead. The generator gains a "cronologia:" key
that draws era bars from each milestone year to 2026 with one highlighted
bar (palette validated for CVD and contrast). Milestone dates for App
Store, Oculus Rift and GeForce Now verified. Regenerates the v2 deck
with the slide 3 layer diagram and slide 6 timeline.

Co-Authored-By: Claude Opus 5.5 <noreply@anthropic.com>
</commit_message>
<xml_diff>
--- a/diseno-plataformas/unidad-04/Unidad-4-Clase-1-2026-v2.pptx
+++ b/diseno-plataformas/unidad-04/Unidad-4-Clase-1-2026-v2.pptx
@@ -1731,7 +1731,47 @@
           </a:p>
           <a:p>
             <a:r>
-              <a:t>Preguntar quién recuerda el diagrama de tres capas (dispositivo → intención → nave). Hoy vamos a ver por qué cada viñeta es una restricción de diseño, con números y fuentes oficiales.</a:t>
+              <a:t>Diagrama de las tres capas (pedido por la titular, agregado en la v2):</a:t>
+            </a:r>
+          </a:p>
+          <a:p>
+            <a:r>
+              <a:t>- Dispositivo: CÓMO pide el jugador la acción (teclado, pantalla táctil, gamepad). Es lo que cambia de una plataforma a otra.</a:t>
+            </a:r>
+          </a:p>
+          <a:p>
+            <a:r>
+              <a:t>- Intención: QUÉ quiere hacer el jugador (mover, disparar). Es independiente del dispositivo.</a:t>
+            </a:r>
+          </a:p>
+          <a:p>
+            <a:r>
+              <a:t>- Nave: la lógica del juego (movimiento, disparo, límites). No debería saber de dónde vino la orden.</a:t>
+            </a:r>
+          </a:p>
+          <a:p>
+            <a:r>
+              <a:t>Leerlo de arriba hacia abajo: cada dispositivo se traduce a la misma intención, y la nave solo recibe intenciones. Así, llevar el juego a móvil significa agregar un dispositivo (táctil), no reescribir la nave.</a:t>
+            </a:r>
+          </a:p>
+          <a:p>
+            <a:r>
+              <a:t>El problema real de Asteroides (nota en rojo de la slide): hoy Ship.cs (líneas 61–73) lee Input.GetKey(KeyCode.Space / LeftArrow / RightArrow) directamente, salteando la capa de intención. Por eso, para pasar a móvil habría que modificar la clase de la nave: es el supuesto S1 del caso práctico, que los alumnos van a encontrar en la actividad A4.2.</a:t>
+            </a:r>
+          </a:p>
+          <a:p>
+            <a:r>
+              <a:t>En Unity, la capa de intención la ofrece el Input System: las Actions (Move, Fire) separan la acción de sus bindings (teclado, táctil, gamepad). Solo mencionarlo; se trabaja en la Clase 2 (On-Screen Controls).</a:t>
+            </a:r>
+          </a:p>
+          <a:p>
+            <a:r>
+              <a:t>Preguntar: ¿qué partes de la nave NO deberían cambiar al pasar a móvil? Respuesta: la lógica de movimiento, disparo y límites; solo cambia la capa de dispositivo (y los límites, por el aspect ratio, como vamos a ver en la slide 17).</a:t>
+            </a:r>
+          </a:p>
+          <a:p>
+            <a:r>
+              <a:t>Hoy vamos a ver por qué cada viñeta es una restricción de diseño, con números y fuentes oficiales.</a:t>
             </a:r>
           </a:p>
         </p:txBody>
@@ -2012,6 +2052,21 @@
           <a:p>
             <a:r>
               <a:t>Dato a remarcar: Asteroids, el juego que inspira nuestro proyecto, es justamente un clásico arcade (Atari, 1979). Estamos llevando un diseño de arcade al teléfono.</a:t>
+            </a:r>
+          </a:p>
+          <a:p>
+            <a:r>
+              <a:t>Cómo leer la cronología (pedido de la titular): cada barra arranca en el hito que abre una época y llega hasta hoy (2026). Las barras no "terminan" porque ninguna plataforma desapareció: los arcades, las consolas y la PC siguen vigentes, y cada época nueva se SUMA a las anteriores en lugar de reemplazarlas. La barra destacada es la del teléfono (2008, lanzamiento del App Store), la época de esta unidad.</a:t>
+            </a:r>
+          </a:p>
+          <a:p>
+            <a:r>
+              <a:t>Hitos usados: Pong (1972, arcade); Atari 2600 (1977, popularizó la consola doméstica con cartuchos); IBM PC (1981); Game Boy (1989); App Store (10/07/2008, verificado en Apple Newsroom); Oculus Rift (28/03/2016, primer visor de VR de consumo masivo); GeForce Now (04/02/2020, lanzamiento comercial del cloud gaming de NVIDIA). Son hitos de referencia, no "inventos" de cada época: por ejemplo, la primera consola doméstica fue la Magnavox Odyssey (1972) y en PC se jugaba antes de 1981.</a:t>
+            </a:r>
+          </a:p>
+          <a:p>
+            <a:r>
+              <a:t>Pregunta posible: ¿qué tiene de distinto la época del teléfono respecto de las anteriores? Respuesta esperada: el jugador no compra el dispositivo para jugar, porque ya lo lleva en el bolsillo por otros motivos; por eso el juego compite con llamadas, mensajes y notificaciones (lo que vemos hoy en las slides 12 y 13).</a:t>
             </a:r>
           </a:p>
           <a:p>
@@ -12742,33 +12797,34 @@
                 </a:solidFill>
                 <a:latin typeface="Calibri"/>
               </a:rPr>
-              <a:t>Clase 28/09/2026 — Clase2-Plataformas.pptx</a:t>
-            </a:r>
-          </a:p>
-        </p:txBody>
-      </p:sp>
-      <p:sp>
-        <p:nvSpPr>
-          <p:cNvPr id="9" name="Rectangle 8"/>
+              <a:t>Clase 28/09/2026 — Clase2-Plataformas.pptx; código del proyecto (Ship.cs 61–73)</a:t>
+            </a:r>
+          </a:p>
+        </p:txBody>
+      </p:sp>
+      <p:sp>
+        <p:nvSpPr>
+          <p:cNvPr id="9" name="Rounded Rectangle 8"/>
           <p:cNvSpPr/>
           <p:nvPr/>
         </p:nvSpPr>
         <p:spPr>
           <a:xfrm>
-            <a:off x="7756855" y="1234440"/>
-            <a:ext cx="3931920" cy="4754880"/>
-          </a:xfrm>
-          <a:prstGeom prst="rect">
-            <a:avLst/>
+            <a:off x="6568135" y="1234440"/>
+            <a:ext cx="5120640" cy="1191768"/>
+          </a:xfrm>
+          <a:prstGeom prst="roundRect">
+            <a:avLst>
+              <a:gd name="adj" fmla="val 12000"/>
+            </a:avLst>
           </a:prstGeom>
           <a:solidFill>
             <a:srgbClr val="F3F4F6"/>
           </a:solidFill>
-          <a:ln>
+          <a:ln w="25400">
             <a:solidFill>
-              <a:srgbClr val="6B7280"/>
+              <a:srgbClr val="0D9488"/>
             </a:solidFill>
-            <a:prstDash val="dash"/>
           </a:ln>
           <a:effectLst/>
         </p:spPr>
@@ -12787,31 +12843,10 @@
           </a:fontRef>
         </p:style>
         <p:txBody>
-          <a:bodyPr rtlCol="0" anchor="ctr" wrap="square" lIns="182880" rIns="182880"/>
+          <a:bodyPr rtlCol="0" anchor="ctr"/>
           <a:lstStyle/>
           <a:p>
             <a:pPr algn="ctr"/>
-            <a:r>
-              <a:rPr sz="1300" b="1" i="0">
-                <a:solidFill>
-                  <a:srgbClr val="6B7280"/>
-                </a:solidFill>
-                <a:latin typeface="Calibri"/>
-              </a:rPr>
-              <a:t>[IMAGEN SUGERIDA]</a:t>
-            </a:r>
-          </a:p>
-          <a:p>
-            <a:pPr algn="ctr"/>
-            <a:r>
-              <a:rPr sz="1300" b="0" i="1">
-                <a:solidFill>
-                  <a:srgbClr val="6B7280"/>
-                </a:solidFill>
-                <a:latin typeface="Calibri"/>
-              </a:rPr>
-              <a:t>Miniaturas de las slides 8 (móvil) y 12 (intención vs. dispositivo) de la clase del 28/09.</a:t>
-            </a:r>
           </a:p>
         </p:txBody>
       </p:sp>
@@ -12823,8 +12858,753 @@
         </p:nvSpPr>
         <p:spPr>
           <a:xfrm>
+            <a:off x="6751015" y="1325880"/>
+            <a:ext cx="4754880" cy="365760"/>
+          </a:xfrm>
+          <a:prstGeom prst="rect">
+            <a:avLst/>
+          </a:prstGeom>
+          <a:noFill/>
+        </p:spPr>
+        <p:txBody>
+          <a:bodyPr wrap="square" anchor="t" lIns="0" rIns="0" tIns="0" bIns="0">
+            <a:spAutoFit/>
+          </a:bodyPr>
+          <a:lstStyle/>
+          <a:p>
+            <a:r>
+              <a:rPr sz="1500" b="1" i="0">
+                <a:solidFill>
+                  <a:srgbClr val="0D9488"/>
+                </a:solidFill>
+                <a:latin typeface="Calibri"/>
+              </a:rPr>
+              <a:t>DISPOSITIVO</a:t>
+            </a:r>
+          </a:p>
+        </p:txBody>
+      </p:sp>
+      <p:sp>
+        <p:nvSpPr>
+          <p:cNvPr id="11" name="Rounded Rectangle 10"/>
+          <p:cNvSpPr/>
+          <p:nvPr/>
+        </p:nvSpPr>
+        <p:spPr>
+          <a:xfrm>
+            <a:off x="6751015" y="1786128"/>
+            <a:ext cx="1493520" cy="502920"/>
+          </a:xfrm>
+          <a:prstGeom prst="roundRect">
+            <a:avLst/>
+          </a:prstGeom>
+          <a:solidFill>
+            <a:srgbClr val="0D9488"/>
+          </a:solidFill>
+          <a:ln>
+            <a:noFill/>
+          </a:ln>
+          <a:effectLst/>
+        </p:spPr>
+        <p:style>
+          <a:lnRef idx="1">
+            <a:schemeClr val="accent1"/>
+          </a:lnRef>
+          <a:fillRef idx="3">
+            <a:schemeClr val="accent1"/>
+          </a:fillRef>
+          <a:effectRef idx="2">
+            <a:schemeClr val="accent1"/>
+          </a:effectRef>
+          <a:fontRef idx="minor">
+            <a:schemeClr val="lt1"/>
+          </a:fontRef>
+        </p:style>
+        <p:txBody>
+          <a:bodyPr rtlCol="0" anchor="ctr" wrap="square" lIns="45720" rIns="45720"/>
+          <a:lstStyle/>
+          <a:p>
+            <a:pPr algn="ctr"/>
+            <a:r>
+              <a:rPr sz="1400" b="1" i="0">
+                <a:solidFill>
+                  <a:srgbClr val="FFFFFF"/>
+                </a:solidFill>
+                <a:latin typeface="Calibri"/>
+              </a:rPr>
+              <a:t>Teclado</a:t>
+            </a:r>
+          </a:p>
+        </p:txBody>
+      </p:sp>
+      <p:sp>
+        <p:nvSpPr>
+          <p:cNvPr id="12" name="Rounded Rectangle 11"/>
+          <p:cNvSpPr/>
+          <p:nvPr/>
+        </p:nvSpPr>
+        <p:spPr>
+          <a:xfrm>
+            <a:off x="8381695" y="1786128"/>
+            <a:ext cx="1493520" cy="502920"/>
+          </a:xfrm>
+          <a:prstGeom prst="roundRect">
+            <a:avLst/>
+          </a:prstGeom>
+          <a:solidFill>
+            <a:srgbClr val="0D9488"/>
+          </a:solidFill>
+          <a:ln>
+            <a:noFill/>
+          </a:ln>
+          <a:effectLst/>
+        </p:spPr>
+        <p:style>
+          <a:lnRef idx="1">
+            <a:schemeClr val="accent1"/>
+          </a:lnRef>
+          <a:fillRef idx="3">
+            <a:schemeClr val="accent1"/>
+          </a:fillRef>
+          <a:effectRef idx="2">
+            <a:schemeClr val="accent1"/>
+          </a:effectRef>
+          <a:fontRef idx="minor">
+            <a:schemeClr val="lt1"/>
+          </a:fontRef>
+        </p:style>
+        <p:txBody>
+          <a:bodyPr rtlCol="0" anchor="ctr" wrap="square" lIns="45720" rIns="45720"/>
+          <a:lstStyle/>
+          <a:p>
+            <a:pPr algn="ctr"/>
+            <a:r>
+              <a:rPr sz="1400" b="1" i="0">
+                <a:solidFill>
+                  <a:srgbClr val="FFFFFF"/>
+                </a:solidFill>
+                <a:latin typeface="Calibri"/>
+              </a:rPr>
+              <a:t>Táctil</a:t>
+            </a:r>
+          </a:p>
+        </p:txBody>
+      </p:sp>
+      <p:sp>
+        <p:nvSpPr>
+          <p:cNvPr id="13" name="Rounded Rectangle 12"/>
+          <p:cNvSpPr/>
+          <p:nvPr/>
+        </p:nvSpPr>
+        <p:spPr>
+          <a:xfrm>
+            <a:off x="10012375" y="1786128"/>
+            <a:ext cx="1493520" cy="502920"/>
+          </a:xfrm>
+          <a:prstGeom prst="roundRect">
+            <a:avLst/>
+          </a:prstGeom>
+          <a:solidFill>
+            <a:srgbClr val="0D9488"/>
+          </a:solidFill>
+          <a:ln>
+            <a:noFill/>
+          </a:ln>
+          <a:effectLst/>
+        </p:spPr>
+        <p:style>
+          <a:lnRef idx="1">
+            <a:schemeClr val="accent1"/>
+          </a:lnRef>
+          <a:fillRef idx="3">
+            <a:schemeClr val="accent1"/>
+          </a:fillRef>
+          <a:effectRef idx="2">
+            <a:schemeClr val="accent1"/>
+          </a:effectRef>
+          <a:fontRef idx="minor">
+            <a:schemeClr val="lt1"/>
+          </a:fontRef>
+        </p:style>
+        <p:txBody>
+          <a:bodyPr rtlCol="0" anchor="ctr" wrap="square" lIns="45720" rIns="45720"/>
+          <a:lstStyle/>
+          <a:p>
+            <a:pPr algn="ctr"/>
+            <a:r>
+              <a:rPr sz="1400" b="1" i="0">
+                <a:solidFill>
+                  <a:srgbClr val="FFFFFF"/>
+                </a:solidFill>
+                <a:latin typeface="Calibri"/>
+              </a:rPr>
+              <a:t>Gamepad</a:t>
+            </a:r>
+          </a:p>
+        </p:txBody>
+      </p:sp>
+      <p:sp>
+        <p:nvSpPr>
+          <p:cNvPr id="14" name="Down Arrow 13"/>
+          <p:cNvSpPr/>
+          <p:nvPr/>
+        </p:nvSpPr>
+        <p:spPr>
+          <a:xfrm>
+            <a:off x="8899855" y="2462784"/>
+            <a:ext cx="457200" cy="310896"/>
+          </a:xfrm>
+          <a:prstGeom prst="downArrow">
+            <a:avLst/>
+          </a:prstGeom>
+          <a:solidFill>
+            <a:srgbClr val="6B7280"/>
+          </a:solidFill>
+          <a:ln>
+            <a:noFill/>
+          </a:ln>
+          <a:effectLst/>
+        </p:spPr>
+        <p:style>
+          <a:lnRef idx="1">
+            <a:schemeClr val="accent1"/>
+          </a:lnRef>
+          <a:fillRef idx="3">
+            <a:schemeClr val="accent1"/>
+          </a:fillRef>
+          <a:effectRef idx="2">
+            <a:schemeClr val="accent1"/>
+          </a:effectRef>
+          <a:fontRef idx="minor">
+            <a:schemeClr val="lt1"/>
+          </a:fontRef>
+        </p:style>
+        <p:txBody>
+          <a:bodyPr rtlCol="0" anchor="ctr"/>
+          <a:lstStyle/>
+          <a:p>
+            <a:pPr algn="ctr"/>
+          </a:p>
+        </p:txBody>
+      </p:sp>
+      <p:sp>
+        <p:nvSpPr>
+          <p:cNvPr id="15" name="Rounded Rectangle 14"/>
+          <p:cNvSpPr/>
+          <p:nvPr/>
+        </p:nvSpPr>
+        <p:spPr>
+          <a:xfrm>
+            <a:off x="6568135" y="2810256"/>
+            <a:ext cx="5120640" cy="1191768"/>
+          </a:xfrm>
+          <a:prstGeom prst="roundRect">
+            <a:avLst>
+              <a:gd name="adj" fmla="val 12000"/>
+            </a:avLst>
+          </a:prstGeom>
+          <a:solidFill>
+            <a:srgbClr val="F3F4F6"/>
+          </a:solidFill>
+          <a:ln w="25400">
+            <a:solidFill>
+              <a:srgbClr val="D97706"/>
+            </a:solidFill>
+          </a:ln>
+          <a:effectLst/>
+        </p:spPr>
+        <p:style>
+          <a:lnRef idx="1">
+            <a:schemeClr val="accent1"/>
+          </a:lnRef>
+          <a:fillRef idx="3">
+            <a:schemeClr val="accent1"/>
+          </a:fillRef>
+          <a:effectRef idx="2">
+            <a:schemeClr val="accent1"/>
+          </a:effectRef>
+          <a:fontRef idx="minor">
+            <a:schemeClr val="lt1"/>
+          </a:fontRef>
+        </p:style>
+        <p:txBody>
+          <a:bodyPr rtlCol="0" anchor="ctr"/>
+          <a:lstStyle/>
+          <a:p>
+            <a:pPr algn="ctr"/>
+          </a:p>
+        </p:txBody>
+      </p:sp>
+      <p:sp>
+        <p:nvSpPr>
+          <p:cNvPr id="16" name="TextBox 15"/>
+          <p:cNvSpPr txBox="1"/>
+          <p:nvPr/>
+        </p:nvSpPr>
+        <p:spPr>
+          <a:xfrm>
+            <a:off x="6751015" y="2901696"/>
+            <a:ext cx="4754880" cy="365760"/>
+          </a:xfrm>
+          <a:prstGeom prst="rect">
+            <a:avLst/>
+          </a:prstGeom>
+          <a:noFill/>
+        </p:spPr>
+        <p:txBody>
+          <a:bodyPr wrap="square" anchor="t" lIns="0" rIns="0" tIns="0" bIns="0">
+            <a:spAutoFit/>
+          </a:bodyPr>
+          <a:lstStyle/>
+          <a:p>
+            <a:r>
+              <a:rPr sz="1500" b="1" i="0">
+                <a:solidFill>
+                  <a:srgbClr val="D97706"/>
+                </a:solidFill>
+                <a:latin typeface="Calibri"/>
+              </a:rPr>
+              <a:t>INTENCIÓN</a:t>
+            </a:r>
+          </a:p>
+        </p:txBody>
+      </p:sp>
+      <p:sp>
+        <p:nvSpPr>
+          <p:cNvPr id="17" name="Rounded Rectangle 16"/>
+          <p:cNvSpPr/>
+          <p:nvPr/>
+        </p:nvSpPr>
+        <p:spPr>
+          <a:xfrm>
+            <a:off x="6751015" y="3361944"/>
+            <a:ext cx="2308860" cy="502920"/>
+          </a:xfrm>
+          <a:prstGeom prst="roundRect">
+            <a:avLst/>
+          </a:prstGeom>
+          <a:solidFill>
+            <a:srgbClr val="D97706"/>
+          </a:solidFill>
+          <a:ln>
+            <a:noFill/>
+          </a:ln>
+          <a:effectLst/>
+        </p:spPr>
+        <p:style>
+          <a:lnRef idx="1">
+            <a:schemeClr val="accent1"/>
+          </a:lnRef>
+          <a:fillRef idx="3">
+            <a:schemeClr val="accent1"/>
+          </a:fillRef>
+          <a:effectRef idx="2">
+            <a:schemeClr val="accent1"/>
+          </a:effectRef>
+          <a:fontRef idx="minor">
+            <a:schemeClr val="lt1"/>
+          </a:fontRef>
+        </p:style>
+        <p:txBody>
+          <a:bodyPr rtlCol="0" anchor="ctr" wrap="square" lIns="45720" rIns="45720"/>
+          <a:lstStyle/>
+          <a:p>
+            <a:pPr algn="ctr"/>
+            <a:r>
+              <a:rPr sz="1400" b="1" i="0">
+                <a:solidFill>
+                  <a:srgbClr val="FFFFFF"/>
+                </a:solidFill>
+                <a:latin typeface="Calibri"/>
+              </a:rPr>
+              <a:t>Mover</a:t>
+            </a:r>
+          </a:p>
+        </p:txBody>
+      </p:sp>
+      <p:sp>
+        <p:nvSpPr>
+          <p:cNvPr id="18" name="Rounded Rectangle 17"/>
+          <p:cNvSpPr/>
+          <p:nvPr/>
+        </p:nvSpPr>
+        <p:spPr>
+          <a:xfrm>
+            <a:off x="9197035" y="3361944"/>
+            <a:ext cx="2308860" cy="502920"/>
+          </a:xfrm>
+          <a:prstGeom prst="roundRect">
+            <a:avLst/>
+          </a:prstGeom>
+          <a:solidFill>
+            <a:srgbClr val="D97706"/>
+          </a:solidFill>
+          <a:ln>
+            <a:noFill/>
+          </a:ln>
+          <a:effectLst/>
+        </p:spPr>
+        <p:style>
+          <a:lnRef idx="1">
+            <a:schemeClr val="accent1"/>
+          </a:lnRef>
+          <a:fillRef idx="3">
+            <a:schemeClr val="accent1"/>
+          </a:fillRef>
+          <a:effectRef idx="2">
+            <a:schemeClr val="accent1"/>
+          </a:effectRef>
+          <a:fontRef idx="minor">
+            <a:schemeClr val="lt1"/>
+          </a:fontRef>
+        </p:style>
+        <p:txBody>
+          <a:bodyPr rtlCol="0" anchor="ctr" wrap="square" lIns="45720" rIns="45720"/>
+          <a:lstStyle/>
+          <a:p>
+            <a:pPr algn="ctr"/>
+            <a:r>
+              <a:rPr sz="1400" b="1" i="0">
+                <a:solidFill>
+                  <a:srgbClr val="FFFFFF"/>
+                </a:solidFill>
+                <a:latin typeface="Calibri"/>
+              </a:rPr>
+              <a:t>Disparar</a:t>
+            </a:r>
+          </a:p>
+        </p:txBody>
+      </p:sp>
+      <p:sp>
+        <p:nvSpPr>
+          <p:cNvPr id="19" name="Down Arrow 18"/>
+          <p:cNvSpPr/>
+          <p:nvPr/>
+        </p:nvSpPr>
+        <p:spPr>
+          <a:xfrm>
+            <a:off x="8899855" y="4038600"/>
+            <a:ext cx="457200" cy="310896"/>
+          </a:xfrm>
+          <a:prstGeom prst="downArrow">
+            <a:avLst/>
+          </a:prstGeom>
+          <a:solidFill>
+            <a:srgbClr val="6B7280"/>
+          </a:solidFill>
+          <a:ln>
+            <a:noFill/>
+          </a:ln>
+          <a:effectLst/>
+        </p:spPr>
+        <p:style>
+          <a:lnRef idx="1">
+            <a:schemeClr val="accent1"/>
+          </a:lnRef>
+          <a:fillRef idx="3">
+            <a:schemeClr val="accent1"/>
+          </a:fillRef>
+          <a:effectRef idx="2">
+            <a:schemeClr val="accent1"/>
+          </a:effectRef>
+          <a:fontRef idx="minor">
+            <a:schemeClr val="lt1"/>
+          </a:fontRef>
+        </p:style>
+        <p:txBody>
+          <a:bodyPr rtlCol="0" anchor="ctr"/>
+          <a:lstStyle/>
+          <a:p>
+            <a:pPr algn="ctr"/>
+          </a:p>
+        </p:txBody>
+      </p:sp>
+      <p:sp>
+        <p:nvSpPr>
+          <p:cNvPr id="20" name="Rounded Rectangle 19"/>
+          <p:cNvSpPr/>
+          <p:nvPr/>
+        </p:nvSpPr>
+        <p:spPr>
+          <a:xfrm>
+            <a:off x="6568135" y="4386072"/>
+            <a:ext cx="5120640" cy="1191768"/>
+          </a:xfrm>
+          <a:prstGeom prst="roundRect">
+            <a:avLst>
+              <a:gd name="adj" fmla="val 12000"/>
+            </a:avLst>
+          </a:prstGeom>
+          <a:solidFill>
+            <a:srgbClr val="F3F4F6"/>
+          </a:solidFill>
+          <a:ln w="25400">
+            <a:solidFill>
+              <a:srgbClr val="1F2A44"/>
+            </a:solidFill>
+          </a:ln>
+          <a:effectLst/>
+        </p:spPr>
+        <p:style>
+          <a:lnRef idx="1">
+            <a:schemeClr val="accent1"/>
+          </a:lnRef>
+          <a:fillRef idx="3">
+            <a:schemeClr val="accent1"/>
+          </a:fillRef>
+          <a:effectRef idx="2">
+            <a:schemeClr val="accent1"/>
+          </a:effectRef>
+          <a:fontRef idx="minor">
+            <a:schemeClr val="lt1"/>
+          </a:fontRef>
+        </p:style>
+        <p:txBody>
+          <a:bodyPr rtlCol="0" anchor="ctr"/>
+          <a:lstStyle/>
+          <a:p>
+            <a:pPr algn="ctr"/>
+          </a:p>
+        </p:txBody>
+      </p:sp>
+      <p:sp>
+        <p:nvSpPr>
+          <p:cNvPr id="21" name="TextBox 20"/>
+          <p:cNvSpPr txBox="1"/>
+          <p:nvPr/>
+        </p:nvSpPr>
+        <p:spPr>
+          <a:xfrm>
+            <a:off x="6751015" y="4477512"/>
+            <a:ext cx="4754880" cy="365760"/>
+          </a:xfrm>
+          <a:prstGeom prst="rect">
+            <a:avLst/>
+          </a:prstGeom>
+          <a:noFill/>
+        </p:spPr>
+        <p:txBody>
+          <a:bodyPr wrap="square" anchor="t" lIns="0" rIns="0" tIns="0" bIns="0">
+            <a:spAutoFit/>
+          </a:bodyPr>
+          <a:lstStyle/>
+          <a:p>
+            <a:r>
+              <a:rPr sz="1500" b="1" i="0">
+                <a:solidFill>
+                  <a:srgbClr val="1F2A44"/>
+                </a:solidFill>
+                <a:latin typeface="Calibri"/>
+              </a:rPr>
+              <a:t>NAVE</a:t>
+            </a:r>
+          </a:p>
+        </p:txBody>
+      </p:sp>
+      <p:sp>
+        <p:nvSpPr>
+          <p:cNvPr id="22" name="Rounded Rectangle 21"/>
+          <p:cNvSpPr/>
+          <p:nvPr/>
+        </p:nvSpPr>
+        <p:spPr>
+          <a:xfrm>
+            <a:off x="6751015" y="4937760"/>
+            <a:ext cx="1493520" cy="502920"/>
+          </a:xfrm>
+          <a:prstGeom prst="roundRect">
+            <a:avLst/>
+          </a:prstGeom>
+          <a:solidFill>
+            <a:srgbClr val="1F2A44"/>
+          </a:solidFill>
+          <a:ln>
+            <a:noFill/>
+          </a:ln>
+          <a:effectLst/>
+        </p:spPr>
+        <p:style>
+          <a:lnRef idx="1">
+            <a:schemeClr val="accent1"/>
+          </a:lnRef>
+          <a:fillRef idx="3">
+            <a:schemeClr val="accent1"/>
+          </a:fillRef>
+          <a:effectRef idx="2">
+            <a:schemeClr val="accent1"/>
+          </a:effectRef>
+          <a:fontRef idx="minor">
+            <a:schemeClr val="lt1"/>
+          </a:fontRef>
+        </p:style>
+        <p:txBody>
+          <a:bodyPr rtlCol="0" anchor="ctr" wrap="square" lIns="45720" rIns="45720"/>
+          <a:lstStyle/>
+          <a:p>
+            <a:pPr algn="ctr"/>
+            <a:r>
+              <a:rPr sz="1400" b="1" i="0">
+                <a:solidFill>
+                  <a:srgbClr val="FFFFFF"/>
+                </a:solidFill>
+                <a:latin typeface="Calibri"/>
+              </a:rPr>
+              <a:t>Movimiento</a:t>
+            </a:r>
+          </a:p>
+        </p:txBody>
+      </p:sp>
+      <p:sp>
+        <p:nvSpPr>
+          <p:cNvPr id="23" name="Rounded Rectangle 22"/>
+          <p:cNvSpPr/>
+          <p:nvPr/>
+        </p:nvSpPr>
+        <p:spPr>
+          <a:xfrm>
+            <a:off x="8381695" y="4937760"/>
+            <a:ext cx="1493520" cy="502920"/>
+          </a:xfrm>
+          <a:prstGeom prst="roundRect">
+            <a:avLst/>
+          </a:prstGeom>
+          <a:solidFill>
+            <a:srgbClr val="1F2A44"/>
+          </a:solidFill>
+          <a:ln>
+            <a:noFill/>
+          </a:ln>
+          <a:effectLst/>
+        </p:spPr>
+        <p:style>
+          <a:lnRef idx="1">
+            <a:schemeClr val="accent1"/>
+          </a:lnRef>
+          <a:fillRef idx="3">
+            <a:schemeClr val="accent1"/>
+          </a:fillRef>
+          <a:effectRef idx="2">
+            <a:schemeClr val="accent1"/>
+          </a:effectRef>
+          <a:fontRef idx="minor">
+            <a:schemeClr val="lt1"/>
+          </a:fontRef>
+        </p:style>
+        <p:txBody>
+          <a:bodyPr rtlCol="0" anchor="ctr" wrap="square" lIns="45720" rIns="45720"/>
+          <a:lstStyle/>
+          <a:p>
+            <a:pPr algn="ctr"/>
+            <a:r>
+              <a:rPr sz="1400" b="1" i="0">
+                <a:solidFill>
+                  <a:srgbClr val="FFFFFF"/>
+                </a:solidFill>
+                <a:latin typeface="Calibri"/>
+              </a:rPr>
+              <a:t>Disparo</a:t>
+            </a:r>
+          </a:p>
+        </p:txBody>
+      </p:sp>
+      <p:sp>
+        <p:nvSpPr>
+          <p:cNvPr id="24" name="Rounded Rectangle 23"/>
+          <p:cNvSpPr/>
+          <p:nvPr/>
+        </p:nvSpPr>
+        <p:spPr>
+          <a:xfrm>
+            <a:off x="10012375" y="4937760"/>
+            <a:ext cx="1493520" cy="502920"/>
+          </a:xfrm>
+          <a:prstGeom prst="roundRect">
+            <a:avLst/>
+          </a:prstGeom>
+          <a:solidFill>
+            <a:srgbClr val="1F2A44"/>
+          </a:solidFill>
+          <a:ln>
+            <a:noFill/>
+          </a:ln>
+          <a:effectLst/>
+        </p:spPr>
+        <p:style>
+          <a:lnRef idx="1">
+            <a:schemeClr val="accent1"/>
+          </a:lnRef>
+          <a:fillRef idx="3">
+            <a:schemeClr val="accent1"/>
+          </a:fillRef>
+          <a:effectRef idx="2">
+            <a:schemeClr val="accent1"/>
+          </a:effectRef>
+          <a:fontRef idx="minor">
+            <a:schemeClr val="lt1"/>
+          </a:fontRef>
+        </p:style>
+        <p:txBody>
+          <a:bodyPr rtlCol="0" anchor="ctr" wrap="square" lIns="45720" rIns="45720"/>
+          <a:lstStyle/>
+          <a:p>
+            <a:pPr algn="ctr"/>
+            <a:r>
+              <a:rPr sz="1400" b="1" i="0">
+                <a:solidFill>
+                  <a:srgbClr val="FFFFFF"/>
+                </a:solidFill>
+                <a:latin typeface="Calibri"/>
+              </a:rPr>
+              <a:t>Límites</a:t>
+            </a:r>
+          </a:p>
+        </p:txBody>
+      </p:sp>
+      <p:sp>
+        <p:nvSpPr>
+          <p:cNvPr id="25" name="TextBox 24"/>
+          <p:cNvSpPr txBox="1"/>
+          <p:nvPr/>
+        </p:nvSpPr>
+        <p:spPr>
+          <a:xfrm>
+            <a:off x="6568135" y="5669280"/>
+            <a:ext cx="5120640" cy="320040"/>
+          </a:xfrm>
+          <a:prstGeom prst="rect">
+            <a:avLst/>
+          </a:prstGeom>
+          <a:noFill/>
+        </p:spPr>
+        <p:txBody>
+          <a:bodyPr wrap="square" anchor="ctr" lIns="0" rIns="0" tIns="0" bIns="0">
+            <a:spAutoFit/>
+          </a:bodyPr>
+          <a:lstStyle/>
+          <a:p>
+            <a:pPr algn="ctr"/>
+            <a:r>
+              <a:rPr sz="1300" b="0" i="1">
+                <a:solidFill>
+                  <a:srgbClr val="DC2626"/>
+                </a:solidFill>
+                <a:latin typeface="Calibri"/>
+              </a:rPr>
+              <a:t>Hoy Ship.cs lee el teclado directo: falta la capa del medio</a:t>
+            </a:r>
+          </a:p>
+        </p:txBody>
+      </p:sp>
+      <p:sp>
+        <p:nvSpPr>
+          <p:cNvPr id="26" name="TextBox 25"/>
+          <p:cNvSpPr txBox="1"/>
+          <p:nvPr/>
+        </p:nvSpPr>
+        <p:spPr>
+          <a:xfrm>
             <a:off x="502920" y="1234440"/>
-            <a:ext cx="6979615" cy="4754880"/>
+            <a:ext cx="5790895" cy="4754880"/>
           </a:xfrm>
           <a:prstGeom prst="rect">
             <a:avLst/>
@@ -14508,7 +15288,7 @@
                 </a:solidFill>
                 <a:latin typeface="Calibri"/>
               </a:rPr>
-              <a:t>Kevuru Games (blog, consultado 2026-10-05); ejemplos históricos ampliamente documentados</a:t>
+              <a:t>Kevuru Games (blog); Apple Newsroom (App Store, 10/07/2008); lanzamientos de Oculus Rift (28/03/2016) y GeForce Now (04/02/2020)</a:t>
             </a:r>
           </a:p>
         </p:txBody>
@@ -14521,20 +15301,17 @@
         </p:nvSpPr>
         <p:spPr>
           <a:xfrm>
-            <a:off x="7756855" y="1234440"/>
-            <a:ext cx="3931920" cy="4754880"/>
+            <a:off x="7071055" y="1234440"/>
+            <a:ext cx="12700" cy="4069080"/>
           </a:xfrm>
           <a:prstGeom prst="rect">
             <a:avLst/>
           </a:prstGeom>
           <a:solidFill>
-            <a:srgbClr val="F3F4F6"/>
+            <a:srgbClr val="E5E7EB"/>
           </a:solidFill>
           <a:ln>
-            <a:solidFill>
-              <a:srgbClr val="6B7280"/>
-            </a:solidFill>
-            <a:prstDash val="dash"/>
+            <a:noFill/>
           </a:ln>
           <a:effectLst/>
         </p:spPr>
@@ -14553,31 +15330,10 @@
           </a:fontRef>
         </p:style>
         <p:txBody>
-          <a:bodyPr rtlCol="0" anchor="ctr" wrap="square" lIns="182880" rIns="182880"/>
+          <a:bodyPr rtlCol="0" anchor="ctr"/>
           <a:lstStyle/>
           <a:p>
             <a:pPr algn="ctr"/>
-            <a:r>
-              <a:rPr sz="1300" b="1" i="0">
-                <a:solidFill>
-                  <a:srgbClr val="6B7280"/>
-                </a:solidFill>
-                <a:latin typeface="Calibri"/>
-              </a:rPr>
-              <a:t>[IMAGEN SUGERIDA]</a:t>
-            </a:r>
-          </a:p>
-          <a:p>
-            <a:pPr algn="ctr"/>
-            <a:r>
-              <a:rPr sz="1300" b="0" i="1">
-                <a:solidFill>
-                  <a:srgbClr val="6B7280"/>
-                </a:solidFill>
-                <a:latin typeface="Calibri"/>
-              </a:rPr>
-              <a:t>Línea de tiempo: gabinete arcade → consola en la TV → PC → Game Boy → teléfono → visor XR / nube.</a:t>
-            </a:r>
           </a:p>
         </p:txBody>
       </p:sp>
@@ -14589,8 +15345,1129 @@
         </p:nvSpPr>
         <p:spPr>
           <a:xfrm>
+            <a:off x="6705295" y="5349240"/>
+            <a:ext cx="731520" cy="274320"/>
+          </a:xfrm>
+          <a:prstGeom prst="rect">
+            <a:avLst/>
+          </a:prstGeom>
+          <a:noFill/>
+        </p:spPr>
+        <p:txBody>
+          <a:bodyPr wrap="square" anchor="t" lIns="0" rIns="0" tIns="0" bIns="0">
+            <a:spAutoFit/>
+          </a:bodyPr>
+          <a:lstStyle/>
+          <a:p>
+            <a:pPr algn="ctr"/>
+            <a:r>
+              <a:rPr sz="1100" b="0" i="0">
+                <a:solidFill>
+                  <a:srgbClr val="6B7280"/>
+                </a:solidFill>
+                <a:latin typeface="Calibri"/>
+              </a:rPr>
+              <a:t>1970</a:t>
+            </a:r>
+          </a:p>
+        </p:txBody>
+      </p:sp>
+      <p:sp>
+        <p:nvSpPr>
+          <p:cNvPr id="11" name="Rectangle 10"/>
+          <p:cNvSpPr/>
+          <p:nvPr/>
+        </p:nvSpPr>
+        <p:spPr>
+          <a:xfrm>
+            <a:off x="7879319" y="1234440"/>
+            <a:ext cx="12700" cy="4069080"/>
+          </a:xfrm>
+          <a:prstGeom prst="rect">
+            <a:avLst/>
+          </a:prstGeom>
+          <a:solidFill>
+            <a:srgbClr val="E5E7EB"/>
+          </a:solidFill>
+          <a:ln>
+            <a:noFill/>
+          </a:ln>
+          <a:effectLst/>
+        </p:spPr>
+        <p:style>
+          <a:lnRef idx="1">
+            <a:schemeClr val="accent1"/>
+          </a:lnRef>
+          <a:fillRef idx="3">
+            <a:schemeClr val="accent1"/>
+          </a:fillRef>
+          <a:effectRef idx="2">
+            <a:schemeClr val="accent1"/>
+          </a:effectRef>
+          <a:fontRef idx="minor">
+            <a:schemeClr val="lt1"/>
+          </a:fontRef>
+        </p:style>
+        <p:txBody>
+          <a:bodyPr rtlCol="0" anchor="ctr"/>
+          <a:lstStyle/>
+          <a:p>
+            <a:pPr algn="ctr"/>
+          </a:p>
+        </p:txBody>
+      </p:sp>
+      <p:sp>
+        <p:nvSpPr>
+          <p:cNvPr id="12" name="TextBox 11"/>
+          <p:cNvSpPr txBox="1"/>
+          <p:nvPr/>
+        </p:nvSpPr>
+        <p:spPr>
+          <a:xfrm>
+            <a:off x="7513559" y="5349240"/>
+            <a:ext cx="731520" cy="274320"/>
+          </a:xfrm>
+          <a:prstGeom prst="rect">
+            <a:avLst/>
+          </a:prstGeom>
+          <a:noFill/>
+        </p:spPr>
+        <p:txBody>
+          <a:bodyPr wrap="square" anchor="t" lIns="0" rIns="0" tIns="0" bIns="0">
+            <a:spAutoFit/>
+          </a:bodyPr>
+          <a:lstStyle/>
+          <a:p>
+            <a:pPr algn="ctr"/>
+            <a:r>
+              <a:rPr sz="1100" b="0" i="0">
+                <a:solidFill>
+                  <a:srgbClr val="6B7280"/>
+                </a:solidFill>
+                <a:latin typeface="Calibri"/>
+              </a:rPr>
+              <a:t>1980</a:t>
+            </a:r>
+          </a:p>
+        </p:txBody>
+      </p:sp>
+      <p:sp>
+        <p:nvSpPr>
+          <p:cNvPr id="13" name="Rectangle 12"/>
+          <p:cNvSpPr/>
+          <p:nvPr/>
+        </p:nvSpPr>
+        <p:spPr>
+          <a:xfrm>
+            <a:off x="8687583" y="1234440"/>
+            <a:ext cx="12700" cy="4069080"/>
+          </a:xfrm>
+          <a:prstGeom prst="rect">
+            <a:avLst/>
+          </a:prstGeom>
+          <a:solidFill>
+            <a:srgbClr val="E5E7EB"/>
+          </a:solidFill>
+          <a:ln>
+            <a:noFill/>
+          </a:ln>
+          <a:effectLst/>
+        </p:spPr>
+        <p:style>
+          <a:lnRef idx="1">
+            <a:schemeClr val="accent1"/>
+          </a:lnRef>
+          <a:fillRef idx="3">
+            <a:schemeClr val="accent1"/>
+          </a:fillRef>
+          <a:effectRef idx="2">
+            <a:schemeClr val="accent1"/>
+          </a:effectRef>
+          <a:fontRef idx="minor">
+            <a:schemeClr val="lt1"/>
+          </a:fontRef>
+        </p:style>
+        <p:txBody>
+          <a:bodyPr rtlCol="0" anchor="ctr"/>
+          <a:lstStyle/>
+          <a:p>
+            <a:pPr algn="ctr"/>
+          </a:p>
+        </p:txBody>
+      </p:sp>
+      <p:sp>
+        <p:nvSpPr>
+          <p:cNvPr id="14" name="TextBox 13"/>
+          <p:cNvSpPr txBox="1"/>
+          <p:nvPr/>
+        </p:nvSpPr>
+        <p:spPr>
+          <a:xfrm>
+            <a:off x="8321823" y="5349240"/>
+            <a:ext cx="731520" cy="274320"/>
+          </a:xfrm>
+          <a:prstGeom prst="rect">
+            <a:avLst/>
+          </a:prstGeom>
+          <a:noFill/>
+        </p:spPr>
+        <p:txBody>
+          <a:bodyPr wrap="square" anchor="t" lIns="0" rIns="0" tIns="0" bIns="0">
+            <a:spAutoFit/>
+          </a:bodyPr>
+          <a:lstStyle/>
+          <a:p>
+            <a:pPr algn="ctr"/>
+            <a:r>
+              <a:rPr sz="1100" b="0" i="0">
+                <a:solidFill>
+                  <a:srgbClr val="6B7280"/>
+                </a:solidFill>
+                <a:latin typeface="Calibri"/>
+              </a:rPr>
+              <a:t>1990</a:t>
+            </a:r>
+          </a:p>
+        </p:txBody>
+      </p:sp>
+      <p:sp>
+        <p:nvSpPr>
+          <p:cNvPr id="15" name="Rectangle 14"/>
+          <p:cNvSpPr/>
+          <p:nvPr/>
+        </p:nvSpPr>
+        <p:spPr>
+          <a:xfrm>
+            <a:off x="9495847" y="1234440"/>
+            <a:ext cx="12700" cy="4069080"/>
+          </a:xfrm>
+          <a:prstGeom prst="rect">
+            <a:avLst/>
+          </a:prstGeom>
+          <a:solidFill>
+            <a:srgbClr val="E5E7EB"/>
+          </a:solidFill>
+          <a:ln>
+            <a:noFill/>
+          </a:ln>
+          <a:effectLst/>
+        </p:spPr>
+        <p:style>
+          <a:lnRef idx="1">
+            <a:schemeClr val="accent1"/>
+          </a:lnRef>
+          <a:fillRef idx="3">
+            <a:schemeClr val="accent1"/>
+          </a:fillRef>
+          <a:effectRef idx="2">
+            <a:schemeClr val="accent1"/>
+          </a:effectRef>
+          <a:fontRef idx="minor">
+            <a:schemeClr val="lt1"/>
+          </a:fontRef>
+        </p:style>
+        <p:txBody>
+          <a:bodyPr rtlCol="0" anchor="ctr"/>
+          <a:lstStyle/>
+          <a:p>
+            <a:pPr algn="ctr"/>
+          </a:p>
+        </p:txBody>
+      </p:sp>
+      <p:sp>
+        <p:nvSpPr>
+          <p:cNvPr id="16" name="TextBox 15"/>
+          <p:cNvSpPr txBox="1"/>
+          <p:nvPr/>
+        </p:nvSpPr>
+        <p:spPr>
+          <a:xfrm>
+            <a:off x="9130087" y="5349240"/>
+            <a:ext cx="731520" cy="274320"/>
+          </a:xfrm>
+          <a:prstGeom prst="rect">
+            <a:avLst/>
+          </a:prstGeom>
+          <a:noFill/>
+        </p:spPr>
+        <p:txBody>
+          <a:bodyPr wrap="square" anchor="t" lIns="0" rIns="0" tIns="0" bIns="0">
+            <a:spAutoFit/>
+          </a:bodyPr>
+          <a:lstStyle/>
+          <a:p>
+            <a:pPr algn="ctr"/>
+            <a:r>
+              <a:rPr sz="1100" b="0" i="0">
+                <a:solidFill>
+                  <a:srgbClr val="6B7280"/>
+                </a:solidFill>
+                <a:latin typeface="Calibri"/>
+              </a:rPr>
+              <a:t>2000</a:t>
+            </a:r>
+          </a:p>
+        </p:txBody>
+      </p:sp>
+      <p:sp>
+        <p:nvSpPr>
+          <p:cNvPr id="17" name="Rectangle 16"/>
+          <p:cNvSpPr/>
+          <p:nvPr/>
+        </p:nvSpPr>
+        <p:spPr>
+          <a:xfrm>
+            <a:off x="10304112" y="1234440"/>
+            <a:ext cx="12700" cy="4069080"/>
+          </a:xfrm>
+          <a:prstGeom prst="rect">
+            <a:avLst/>
+          </a:prstGeom>
+          <a:solidFill>
+            <a:srgbClr val="E5E7EB"/>
+          </a:solidFill>
+          <a:ln>
+            <a:noFill/>
+          </a:ln>
+          <a:effectLst/>
+        </p:spPr>
+        <p:style>
+          <a:lnRef idx="1">
+            <a:schemeClr val="accent1"/>
+          </a:lnRef>
+          <a:fillRef idx="3">
+            <a:schemeClr val="accent1"/>
+          </a:fillRef>
+          <a:effectRef idx="2">
+            <a:schemeClr val="accent1"/>
+          </a:effectRef>
+          <a:fontRef idx="minor">
+            <a:schemeClr val="lt1"/>
+          </a:fontRef>
+        </p:style>
+        <p:txBody>
+          <a:bodyPr rtlCol="0" anchor="ctr"/>
+          <a:lstStyle/>
+          <a:p>
+            <a:pPr algn="ctr"/>
+          </a:p>
+        </p:txBody>
+      </p:sp>
+      <p:sp>
+        <p:nvSpPr>
+          <p:cNvPr id="18" name="TextBox 17"/>
+          <p:cNvSpPr txBox="1"/>
+          <p:nvPr/>
+        </p:nvSpPr>
+        <p:spPr>
+          <a:xfrm>
+            <a:off x="9938352" y="5349240"/>
+            <a:ext cx="731520" cy="274320"/>
+          </a:xfrm>
+          <a:prstGeom prst="rect">
+            <a:avLst/>
+          </a:prstGeom>
+          <a:noFill/>
+        </p:spPr>
+        <p:txBody>
+          <a:bodyPr wrap="square" anchor="t" lIns="0" rIns="0" tIns="0" bIns="0">
+            <a:spAutoFit/>
+          </a:bodyPr>
+          <a:lstStyle/>
+          <a:p>
+            <a:pPr algn="ctr"/>
+            <a:r>
+              <a:rPr sz="1100" b="0" i="0">
+                <a:solidFill>
+                  <a:srgbClr val="6B7280"/>
+                </a:solidFill>
+                <a:latin typeface="Calibri"/>
+              </a:rPr>
+              <a:t>2010</a:t>
+            </a:r>
+          </a:p>
+        </p:txBody>
+      </p:sp>
+      <p:sp>
+        <p:nvSpPr>
+          <p:cNvPr id="19" name="Rectangle 18"/>
+          <p:cNvSpPr/>
+          <p:nvPr/>
+        </p:nvSpPr>
+        <p:spPr>
+          <a:xfrm>
+            <a:off x="11112376" y="1234440"/>
+            <a:ext cx="12700" cy="4069080"/>
+          </a:xfrm>
+          <a:prstGeom prst="rect">
+            <a:avLst/>
+          </a:prstGeom>
+          <a:solidFill>
+            <a:srgbClr val="E5E7EB"/>
+          </a:solidFill>
+          <a:ln>
+            <a:noFill/>
+          </a:ln>
+          <a:effectLst/>
+        </p:spPr>
+        <p:style>
+          <a:lnRef idx="1">
+            <a:schemeClr val="accent1"/>
+          </a:lnRef>
+          <a:fillRef idx="3">
+            <a:schemeClr val="accent1"/>
+          </a:fillRef>
+          <a:effectRef idx="2">
+            <a:schemeClr val="accent1"/>
+          </a:effectRef>
+          <a:fontRef idx="minor">
+            <a:schemeClr val="lt1"/>
+          </a:fontRef>
+        </p:style>
+        <p:txBody>
+          <a:bodyPr rtlCol="0" anchor="ctr"/>
+          <a:lstStyle/>
+          <a:p>
+            <a:pPr algn="ctr"/>
+          </a:p>
+        </p:txBody>
+      </p:sp>
+      <p:sp>
+        <p:nvSpPr>
+          <p:cNvPr id="20" name="TextBox 19"/>
+          <p:cNvSpPr txBox="1"/>
+          <p:nvPr/>
+        </p:nvSpPr>
+        <p:spPr>
+          <a:xfrm>
+            <a:off x="10746616" y="5349240"/>
+            <a:ext cx="731520" cy="274320"/>
+          </a:xfrm>
+          <a:prstGeom prst="rect">
+            <a:avLst/>
+          </a:prstGeom>
+          <a:noFill/>
+        </p:spPr>
+        <p:txBody>
+          <a:bodyPr wrap="square" anchor="t" lIns="0" rIns="0" tIns="0" bIns="0">
+            <a:spAutoFit/>
+          </a:bodyPr>
+          <a:lstStyle/>
+          <a:p>
+            <a:pPr algn="ctr"/>
+            <a:r>
+              <a:rPr sz="1100" b="0" i="0">
+                <a:solidFill>
+                  <a:srgbClr val="6B7280"/>
+                </a:solidFill>
+                <a:latin typeface="Calibri"/>
+              </a:rPr>
+              <a:t>2020</a:t>
+            </a:r>
+          </a:p>
+        </p:txBody>
+      </p:sp>
+      <p:sp>
+        <p:nvSpPr>
+          <p:cNvPr id="21" name="TextBox 20"/>
+          <p:cNvSpPr txBox="1"/>
+          <p:nvPr/>
+        </p:nvSpPr>
+        <p:spPr>
+          <a:xfrm>
+            <a:off x="4922215" y="1272540"/>
+            <a:ext cx="2011680" cy="505097"/>
+          </a:xfrm>
+          <a:prstGeom prst="rect">
+            <a:avLst/>
+          </a:prstGeom>
+          <a:noFill/>
+        </p:spPr>
+        <p:txBody>
+          <a:bodyPr wrap="square" anchor="ctr" lIns="0" rIns="0" tIns="0" bIns="0">
+            <a:spAutoFit/>
+          </a:bodyPr>
+          <a:lstStyle/>
+          <a:p>
+            <a:pPr algn="r"/>
+            <a:r>
+              <a:rPr sz="1400" b="0" i="0">
+                <a:solidFill>
+                  <a:srgbClr val="1F2937"/>
+                </a:solidFill>
+                <a:latin typeface="Calibri"/>
+              </a:rPr>
+              <a:t>Arcade · Pong</a:t>
+            </a:r>
+          </a:p>
+        </p:txBody>
+      </p:sp>
+      <p:sp>
+        <p:nvSpPr>
+          <p:cNvPr id="22" name="Rounded Rectangle 21"/>
+          <p:cNvSpPr/>
+          <p:nvPr/>
+        </p:nvSpPr>
+        <p:spPr>
+          <a:xfrm>
+            <a:off x="7232707" y="1272540"/>
+            <a:ext cx="4364628" cy="505097"/>
+          </a:xfrm>
+          <a:prstGeom prst="roundRect">
+            <a:avLst>
+              <a:gd name="adj" fmla="val 15000"/>
+            </a:avLst>
+          </a:prstGeom>
+          <a:solidFill>
+            <a:srgbClr val="475569"/>
+          </a:solidFill>
+          <a:ln>
+            <a:noFill/>
+          </a:ln>
+          <a:effectLst/>
+        </p:spPr>
+        <p:style>
+          <a:lnRef idx="1">
+            <a:schemeClr val="accent1"/>
+          </a:lnRef>
+          <a:fillRef idx="3">
+            <a:schemeClr val="accent1"/>
+          </a:fillRef>
+          <a:effectRef idx="2">
+            <a:schemeClr val="accent1"/>
+          </a:effectRef>
+          <a:fontRef idx="minor">
+            <a:schemeClr val="lt1"/>
+          </a:fontRef>
+        </p:style>
+        <p:txBody>
+          <a:bodyPr rtlCol="0" anchor="ctr" wrap="none" lIns="73152"/>
+          <a:lstStyle/>
+          <a:p>
+            <a:pPr algn="l"/>
+            <a:r>
+              <a:rPr sz="1300" b="1" i="0">
+                <a:solidFill>
+                  <a:srgbClr val="FFFFFF"/>
+                </a:solidFill>
+                <a:latin typeface="Calibri"/>
+              </a:rPr>
+              <a:t>1972</a:t>
+            </a:r>
+          </a:p>
+        </p:txBody>
+      </p:sp>
+      <p:sp>
+        <p:nvSpPr>
+          <p:cNvPr id="23" name="TextBox 22"/>
+          <p:cNvSpPr txBox="1"/>
+          <p:nvPr/>
+        </p:nvSpPr>
+        <p:spPr>
+          <a:xfrm>
+            <a:off x="4922215" y="1853837"/>
+            <a:ext cx="2011680" cy="505097"/>
+          </a:xfrm>
+          <a:prstGeom prst="rect">
+            <a:avLst/>
+          </a:prstGeom>
+          <a:noFill/>
+        </p:spPr>
+        <p:txBody>
+          <a:bodyPr wrap="square" anchor="ctr" lIns="0" rIns="0" tIns="0" bIns="0">
+            <a:spAutoFit/>
+          </a:bodyPr>
+          <a:lstStyle/>
+          <a:p>
+            <a:pPr algn="r"/>
+            <a:r>
+              <a:rPr sz="1400" b="0" i="0">
+                <a:solidFill>
+                  <a:srgbClr val="1F2937"/>
+                </a:solidFill>
+                <a:latin typeface="Calibri"/>
+              </a:rPr>
+              <a:t>Consola · Atari 2600</a:t>
+            </a:r>
+          </a:p>
+        </p:txBody>
+      </p:sp>
+      <p:sp>
+        <p:nvSpPr>
+          <p:cNvPr id="24" name="Rounded Rectangle 23"/>
+          <p:cNvSpPr/>
+          <p:nvPr/>
+        </p:nvSpPr>
+        <p:spPr>
+          <a:xfrm>
+            <a:off x="7636840" y="1853837"/>
+            <a:ext cx="3960495" cy="505097"/>
+          </a:xfrm>
+          <a:prstGeom prst="roundRect">
+            <a:avLst>
+              <a:gd name="adj" fmla="val 15000"/>
+            </a:avLst>
+          </a:prstGeom>
+          <a:solidFill>
+            <a:srgbClr val="475569"/>
+          </a:solidFill>
+          <a:ln>
+            <a:noFill/>
+          </a:ln>
+          <a:effectLst/>
+        </p:spPr>
+        <p:style>
+          <a:lnRef idx="1">
+            <a:schemeClr val="accent1"/>
+          </a:lnRef>
+          <a:fillRef idx="3">
+            <a:schemeClr val="accent1"/>
+          </a:fillRef>
+          <a:effectRef idx="2">
+            <a:schemeClr val="accent1"/>
+          </a:effectRef>
+          <a:fontRef idx="minor">
+            <a:schemeClr val="lt1"/>
+          </a:fontRef>
+        </p:style>
+        <p:txBody>
+          <a:bodyPr rtlCol="0" anchor="ctr" wrap="none" lIns="73152"/>
+          <a:lstStyle/>
+          <a:p>
+            <a:pPr algn="l"/>
+            <a:r>
+              <a:rPr sz="1300" b="1" i="0">
+                <a:solidFill>
+                  <a:srgbClr val="FFFFFF"/>
+                </a:solidFill>
+                <a:latin typeface="Calibri"/>
+              </a:rPr>
+              <a:t>1977</a:t>
+            </a:r>
+          </a:p>
+        </p:txBody>
+      </p:sp>
+      <p:sp>
+        <p:nvSpPr>
+          <p:cNvPr id="25" name="TextBox 24"/>
+          <p:cNvSpPr txBox="1"/>
+          <p:nvPr/>
+        </p:nvSpPr>
+        <p:spPr>
+          <a:xfrm>
+            <a:off x="4922215" y="2435134"/>
+            <a:ext cx="2011680" cy="505097"/>
+          </a:xfrm>
+          <a:prstGeom prst="rect">
+            <a:avLst/>
+          </a:prstGeom>
+          <a:noFill/>
+        </p:spPr>
+        <p:txBody>
+          <a:bodyPr wrap="square" anchor="ctr" lIns="0" rIns="0" tIns="0" bIns="0">
+            <a:spAutoFit/>
+          </a:bodyPr>
+          <a:lstStyle/>
+          <a:p>
+            <a:pPr algn="r"/>
+            <a:r>
+              <a:rPr sz="1400" b="0" i="0">
+                <a:solidFill>
+                  <a:srgbClr val="1F2937"/>
+                </a:solidFill>
+                <a:latin typeface="Calibri"/>
+              </a:rPr>
+              <a:t>PC · IBM PC</a:t>
+            </a:r>
+          </a:p>
+        </p:txBody>
+      </p:sp>
+      <p:sp>
+        <p:nvSpPr>
+          <p:cNvPr id="26" name="Rounded Rectangle 25"/>
+          <p:cNvSpPr/>
+          <p:nvPr/>
+        </p:nvSpPr>
+        <p:spPr>
+          <a:xfrm>
+            <a:off x="7960145" y="2435134"/>
+            <a:ext cx="3637190" cy="505097"/>
+          </a:xfrm>
+          <a:prstGeom prst="roundRect">
+            <a:avLst>
+              <a:gd name="adj" fmla="val 15000"/>
+            </a:avLst>
+          </a:prstGeom>
+          <a:solidFill>
+            <a:srgbClr val="475569"/>
+          </a:solidFill>
+          <a:ln>
+            <a:noFill/>
+          </a:ln>
+          <a:effectLst/>
+        </p:spPr>
+        <p:style>
+          <a:lnRef idx="1">
+            <a:schemeClr val="accent1"/>
+          </a:lnRef>
+          <a:fillRef idx="3">
+            <a:schemeClr val="accent1"/>
+          </a:fillRef>
+          <a:effectRef idx="2">
+            <a:schemeClr val="accent1"/>
+          </a:effectRef>
+          <a:fontRef idx="minor">
+            <a:schemeClr val="lt1"/>
+          </a:fontRef>
+        </p:style>
+        <p:txBody>
+          <a:bodyPr rtlCol="0" anchor="ctr" wrap="none" lIns="73152"/>
+          <a:lstStyle/>
+          <a:p>
+            <a:pPr algn="l"/>
+            <a:r>
+              <a:rPr sz="1300" b="1" i="0">
+                <a:solidFill>
+                  <a:srgbClr val="FFFFFF"/>
+                </a:solidFill>
+                <a:latin typeface="Calibri"/>
+              </a:rPr>
+              <a:t>1981</a:t>
+            </a:r>
+          </a:p>
+        </p:txBody>
+      </p:sp>
+      <p:sp>
+        <p:nvSpPr>
+          <p:cNvPr id="27" name="TextBox 26"/>
+          <p:cNvSpPr txBox="1"/>
+          <p:nvPr/>
+        </p:nvSpPr>
+        <p:spPr>
+          <a:xfrm>
+            <a:off x="4922215" y="3016431"/>
+            <a:ext cx="2011680" cy="505097"/>
+          </a:xfrm>
+          <a:prstGeom prst="rect">
+            <a:avLst/>
+          </a:prstGeom>
+          <a:noFill/>
+        </p:spPr>
+        <p:txBody>
+          <a:bodyPr wrap="square" anchor="ctr" lIns="0" rIns="0" tIns="0" bIns="0">
+            <a:spAutoFit/>
+          </a:bodyPr>
+          <a:lstStyle/>
+          <a:p>
+            <a:pPr algn="r"/>
+            <a:r>
+              <a:rPr sz="1400" b="0" i="0">
+                <a:solidFill>
+                  <a:srgbClr val="1F2937"/>
+                </a:solidFill>
+                <a:latin typeface="Calibri"/>
+              </a:rPr>
+              <a:t>Portátil · Game Boy</a:t>
+            </a:r>
+          </a:p>
+        </p:txBody>
+      </p:sp>
+      <p:sp>
+        <p:nvSpPr>
+          <p:cNvPr id="28" name="Rounded Rectangle 27"/>
+          <p:cNvSpPr/>
+          <p:nvPr/>
+        </p:nvSpPr>
+        <p:spPr>
+          <a:xfrm>
+            <a:off x="8606757" y="3016431"/>
+            <a:ext cx="2990578" cy="505097"/>
+          </a:xfrm>
+          <a:prstGeom prst="roundRect">
+            <a:avLst>
+              <a:gd name="adj" fmla="val 15000"/>
+            </a:avLst>
+          </a:prstGeom>
+          <a:solidFill>
+            <a:srgbClr val="475569"/>
+          </a:solidFill>
+          <a:ln>
+            <a:noFill/>
+          </a:ln>
+          <a:effectLst/>
+        </p:spPr>
+        <p:style>
+          <a:lnRef idx="1">
+            <a:schemeClr val="accent1"/>
+          </a:lnRef>
+          <a:fillRef idx="3">
+            <a:schemeClr val="accent1"/>
+          </a:fillRef>
+          <a:effectRef idx="2">
+            <a:schemeClr val="accent1"/>
+          </a:effectRef>
+          <a:fontRef idx="minor">
+            <a:schemeClr val="lt1"/>
+          </a:fontRef>
+        </p:style>
+        <p:txBody>
+          <a:bodyPr rtlCol="0" anchor="ctr" wrap="none" lIns="73152"/>
+          <a:lstStyle/>
+          <a:p>
+            <a:pPr algn="l"/>
+            <a:r>
+              <a:rPr sz="1300" b="1" i="0">
+                <a:solidFill>
+                  <a:srgbClr val="FFFFFF"/>
+                </a:solidFill>
+                <a:latin typeface="Calibri"/>
+              </a:rPr>
+              <a:t>1989</a:t>
+            </a:r>
+          </a:p>
+        </p:txBody>
+      </p:sp>
+      <p:sp>
+        <p:nvSpPr>
+          <p:cNvPr id="29" name="TextBox 28"/>
+          <p:cNvSpPr txBox="1"/>
+          <p:nvPr/>
+        </p:nvSpPr>
+        <p:spPr>
+          <a:xfrm>
+            <a:off x="4922215" y="3597728"/>
+            <a:ext cx="2011680" cy="505097"/>
+          </a:xfrm>
+          <a:prstGeom prst="rect">
+            <a:avLst/>
+          </a:prstGeom>
+          <a:noFill/>
+        </p:spPr>
+        <p:txBody>
+          <a:bodyPr wrap="square" anchor="ctr" lIns="0" rIns="0" tIns="0" bIns="0">
+            <a:spAutoFit/>
+          </a:bodyPr>
+          <a:lstStyle/>
+          <a:p>
+            <a:pPr algn="r"/>
+            <a:r>
+              <a:rPr sz="1400" b="1" i="0">
+                <a:solidFill>
+                  <a:srgbClr val="1F2937"/>
+                </a:solidFill>
+                <a:latin typeface="Calibri"/>
+              </a:rPr>
+              <a:t>Teléfono · App Store</a:t>
+            </a:r>
+          </a:p>
+        </p:txBody>
+      </p:sp>
+      <p:sp>
+        <p:nvSpPr>
+          <p:cNvPr id="30" name="Rounded Rectangle 29"/>
+          <p:cNvSpPr/>
+          <p:nvPr/>
+        </p:nvSpPr>
+        <p:spPr>
+          <a:xfrm>
+            <a:off x="10142459" y="3597728"/>
+            <a:ext cx="1454876" cy="505097"/>
+          </a:xfrm>
+          <a:prstGeom prst="roundRect">
+            <a:avLst>
+              <a:gd name="adj" fmla="val 15000"/>
+            </a:avLst>
+          </a:prstGeom>
+          <a:solidFill>
+            <a:srgbClr val="0D9488"/>
+          </a:solidFill>
+          <a:ln>
+            <a:noFill/>
+          </a:ln>
+          <a:effectLst/>
+        </p:spPr>
+        <p:style>
+          <a:lnRef idx="1">
+            <a:schemeClr val="accent1"/>
+          </a:lnRef>
+          <a:fillRef idx="3">
+            <a:schemeClr val="accent1"/>
+          </a:fillRef>
+          <a:effectRef idx="2">
+            <a:schemeClr val="accent1"/>
+          </a:effectRef>
+          <a:fontRef idx="minor">
+            <a:schemeClr val="lt1"/>
+          </a:fontRef>
+        </p:style>
+        <p:txBody>
+          <a:bodyPr rtlCol="0" anchor="ctr" wrap="none" lIns="73152"/>
+          <a:lstStyle/>
+          <a:p>
+            <a:pPr algn="l"/>
+            <a:r>
+              <a:rPr sz="1300" b="1" i="0">
+                <a:solidFill>
+                  <a:srgbClr val="FFFFFF"/>
+                </a:solidFill>
+                <a:latin typeface="Calibri"/>
+              </a:rPr>
+              <a:t>2008</a:t>
+            </a:r>
+          </a:p>
+        </p:txBody>
+      </p:sp>
+      <p:sp>
+        <p:nvSpPr>
+          <p:cNvPr id="31" name="TextBox 30"/>
+          <p:cNvSpPr txBox="1"/>
+          <p:nvPr/>
+        </p:nvSpPr>
+        <p:spPr>
+          <a:xfrm>
+            <a:off x="4922215" y="4179025"/>
+            <a:ext cx="2011680" cy="505097"/>
+          </a:xfrm>
+          <a:prstGeom prst="rect">
+            <a:avLst/>
+          </a:prstGeom>
+          <a:noFill/>
+        </p:spPr>
+        <p:txBody>
+          <a:bodyPr wrap="square" anchor="ctr" lIns="0" rIns="0" tIns="0" bIns="0">
+            <a:spAutoFit/>
+          </a:bodyPr>
+          <a:lstStyle/>
+          <a:p>
+            <a:pPr algn="r"/>
+            <a:r>
+              <a:rPr sz="1400" b="0" i="0">
+                <a:solidFill>
+                  <a:srgbClr val="1F2937"/>
+                </a:solidFill>
+                <a:latin typeface="Calibri"/>
+              </a:rPr>
+              <a:t>XR · Oculus Rift</a:t>
+            </a:r>
+          </a:p>
+        </p:txBody>
+      </p:sp>
+      <p:sp>
+        <p:nvSpPr>
+          <p:cNvPr id="32" name="Rounded Rectangle 31"/>
+          <p:cNvSpPr/>
+          <p:nvPr/>
+        </p:nvSpPr>
+        <p:spPr>
+          <a:xfrm>
+            <a:off x="10789070" y="4179025"/>
+            <a:ext cx="808265" cy="505097"/>
+          </a:xfrm>
+          <a:prstGeom prst="roundRect">
+            <a:avLst>
+              <a:gd name="adj" fmla="val 15000"/>
+            </a:avLst>
+          </a:prstGeom>
+          <a:solidFill>
+            <a:srgbClr val="475569"/>
+          </a:solidFill>
+          <a:ln>
+            <a:noFill/>
+          </a:ln>
+          <a:effectLst/>
+        </p:spPr>
+        <p:style>
+          <a:lnRef idx="1">
+            <a:schemeClr val="accent1"/>
+          </a:lnRef>
+          <a:fillRef idx="3">
+            <a:schemeClr val="accent1"/>
+          </a:fillRef>
+          <a:effectRef idx="2">
+            <a:schemeClr val="accent1"/>
+          </a:effectRef>
+          <a:fontRef idx="minor">
+            <a:schemeClr val="lt1"/>
+          </a:fontRef>
+        </p:style>
+        <p:txBody>
+          <a:bodyPr rtlCol="0" anchor="ctr" wrap="none" lIns="73152"/>
+          <a:lstStyle/>
+          <a:p>
+            <a:pPr algn="l"/>
+            <a:r>
+              <a:rPr sz="1300" b="1" i="0">
+                <a:solidFill>
+                  <a:srgbClr val="FFFFFF"/>
+                </a:solidFill>
+                <a:latin typeface="Calibri"/>
+              </a:rPr>
+              <a:t>2016</a:t>
+            </a:r>
+          </a:p>
+        </p:txBody>
+      </p:sp>
+      <p:sp>
+        <p:nvSpPr>
+          <p:cNvPr id="33" name="TextBox 32"/>
+          <p:cNvSpPr txBox="1"/>
+          <p:nvPr/>
+        </p:nvSpPr>
+        <p:spPr>
+          <a:xfrm>
+            <a:off x="4922215" y="4760322"/>
+            <a:ext cx="2011680" cy="505097"/>
+          </a:xfrm>
+          <a:prstGeom prst="rect">
+            <a:avLst/>
+          </a:prstGeom>
+          <a:noFill/>
+        </p:spPr>
+        <p:txBody>
+          <a:bodyPr wrap="square" anchor="ctr" lIns="0" rIns="0" tIns="0" bIns="0">
+            <a:spAutoFit/>
+          </a:bodyPr>
+          <a:lstStyle/>
+          <a:p>
+            <a:pPr algn="r"/>
+            <a:r>
+              <a:rPr sz="1400" b="0" i="0">
+                <a:solidFill>
+                  <a:srgbClr val="1F2937"/>
+                </a:solidFill>
+                <a:latin typeface="Calibri"/>
+              </a:rPr>
+              <a:t>Nube · GeForce Now</a:t>
+            </a:r>
+          </a:p>
+        </p:txBody>
+      </p:sp>
+      <p:sp>
+        <p:nvSpPr>
+          <p:cNvPr id="34" name="Rounded Rectangle 33"/>
+          <p:cNvSpPr/>
+          <p:nvPr/>
+        </p:nvSpPr>
+        <p:spPr>
+          <a:xfrm>
+            <a:off x="11112376" y="4760322"/>
+            <a:ext cx="484959" cy="505097"/>
+          </a:xfrm>
+          <a:prstGeom prst="roundRect">
+            <a:avLst>
+              <a:gd name="adj" fmla="val 15000"/>
+            </a:avLst>
+          </a:prstGeom>
+          <a:solidFill>
+            <a:srgbClr val="475569"/>
+          </a:solidFill>
+          <a:ln>
+            <a:noFill/>
+          </a:ln>
+          <a:effectLst/>
+        </p:spPr>
+        <p:style>
+          <a:lnRef idx="1">
+            <a:schemeClr val="accent1"/>
+          </a:lnRef>
+          <a:fillRef idx="3">
+            <a:schemeClr val="accent1"/>
+          </a:fillRef>
+          <a:effectRef idx="2">
+            <a:schemeClr val="accent1"/>
+          </a:effectRef>
+          <a:fontRef idx="minor">
+            <a:schemeClr val="lt1"/>
+          </a:fontRef>
+        </p:style>
+        <p:txBody>
+          <a:bodyPr rtlCol="0" anchor="ctr"/>
+          <a:lstStyle/>
+          <a:p>
+            <a:pPr algn="ctr"/>
+          </a:p>
+        </p:txBody>
+      </p:sp>
+      <p:sp>
+        <p:nvSpPr>
+          <p:cNvPr id="35" name="TextBox 34"/>
+          <p:cNvSpPr txBox="1"/>
+          <p:nvPr/>
+        </p:nvSpPr>
+        <p:spPr>
+          <a:xfrm>
+            <a:off x="10426576" y="4760322"/>
+            <a:ext cx="621792" cy="505097"/>
+          </a:xfrm>
+          <a:prstGeom prst="rect">
+            <a:avLst/>
+          </a:prstGeom>
+          <a:noFill/>
+        </p:spPr>
+        <p:txBody>
+          <a:bodyPr wrap="square" anchor="ctr" lIns="0" rIns="0" tIns="0" bIns="0">
+            <a:spAutoFit/>
+          </a:bodyPr>
+          <a:lstStyle/>
+          <a:p>
+            <a:pPr algn="r"/>
+            <a:r>
+              <a:rPr sz="1300" b="1" i="0">
+                <a:solidFill>
+                  <a:srgbClr val="1F2937"/>
+                </a:solidFill>
+                <a:latin typeface="Calibri"/>
+              </a:rPr>
+              <a:t>2020</a:t>
+            </a:r>
+          </a:p>
+        </p:txBody>
+      </p:sp>
+      <p:sp>
+        <p:nvSpPr>
+          <p:cNvPr id="36" name="TextBox 35"/>
+          <p:cNvSpPr txBox="1"/>
+          <p:nvPr/>
+        </p:nvSpPr>
+        <p:spPr>
+          <a:xfrm>
+            <a:off x="4922215" y="5669280"/>
+            <a:ext cx="6766560" cy="320040"/>
+          </a:xfrm>
+          <a:prstGeom prst="rect">
+            <a:avLst/>
+          </a:prstGeom>
+          <a:noFill/>
+        </p:spPr>
+        <p:txBody>
+          <a:bodyPr wrap="square" anchor="ctr" lIns="0" rIns="0" tIns="0" bIns="0">
+            <a:spAutoFit/>
+          </a:bodyPr>
+          <a:lstStyle/>
+          <a:p>
+            <a:pPr algn="r"/>
+            <a:r>
+              <a:rPr sz="1100" b="0" i="1">
+                <a:solidFill>
+                  <a:srgbClr val="6B7280"/>
+                </a:solidFill>
+                <a:latin typeface="Calibri"/>
+              </a:rPr>
+              <a:t>Cada barra: desde el hito que abre la época hasta 2026</a:t>
+            </a:r>
+          </a:p>
+        </p:txBody>
+      </p:sp>
+      <p:sp>
+        <p:nvSpPr>
+          <p:cNvPr id="37" name="TextBox 36"/>
+          <p:cNvSpPr txBox="1"/>
+          <p:nvPr/>
+        </p:nvSpPr>
+        <p:spPr>
+          <a:xfrm>
             <a:off x="502920" y="1234440"/>
-            <a:ext cx="6979615" cy="4754880"/>
+            <a:ext cx="4144975" cy="4754880"/>
           </a:xfrm>
           <a:prstGeom prst="rect">
             <a:avLst/>

</xml_diff>

<commit_message>
docs(unidad-04): class 1 v2 glossary notes, diagrams instead of empty images
Requested by the course lead:
- remove every reference to classes not yet taught (Clase 2/3/4)
- add a short glossary at the top of the speaker notes of 20 slides
  without changing projected text
- drop the 9 empty image placeholders; keep suggestions in the notes and
  add native diagrams where they need no invented data: phone vs PC,
  tiles/overdraw, two causal flows, real Ship.cs 61-73 code read from the
  repo, and to-scale 16:9 vs 9:16 screens with the spawn range
The generator gains flujo, comparacion, tiles, codigo and vista keys.

Co-Authored-By: Claude Opus 5.5 <noreply@anthropic.com>
</commit_message>
<xml_diff>
--- a/diseno-plataformas/unidad-04/Unidad-4-Clase-1-2026-v2.pptx
+++ b/diseno-plataformas/unidad-04/Unidad-4-Clase-1-2026-v2.pptx
@@ -522,6 +522,11 @@
           <a:lstStyle/>
           <a:p>
             <a:r>
+              <a:t>Imagen sugerida (opcional, sin recuadro en la slide): Teléfono en vertical con Asteroides corriendo, sostenido con una mano.</a:t>
+            </a:r>
+          </a:p>
+          <a:p>
+            <a:r>
               <a:t>Presentar la unidad como continuación directa del panorama del 28/09: ese día recorrimos todas las plataformas; desde hoy, y durante cuatro clases, nos quedamos en el bolsillo del jugador.</a:t>
             </a:r>
           </a:p>
@@ -602,6 +607,41 @@
           <a:lstStyle/>
           <a:p>
             <a:r>
+              <a:t>Glosario (conceptos cortos para la docente):</a:t>
+            </a:r>
+          </a:p>
+          <a:p>
+            <a:r>
+              <a:t>• Tile: porción rectangular de la pantalla; la GPU móvil dibuja la imagen tile por tile.</a:t>
+            </a:r>
+          </a:p>
+          <a:p>
+            <a:r>
+              <a:t>• TBDR (Tile-Based Deferred Rendering): técnica de dibujo por tiles que usan las GPU móviles.</a:t>
+            </a:r>
+          </a:p>
+          <a:p>
+            <a:r>
+              <a:t>• Ancho de banda de memoria: cantidad de datos que se pueden leer o escribir en memoria por segundo.</a:t>
+            </a:r>
+          </a:p>
+          <a:p>
+            <a:r>
+              <a:t>• Overdraw: pintar el mismo píxel más de una vez en un mismo cuadro.</a:t>
+            </a:r>
+          </a:p>
+          <a:p>
+            <a:r>
+              <a:t>• Píxel: cada punto de la imagen en pantalla.</a:t>
+            </a:r>
+          </a:p>
+          <a:p>
+            <a:r>
+              <a:t>• Partículas: muchos elementos gráficos pequeños (chispas, humo) que forman un efecto.</a:t>
+            </a:r>
+          </a:p>
+          <a:p>
+            <a:r>
               <a:t>Las GPU móviles dibujan la pantalla por porciones (tiles): técnica TBDR, tile-based deferred rendering. Leer y escribir memoria consume ancho de banda, y el ancho de banda consume batería.</a:t>
             </a:r>
           </a:p>
@@ -617,7 +657,7 @@
           </a:p>
           <a:p>
             <a:r>
-              <a:t>Llegar solo hasta acá: no explicar el pipeline de la GPU. Conectar con Asteroides: la explosión de la nave usa partículas con transparencia, candidata a medir en la Clase 4.</a:t>
+              <a:t>Llegar solo hasta acá: no explicar el pipeline de la GPU. Conectar con Asteroides: la explosión de la nave usa partículas con transparencia, candidata a medir en el teléfono, más adelante en la unidad.</a:t>
             </a:r>
           </a:p>
         </p:txBody>
@@ -687,6 +727,36 @@
           <a:lstStyle/>
           <a:p>
             <a:r>
+              <a:t>Glosario (conceptos cortos para la docente):</a:t>
+            </a:r>
+          </a:p>
+          <a:p>
+            <a:r>
+              <a:t>• fps (frames per second): cantidad de imágenes que el juego dibuja por segundo.</a:t>
+            </a:r>
+          </a:p>
+          <a:p>
+            <a:r>
+              <a:t>• Throttling térmico: reducción automática de la frecuencia del procesador para que no se sobrecaliente.</a:t>
+            </a:r>
+          </a:p>
+          <a:p>
+            <a:r>
+              <a:t>• Tiempo de frame (frame time): tiempo que tarda en prepararse un cuadro; a 30 fps son 33,3 ms y a 60 fps, 16,7 ms.</a:t>
+            </a:r>
+          </a:p>
+          <a:p>
+            <a:r>
+              <a:t>• ms: milisegundo, la milésima parte de un segundo.</a:t>
+            </a:r>
+          </a:p>
+          <a:p>
+            <a:r>
+              <a:t>• Refrigeración activa: ventiladores u otros sistemas que extraen el calor; los teléfonos no la tienen.</a:t>
+            </a:r>
+          </a:p>
+          <a:p>
+            <a:r>
               <a:t>Es el concepto más importante de la clase.</a:t>
             </a:r>
           </a:p>
@@ -777,6 +847,26 @@
           <a:lstStyle/>
           <a:p>
             <a:r>
+              <a:t>Glosario (conceptos cortos para la docente):</a:t>
+            </a:r>
+          </a:p>
+          <a:p>
+            <a:r>
+              <a:t>• targetFrameRate: opción de Unity que fija los fps objetivo del juego.</a:t>
+            </a:r>
+          </a:p>
+          <a:p>
+            <a:r>
+              <a:t>• Frecuencia de refresco: veces por segundo que se actualiza la pantalla; se mide en Hz.</a:t>
+            </a:r>
+          </a:p>
+          <a:p>
+            <a:r>
+              <a:t>• Frame pacing: entregar los cuadros a intervalos regulares, sincronizados con la pantalla.</a:t>
+            </a:r>
+          </a:p>
+          <a:p>
+            <a:r>
               <a:t>En Android e iOS, por defecto Unity renderiza a 30 fps fijos "to conserve battery power" (texto de la documentación de Application.targetFrameRate: abrir la página y leer la frase).</a:t>
             </a:r>
           </a:p>
@@ -867,6 +957,36 @@
           <a:lstStyle/>
           <a:p>
             <a:r>
+              <a:t>Glosario (conceptos cortos para la docente):</a:t>
+            </a:r>
+          </a:p>
+          <a:p>
+            <a:r>
+              <a:t>• Segundo plano: estado de una app que sigue abierta pero no se ve ni recibe input.</a:t>
+            </a:r>
+          </a:p>
+          <a:p>
+            <a:r>
+              <a:t>• Proceso: programa en ejecución.</a:t>
+            </a:r>
+          </a:p>
+          <a:p>
+            <a:r>
+              <a:t>• Low Memory Killer: componente de Android que cierra procesos cuando falta memoria.</a:t>
+            </a:r>
+          </a:p>
+          <a:p>
+            <a:r>
+              <a:t>• onTrimMemory: aviso de Android a una app para que libere memoria.</a:t>
+            </a:r>
+          </a:p>
+          <a:p>
+            <a:r>
+              <a:t>• Estado: datos de la partida (posición, puntaje, vidas) que hay que guardar para poder retomarla.</a:t>
+            </a:r>
+          </a:p>
+          <a:p>
+            <a:r>
               <a:t>Cuando el jugador sale de la app (llamada, notificación, cambio de app), el juego pasa a segundo plano. Si falta memoria, el sistema operativo cierra procesos en segundo plano: en Android lo hace el Low Memory Killer; en iOS, el sistema termina la app si no libera memoria.</a:t>
             </a:r>
           </a:p>
@@ -947,6 +1067,31 @@
           <a:lstStyle/>
           <a:p>
             <a:r>
+              <a:t>Glosario (conceptos cortos para la docente):</a:t>
+            </a:r>
+          </a:p>
+          <a:p>
+            <a:r>
+              <a:t>• Callback: función que el motor o el sistema llama automáticamente cuando ocurre un evento.</a:t>
+            </a:r>
+          </a:p>
+          <a:p>
+            <a:r>
+              <a:t>• OnApplicationPause / OnApplicationFocus: callbacks de Unity para cuando la app pasa a segundo plano o pierde el foco.</a:t>
+            </a:r>
+          </a:p>
+          <a:p>
+            <a:r>
+              <a:t>• Foco: la app está al frente y recibe el input del jugador.</a:t>
+            </a:r>
+          </a:p>
+          <a:p>
+            <a:r>
+              <a:t>• MonoBehaviour: clase base de los scripts de Unity.</a:t>
+            </a:r>
+          </a:p>
+          <a:p>
+            <a:r>
               <a:t>OnApplicationPause(bool) avisa que la app pasa a segundo plano o vuelve. OnApplicationFocus(bool) avisa que la app pierde o recupera el foco. Dato práctico: en Android, abrir el teclado en pantalla dispara OnApplicationFocus(false).</a:t>
             </a:r>
           </a:p>
@@ -957,7 +1102,7 @@
           </a:p>
           <a:p>
             <a:r>
-              <a:t>No escribir código todavía: eso se hace en la Clase 3 con el defecto deliberado. Solo mostrar que el motor avisa y que el juego base no escucha.</a:t>
+              <a:t>No escribir código todavía: eso se hace más adelante en la unidad, con el defecto deliberado. Solo mostrar que el motor avisa y que el juego base no escucha.</a:t>
             </a:r>
           </a:p>
           <a:p>
@@ -1032,6 +1177,26 @@
           <a:lstStyle/>
           <a:p>
             <a:r>
+              <a:t>Glosario (conceptos cortos para la docente):</a:t>
+            </a:r>
+          </a:p>
+          <a:p>
+            <a:r>
+              <a:t>• Emulador: programa que imita un teléfono dentro de la PC.</a:t>
+            </a:r>
+          </a:p>
+          <a:p>
+            <a:r>
+              <a:t>• Restricción de plataforma: límite que impone el dispositivo o su sistema operativo.</a:t>
+            </a:r>
+          </a:p>
+          <a:p>
+            <a:r>
+              <a:t>• Evidencia: dato que permite confirmar un problema (modelo del teléfono, capturas, video, registros).</a:t>
+            </a:r>
+          </a:p>
+          <a:p>
+            <a:r>
               <a:t>Consigna completa: para cada reporte, indicar (a) la restricción de plataforma más probable, (b) qué evidencia le pedirían al tester, y (c) qué tipo de prueba lo habría detectado antes.</a:t>
             </a:r>
           </a:p>
@@ -1142,6 +1307,41 @@
           <a:lstStyle/>
           <a:p>
             <a:r>
+              <a:t>Glosario (conceptos cortos para la docente):</a:t>
+            </a:r>
+          </a:p>
+          <a:p>
+            <a:r>
+              <a:t>• Player Settings: configuración del proyecto de Unity para cada plataforma de destino.</a:t>
+            </a:r>
+          </a:p>
+          <a:p>
+            <a:r>
+              <a:t>• Device Simulator: ventana de Unity que muestra el juego con la forma de pantalla de un dispositivo real.</a:t>
+            </a:r>
+          </a:p>
+          <a:p>
+            <a:r>
+              <a:t>• Nivel de API de Android: número que identifica cada versión de Android (por ejemplo, API 36 = Android 16).</a:t>
+            </a:r>
+          </a:p>
+          <a:p>
+            <a:r>
+              <a:t>• Application Category: categoría con la que Unity declara la app ante Android; para juegos, "Game".</a:t>
+            </a:r>
+          </a:p>
+          <a:p>
+            <a:r>
+              <a:t>• Giroscopio: sensor que mide la rotación del teléfono.</a:t>
+            </a:r>
+          </a:p>
+          <a:p>
+            <a:r>
+              <a:t>Imagen sugerida (opcional, sin recuadro en la slide): Device Simulator con Asteroides en vertical y los asteroides apareciendo fuera de pantalla.</a:t>
+            </a:r>
+          </a:p>
+          <a:p>
+            <a:r>
               <a:t>Pasos de la demo:</a:t>
             </a:r>
           </a:p>
@@ -1237,6 +1437,31 @@
           <a:lstStyle/>
           <a:p>
             <a:r>
+              <a:t>Glosario (conceptos cortos para la docente):</a:t>
+            </a:r>
+          </a:p>
+          <a:p>
+            <a:r>
+              <a:t>• Spawn: aparición de un objeto en el juego; acá, los asteroides.</a:t>
+            </a:r>
+          </a:p>
+          <a:p>
+            <a:r>
+              <a:t>• Prefab: objeto de Unity guardado como plantilla reutilizable.</a:t>
+            </a:r>
+          </a:p>
+          <a:p>
+            <a:r>
+              <a:t>• Canvas: contenedor de la interfaz (UI) en Unity.</a:t>
+            </a:r>
+          </a:p>
+          <a:p>
+            <a:r>
+              <a:t>• Input.GetKey: lectura directa de una tecla en el sistema de input clásico de Unity.</a:t>
+            </a:r>
+          </a:p>
+          <a:p>
+            <a:r>
               <a:t>Consigna completa: listar al menos 5 supuestos que dejan de valer en un teléfono, indicando dónde están (archivo:línea), qué pasaría en móvil y a qué eje pertenecen (input, pantalla, UI, ciclo de vida, rendimiento).</a:t>
             </a:r>
           </a:p>
@@ -1317,6 +1542,26 @@
           <a:lstStyle/>
           <a:p>
             <a:r>
+              <a:t>Glosario (conceptos cortos para la docente):</a:t>
+            </a:r>
+          </a:p>
+          <a:p>
+            <a:r>
+              <a:t>• Cámara ortográfica: cámara sin perspectiva; su tamaño (orthographicSize) es la mitad de la altura visible, en unidades del mundo.</a:t>
+            </a:r>
+          </a:p>
+          <a:p>
+            <a:r>
+              <a:t>• Relación de aspecto (aspect ratio): ancho dividido por alto de la pantalla (16:9, 9:16).</a:t>
+            </a:r>
+          </a:p>
+          <a:p>
+            <a:r>
+              <a:t>• Coordenadas de mundo: posiciones dentro de la escena, independientes de la pantalla.</a:t>
+            </a:r>
+          </a:p>
+          <a:p>
+            <a:r>
               <a:t>La cámara es ortográfica de tamaño 5: el semiancho visible es 5 × aspect. A 16:9 se ven ≈ 8,9 unidades a cada lado; en vertical 9:16, ≈ 2,8.</a:t>
             </a:r>
           </a:p>
@@ -1407,6 +1652,21 @@
           </a:p>
           <a:p>
             <a:r>
+              <a:t>Glosario (conceptos cortos para la docente):</a:t>
+            </a:r>
+          </a:p>
+          <a:p>
+            <a:r>
+              <a:t>• Audiencia: público al que apunta el juego.</a:t>
+            </a:r>
+          </a:p>
+          <a:p>
+            <a:r>
+              <a:t>• Vigencia (future-proofing): que la plataforma siga activa y evolucionando con el tiempo.</a:t>
+            </a:r>
+          </a:p>
+          <a:p>
+            <a:r>
               <a:t>El artículo de Kevuru propone cuatro consideraciones para elegir plataforma, y concluye que el desafío no es encontrar la "mejor" plataforma, sino la que encaja con la visión del juego y su público:</a:t>
             </a:r>
           </a:p>
@@ -1437,7 +1697,7 @@
           </a:p>
           <a:p>
             <a:r>
-              <a:t>Respuesta esperada a la pregunta: Asteroides encaja en móvil por audiencia (partidas cortas y casuales) y por sus requisitos técnicos bajos, pero exige rediseñar el control, la pantalla y la pausa (lo que encontramos en A4.2). La monetización se decide en la Clase 3.</a:t>
+              <a:t>Respuesta esperada a la pregunta: Asteroides encaja en móvil por audiencia (partidas cortas y casuales) y por sus requisitos técnicos bajos, pero exige rediseñar el control, la pantalla y la pausa (lo que encontramos en A4.2). La monetización se decide más adelante en la unidad.</a:t>
             </a:r>
           </a:p>
         </p:txBody>
@@ -1507,6 +1767,21 @@
           <a:lstStyle/>
           <a:p>
             <a:r>
+              <a:t>Glosario (conceptos cortos para la docente):</a:t>
+            </a:r>
+          </a:p>
+          <a:p>
+            <a:r>
+              <a:t>• Bug: error o defecto que hace que el juego se comporte distinto de lo esperado.</a:t>
+            </a:r>
+          </a:p>
+          <a:p>
+            <a:r>
+              <a:t>Imagen sugerida (opcional, sin recuadro en la slide): Captura del juego con tres íconos superpuestos: termómetro, batería baja y llamada entrante.</a:t>
+            </a:r>
+          </a:p>
+          <a:p>
+            <a:r>
               <a:t>Relato completo: "Asteroides funciona perfecto en la PC del aula. Lo instalamos en un teléfono: a los 10 minutos empieza a trabarse, el teléfono quema en la mano, y si entra una llamada y volvemos, la nave ya explotó y perdimos la partida".</a:t>
             </a:r>
           </a:p>
@@ -1597,6 +1872,26 @@
           </a:p>
           <a:p>
             <a:r>
+              <a:t>Glosario (conceptos cortos para la docente):</a:t>
+            </a:r>
+          </a:p>
+          <a:p>
+            <a:r>
+              <a:t>• Fuente primaria: documento original de quien produce el dato (por ejemplo, el comunicado oficial de la empresa).</a:t>
+            </a:r>
+          </a:p>
+          <a:p>
+            <a:r>
+              <a:t>• Stadia: servicio de cloud gaming de Google (2019–2023).</a:t>
+            </a:r>
+          </a:p>
+          <a:p>
+            <a:r>
+              <a:t>• EA app: lanzador de juegos de PC de Electronic Arts, que reemplazó a Origin.</a:t>
+            </a:r>
+          </a:p>
+          <a:p>
+            <a:r>
               <a:t>El artículo que usamos para las slides 5, 6, 7, 8 y 19 es útil para los conceptos, pero tiene problemas que conviene mostrar:</a:t>
             </a:r>
           </a:p>
@@ -1697,7 +1992,27 @@
           <a:lstStyle/>
           <a:p>
             <a:r>
-              <a:t>Cerrar con el límite de la herramienta, no con la herramienta: el simulador encontró el problema de la pantalla, pero no mide calor ni batería. Eso lo vamos a medir en sus teléfonos, en la Clase 4.</a:t>
+              <a:t>Glosario (conceptos cortos para la docente):</a:t>
+            </a:r>
+          </a:p>
+          <a:p>
+            <a:r>
+              <a:t>• Build Support: módulo de Unity que permite compilar el juego para una plataforma; acá, Android.</a:t>
+            </a:r>
+          </a:p>
+          <a:p>
+            <a:r>
+              <a:t>• Depuración USB: opción de Android que permite a la PC instalar y analizar apps en el teléfono por cable.</a:t>
+            </a:r>
+          </a:p>
+          <a:p>
+            <a:r>
+              <a:t>• TP: trabajo práctico.</a:t>
+            </a:r>
+          </a:p>
+          <a:p>
+            <a:r>
+              <a:t>Cerrar con el límite de la herramienta, no con la herramienta: el simulador encontró el problema de la pantalla, pero no mide calor ni batería. Eso lo vamos a medir en sus teléfonos, más adelante en la unidad.</a:t>
             </a:r>
           </a:p>
           <a:p>
@@ -1707,7 +2022,7 @@
           </a:p>
           <a:p>
             <a:r>
-              <a:t>Tarea técnica obligatoria (sin ella la Clase 4 no se puede hacer):</a:t>
+              <a:t>Tarea técnica obligatoria (sin ella no se puede hacer la práctica en el teléfono):</a:t>
             </a:r>
           </a:p>
           <a:p>
@@ -1787,6 +2102,26 @@
           <a:lstStyle/>
           <a:p>
             <a:r>
+              <a:t>Glosario (conceptos cortos para la docente):</a:t>
+            </a:r>
+          </a:p>
+          <a:p>
+            <a:r>
+              <a:t>• Zona segura (safe area): parte de la pantalla libre de muescas, bordes curvos y barras del sistema, donde la interfaz se ve completa.</a:t>
+            </a:r>
+          </a:p>
+          <a:p>
+            <a:r>
+              <a:t>• Intención: lo que el jugador quiere hacer (mover, disparar), sin importar con qué control lo pide.</a:t>
+            </a:r>
+          </a:p>
+          <a:p>
+            <a:r>
+              <a:t>• Dispositivo de entrada: el medio físico con el que el jugador da órdenes (teclado, pantalla táctil, gamepad).</a:t>
+            </a:r>
+          </a:p>
+          <a:p>
+            <a:r>
               <a:t>Recuperar, no repetir. Las cinco ideas del 28/09, completas:</a:t>
             </a:r>
           </a:p>
@@ -1847,7 +2182,7 @@
           </a:p>
           <a:p>
             <a:r>
-              <a:t>En Unity, la capa de intención la ofrece el Input System: las Actions (Move, Fire) separan la acción de sus bindings (teclado, táctil, gamepad). Solo mencionarlo; se trabaja en la Clase 2 (On-Screen Controls).</a:t>
+              <a:t>En Unity, la capa de intención la ofrece el Input System: las Actions (Move, Fire) separan la acción de sus bindings (teclado, táctil, gamepad). Solo mencionarlo; se trabaja más adelante en la unidad, al diseñar los controles táctiles (On-Screen Controls).</a:t>
             </a:r>
           </a:p>
           <a:p>
@@ -1927,6 +2262,21 @@
           <a:lstStyle/>
           <a:p>
             <a:r>
+              <a:t>Glosario (conceptos cortos para la docente):</a:t>
+            </a:r>
+          </a:p>
+          <a:p>
+            <a:r>
+              <a:t>• Monetización: forma en que el juego genera ingresos (venta, anuncios, compras dentro del juego).</a:t>
+            </a:r>
+          </a:p>
+          <a:p>
+            <a:r>
+              <a:t>• Supuesto de PC: algo que el juego da por hecho porque fue pensado para PC (por ejemplo, que hay teclado).</a:t>
+            </a:r>
+          </a:p>
+          <a:p>
+            <a:r>
               <a:t>Versión completa de los objetivos:</a:t>
             </a:r>
           </a:p>
@@ -2032,6 +2382,26 @@
           </a:p>
           <a:p>
             <a:r>
+              <a:t>Glosario (conceptos cortos para la docente):</a:t>
+            </a:r>
+          </a:p>
+          <a:p>
+            <a:r>
+              <a:t>• Distribución: canal por el que el juego llega al jugador; en móvil, una tienda digital.</a:t>
+            </a:r>
+          </a:p>
+          <a:p>
+            <a:r>
+              <a:t>• Servicio en la nube (cloud gaming): el juego corre en un servidor remoto y el jugador recibe la imagen por internet.</a:t>
+            </a:r>
+          </a:p>
+          <a:p>
+            <a:r>
+              <a:t>• Streaming (Twitch, YouTube): transmisión de video en vivo; acá, gente mirando a otros jugar.</a:t>
+            </a:r>
+          </a:p>
+          <a:p>
+            <a:r>
               <a:t>El artículo de Kevuru Games define las plataformas como "la base de cómo los jugadores se conectan con los juegos", ya sea una consola física, un gabinete arcade o un servicio en la nube que corre todo en línea. Y usa una metáfora útil: la plataforma es el escenario donde el juego "actúa", y hay escenarios más grandes que otros.</a:t>
             </a:r>
           </a:p>
@@ -2047,7 +2417,7 @@
           </a:p>
           <a:p>
             <a:r>
-              <a:t>Respuesta esperada a la pregunta: la capa de ejecución condiciona más el diseño (input, pantalla, rendimiento); la de distribución condiciona el negocio y las reglas (Clase 3); la de comunidad influye en el diseño solo de forma indirecta (juegos pensados para ser vistos, como Among Us).</a:t>
+              <a:t>Respuesta esperada a la pregunta: la capa de ejecución condiciona más el diseño (input, pantalla, rendimiento); la de distribución condiciona el negocio y las reglas (lo vemos más adelante en la unidad); la de comunidad influye en el diseño solo de forma indirecta (juegos pensados para ser vistos, como Among Us).</a:t>
             </a:r>
           </a:p>
         </p:txBody>
@@ -2122,6 +2492,26 @@
           </a:p>
           <a:p>
             <a:r>
+              <a:t>Glosario (conceptos cortos para la docente):</a:t>
+            </a:r>
+          </a:p>
+          <a:p>
+            <a:r>
+              <a:t>• Arcade: máquina de juego de uso público que funciona con fichas o monedas.</a:t>
+            </a:r>
+          </a:p>
+          <a:p>
+            <a:r>
+              <a:t>• XR (realidad extendida): término que agrupa realidad virtual, aumentada y mixta.</a:t>
+            </a:r>
+          </a:p>
+          <a:p>
+            <a:r>
+              <a:t>• App Store: tienda oficial de aplicaciones de Apple; Google Play es la de Android.</a:t>
+            </a:r>
+          </a:p>
+          <a:p>
+            <a:r>
               <a:t>Idea del artículo: cada época tuvo una plataforma que definió cómo se juega. Los arcades fueron las primeras plataformas reales, y además eran espacios sociales.</a:t>
             </a:r>
           </a:p>
@@ -2232,6 +2622,21 @@
           </a:p>
           <a:p>
             <a:r>
+              <a:t>Glosario (conceptos cortos para la docente):</a:t>
+            </a:r>
+          </a:p>
+          <a:p>
+            <a:r>
+              <a:t>• Shooter: juego de disparos.</a:t>
+            </a:r>
+          </a:p>
+          <a:p>
+            <a:r>
+              <a:t>• ESRB (Entertainment Software Rating Board): organismo que clasifica los videojuegos por edad en EE. UU. y Canadá.</a:t>
+            </a:r>
+          </a:p>
+          <a:p>
+            <a:r>
               <a:t>Los ejemplos que da el artículo de Kevuru Games, con lo que aportó cada uno:</a:t>
             </a:r>
           </a:p>
@@ -2277,7 +2682,7 @@
           </a:p>
           <a:p>
             <a:r>
-              <a:t>Respuesta esperada a la pregunta: una máquina que cobra por ficha impone partidas cortas, dificultad creciente y un "Game Over" que invita a pagar de nuevo. Conexión con móvil: ese mismo patrón reaparece en el "continuar" con un anuncio o con una compra (lo analizamos en la Clase 3, monetización). Y Asteroids, el juego que inspira nuestro proyecto, también es un clásico arcade de esa época (Atari, 1979).</a:t>
+              <a:t>Respuesta esperada a la pregunta: una máquina que cobra por ficha impone partidas cortas, dificultad creciente y un "Game Over" que invita a pagar de nuevo. Conexión con móvil: ese mismo patrón reaparece en el "continuar" con un anuncio o con una compra (lo analizamos más adelante en la unidad, al ver monetización). Y Asteroids, el juego que inspira nuestro proyecto, también es un clásico arcade de esa época (Atari, 1979).</a:t>
             </a:r>
           </a:p>
           <a:p>
@@ -2357,6 +2762,16 @@
           </a:p>
           <a:p>
             <a:r>
+              <a:t>Glosario (conceptos cortos para la docente):</a:t>
+            </a:r>
+          </a:p>
+          <a:p>
+            <a:r>
+              <a:t>• Juego casual: juego de reglas simples y partidas cortas, pensado para un público amplio.</a:t>
+            </a:r>
+          </a:p>
+          <a:p>
+            <a:r>
               <a:t>Idea del artículo: con Google Play y el App Store, "los estudios pequeños e incluso desarrolladores solos" pudieron poner sus juegos frente a millones de personas. Los ejemplos que da:</a:t>
             </a:r>
           </a:p>
@@ -2382,12 +2797,12 @@
           </a:p>
           <a:p>
             <a:r>
-              <a:t>Matiz docente (importante): que la tienda esté abierta no significa que no tenga reglas. Para publicar hay que cumplir políticas de pago, de anuncios, de privacidad y de nivel de API (lo vemos en la Clase 3). Y que cualquiera pueda publicar crea otro problema: la visibilidad entre millones de juegos.</a:t>
-            </a:r>
-          </a:p>
-          <a:p>
-            <a:r>
-              <a:t>Respuesta esperada a la pregunta: la visibilidad depende de la propia tienda (búsqueda, destacados, calificaciones), de la comunidad (streamers, boca en boca) y de la calidad técnica (Android vitals puede bajar la visibilidad de un juego con muchos cierres inesperados; lo vemos en la Clase 3).</a:t>
+              <a:t>Matiz docente (importante): que la tienda esté abierta no significa que no tenga reglas. Para publicar hay que cumplir políticas de pago, de anuncios, de privacidad y de nivel de API (lo vemos más adelante en la unidad). Y que cualquiera pueda publicar crea otro problema: la visibilidad entre millones de juegos.</a:t>
+            </a:r>
+          </a:p>
+          <a:p>
+            <a:r>
+              <a:t>Respuesta esperada a la pregunta: la visibilidad depende de la propia tienda (búsqueda, destacados, calificaciones), de la comunidad (streamers, boca en boca) y de la calidad técnica (Android vitals puede bajar la visibilidad de un juego con muchos cierres inesperados; lo vemos más adelante en la unidad).</a:t>
             </a:r>
           </a:p>
         </p:txBody>
@@ -2455,6 +2870,36 @@
         <p:txBody>
           <a:bodyPr/>
           <a:lstStyle/>
+          <a:p>
+            <a:r>
+              <a:t>Glosario (conceptos cortos para la docente):</a:t>
+            </a:r>
+          </a:p>
+          <a:p>
+            <a:r>
+              <a:t>• SoC (System on a Chip): un solo chip que integra CPU, GPU, memoria y otros componentes.</a:t>
+            </a:r>
+          </a:p>
+          <a:p>
+            <a:r>
+              <a:t>• CPU (unidad central de procesamiento): ejecuta la lógica del juego (reglas, física, IA).</a:t>
+            </a:r>
+          </a:p>
+          <a:p>
+            <a:r>
+              <a:t>• GPU (unidad de procesamiento gráfico): dibuja la imagen que se ve en pantalla.</a:t>
+            </a:r>
+          </a:p>
+          <a:p>
+            <a:r>
+              <a:t>• Núcleo: cada unidad de procesamiento dentro de la CPU; los teléfonos combinan núcleos de distinta potencia.</a:t>
+            </a:r>
+          </a:p>
+          <a:p>
+            <a:r>
+              <a:t>• Reloj (frecuencia): velocidad a la que trabaja un procesador; se mide en GHz.</a:t>
+            </a:r>
+          </a:p>
           <a:p>
             <a:r>
               <a:t>En un teléfono, CPU, GPU y memoria viven en un mismo chip (SoC, System on a Chip). Comparten la energía de la batería y el calor que generan. El calor se disipa por la carcasa: no hay ventilador.</a:t>
@@ -5539,7 +5984,7 @@
         <p:spPr>
           <a:xfrm>
             <a:off x="502920" y="1280160"/>
-            <a:ext cx="6979615" cy="3291840"/>
+            <a:ext cx="11185855" cy="3291840"/>
           </a:xfrm>
           <a:prstGeom prst="rect">
             <a:avLst/>
@@ -5609,75 +6054,7 @@
       </p:sp>
       <p:sp>
         <p:nvSpPr>
-          <p:cNvPr id="4" name="Rectangle 3"/>
-          <p:cNvSpPr/>
-          <p:nvPr/>
-        </p:nvSpPr>
-        <p:spPr>
-          <a:xfrm>
-            <a:off x="7756855" y="1188720"/>
-            <a:ext cx="3931920" cy="3291840"/>
-          </a:xfrm>
-          <a:prstGeom prst="rect">
-            <a:avLst/>
-          </a:prstGeom>
-          <a:solidFill>
-            <a:srgbClr val="F3F4F6"/>
-          </a:solidFill>
-          <a:ln>
-            <a:solidFill>
-              <a:srgbClr val="6B7280"/>
-            </a:solidFill>
-            <a:prstDash val="dash"/>
-          </a:ln>
-          <a:effectLst/>
-        </p:spPr>
-        <p:style>
-          <a:lnRef idx="1">
-            <a:schemeClr val="accent1"/>
-          </a:lnRef>
-          <a:fillRef idx="3">
-            <a:schemeClr val="accent1"/>
-          </a:fillRef>
-          <a:effectRef idx="2">
-            <a:schemeClr val="accent1"/>
-          </a:effectRef>
-          <a:fontRef idx="minor">
-            <a:schemeClr val="lt1"/>
-          </a:fontRef>
-        </p:style>
-        <p:txBody>
-          <a:bodyPr rtlCol="0" anchor="ctr" wrap="square" lIns="182880" rIns="182880"/>
-          <a:lstStyle/>
-          <a:p>
-            <a:pPr algn="ctr"/>
-            <a:r>
-              <a:rPr sz="1300" b="1" i="0">
-                <a:solidFill>
-                  <a:srgbClr val="6B7280"/>
-                </a:solidFill>
-                <a:latin typeface="Calibri"/>
-              </a:rPr>
-              <a:t>[IMAGEN SUGERIDA]</a:t>
-            </a:r>
-          </a:p>
-          <a:p>
-            <a:pPr algn="ctr"/>
-            <a:r>
-              <a:rPr sz="1300" b="0" i="1">
-                <a:solidFill>
-                  <a:srgbClr val="6B7280"/>
-                </a:solidFill>
-                <a:latin typeface="Calibri"/>
-              </a:rPr>
-              <a:t>Teléfono en vertical con Asteroides corriendo, sostenido con una mano.</a:t>
-            </a:r>
-          </a:p>
-        </p:txBody>
-      </p:sp>
-      <p:sp>
-        <p:nvSpPr>
-          <p:cNvPr id="5" name="TextBox 4"/>
+          <p:cNvPr id="4" name="TextBox 3"/>
           <p:cNvSpPr txBox="1"/>
           <p:nvPr/>
         </p:nvSpPr>
@@ -6035,26 +6412,25 @@
       </p:sp>
       <p:sp>
         <p:nvSpPr>
-          <p:cNvPr id="9" name="Rectangle 8"/>
+          <p:cNvPr id="9" name="Rounded Rectangle 8"/>
           <p:cNvSpPr/>
           <p:nvPr/>
         </p:nvSpPr>
         <p:spPr>
           <a:xfrm>
-            <a:off x="7756855" y="1234440"/>
-            <a:ext cx="3931920" cy="4754880"/>
-          </a:xfrm>
-          <a:prstGeom prst="rect">
-            <a:avLst/>
+            <a:off x="5928055" y="1325880"/>
+            <a:ext cx="2286000" cy="4572000"/>
+          </a:xfrm>
+          <a:prstGeom prst="roundRect">
+            <a:avLst>
+              <a:gd name="adj" fmla="val 8000"/>
+            </a:avLst>
           </a:prstGeom>
           <a:solidFill>
-            <a:srgbClr val="F3F4F6"/>
+            <a:srgbClr val="1F2A44"/>
           </a:solidFill>
           <a:ln>
-            <a:solidFill>
-              <a:srgbClr val="6B7280"/>
-            </a:solidFill>
-            <a:prstDash val="dash"/>
+            <a:noFill/>
           </a:ln>
           <a:effectLst/>
         </p:spPr>
@@ -6073,44 +6449,1561 @@
           </a:fontRef>
         </p:style>
         <p:txBody>
-          <a:bodyPr rtlCol="0" anchor="ctr" wrap="square" lIns="182880" rIns="182880"/>
+          <a:bodyPr rtlCol="0" anchor="ctr"/>
           <a:lstStyle/>
           <a:p>
             <a:pPr algn="ctr"/>
-            <a:r>
-              <a:rPr sz="1300" b="1" i="0">
-                <a:solidFill>
-                  <a:srgbClr val="6B7280"/>
-                </a:solidFill>
-                <a:latin typeface="Calibri"/>
-              </a:rPr>
-              <a:t>[IMAGEN SUGERIDA]</a:t>
-            </a:r>
-          </a:p>
+          </a:p>
+        </p:txBody>
+      </p:sp>
+      <p:sp>
+        <p:nvSpPr>
+          <p:cNvPr id="10" name="Rectangle 9"/>
+          <p:cNvSpPr/>
+          <p:nvPr/>
+        </p:nvSpPr>
+        <p:spPr>
+          <a:xfrm>
+            <a:off x="6037783" y="1545336"/>
+            <a:ext cx="516636" cy="590441"/>
+          </a:xfrm>
+          <a:prstGeom prst="rect">
+            <a:avLst/>
+          </a:prstGeom>
+          <a:solidFill>
+            <a:srgbClr val="FFFFFF"/>
+          </a:solidFill>
+          <a:ln w="12700">
+            <a:solidFill>
+              <a:srgbClr val="E5E7EB"/>
+            </a:solidFill>
+          </a:ln>
+          <a:effectLst/>
+        </p:spPr>
+        <p:style>
+          <a:lnRef idx="1">
+            <a:schemeClr val="accent1"/>
+          </a:lnRef>
+          <a:fillRef idx="3">
+            <a:schemeClr val="accent1"/>
+          </a:fillRef>
+          <a:effectRef idx="2">
+            <a:schemeClr val="accent1"/>
+          </a:effectRef>
+          <a:fontRef idx="minor">
+            <a:schemeClr val="lt1"/>
+          </a:fontRef>
+        </p:style>
+        <p:txBody>
+          <a:bodyPr rtlCol="0" anchor="ctr"/>
+          <a:lstStyle/>
           <a:p>
             <a:pPr algn="ctr"/>
-            <a:r>
-              <a:rPr sz="1300" b="0" i="1">
-                <a:solidFill>
-                  <a:srgbClr val="6B7280"/>
-                </a:solidFill>
-                <a:latin typeface="Calibri"/>
-              </a:rPr>
-              <a:t>Pantalla dividida en tiles; en un tile, varias capas de partículas superpuestas sobre el mismo píxel.</a:t>
-            </a:r>
-          </a:p>
-        </p:txBody>
-      </p:sp>
-      <p:sp>
-        <p:nvSpPr>
-          <p:cNvPr id="10" name="TextBox 9"/>
+          </a:p>
+        </p:txBody>
+      </p:sp>
+      <p:sp>
+        <p:nvSpPr>
+          <p:cNvPr id="11" name="Rectangle 10"/>
+          <p:cNvSpPr/>
+          <p:nvPr/>
+        </p:nvSpPr>
+        <p:spPr>
+          <a:xfrm>
+            <a:off x="6554419" y="1545336"/>
+            <a:ext cx="516636" cy="590441"/>
+          </a:xfrm>
+          <a:prstGeom prst="rect">
+            <a:avLst/>
+          </a:prstGeom>
+          <a:solidFill>
+            <a:srgbClr val="FFFFFF"/>
+          </a:solidFill>
+          <a:ln w="12700">
+            <a:solidFill>
+              <a:srgbClr val="E5E7EB"/>
+            </a:solidFill>
+          </a:ln>
+          <a:effectLst/>
+        </p:spPr>
+        <p:style>
+          <a:lnRef idx="1">
+            <a:schemeClr val="accent1"/>
+          </a:lnRef>
+          <a:fillRef idx="3">
+            <a:schemeClr val="accent1"/>
+          </a:fillRef>
+          <a:effectRef idx="2">
+            <a:schemeClr val="accent1"/>
+          </a:effectRef>
+          <a:fontRef idx="minor">
+            <a:schemeClr val="lt1"/>
+          </a:fontRef>
+        </p:style>
+        <p:txBody>
+          <a:bodyPr rtlCol="0" anchor="ctr"/>
+          <a:lstStyle/>
+          <a:p>
+            <a:pPr algn="ctr"/>
+          </a:p>
+        </p:txBody>
+      </p:sp>
+      <p:sp>
+        <p:nvSpPr>
+          <p:cNvPr id="12" name="Rectangle 11"/>
+          <p:cNvSpPr/>
+          <p:nvPr/>
+        </p:nvSpPr>
+        <p:spPr>
+          <a:xfrm>
+            <a:off x="7071055" y="1545336"/>
+            <a:ext cx="516636" cy="590441"/>
+          </a:xfrm>
+          <a:prstGeom prst="rect">
+            <a:avLst/>
+          </a:prstGeom>
+          <a:solidFill>
+            <a:srgbClr val="FFFFFF"/>
+          </a:solidFill>
+          <a:ln w="12700">
+            <a:solidFill>
+              <a:srgbClr val="E5E7EB"/>
+            </a:solidFill>
+          </a:ln>
+          <a:effectLst/>
+        </p:spPr>
+        <p:style>
+          <a:lnRef idx="1">
+            <a:schemeClr val="accent1"/>
+          </a:lnRef>
+          <a:fillRef idx="3">
+            <a:schemeClr val="accent1"/>
+          </a:fillRef>
+          <a:effectRef idx="2">
+            <a:schemeClr val="accent1"/>
+          </a:effectRef>
+          <a:fontRef idx="minor">
+            <a:schemeClr val="lt1"/>
+          </a:fontRef>
+        </p:style>
+        <p:txBody>
+          <a:bodyPr rtlCol="0" anchor="ctr"/>
+          <a:lstStyle/>
+          <a:p>
+            <a:pPr algn="ctr"/>
+          </a:p>
+        </p:txBody>
+      </p:sp>
+      <p:sp>
+        <p:nvSpPr>
+          <p:cNvPr id="13" name="Rectangle 12"/>
+          <p:cNvSpPr/>
+          <p:nvPr/>
+        </p:nvSpPr>
+        <p:spPr>
+          <a:xfrm>
+            <a:off x="7587691" y="1545336"/>
+            <a:ext cx="516636" cy="590441"/>
+          </a:xfrm>
+          <a:prstGeom prst="rect">
+            <a:avLst/>
+          </a:prstGeom>
+          <a:solidFill>
+            <a:srgbClr val="FFFFFF"/>
+          </a:solidFill>
+          <a:ln w="12700">
+            <a:solidFill>
+              <a:srgbClr val="E5E7EB"/>
+            </a:solidFill>
+          </a:ln>
+          <a:effectLst/>
+        </p:spPr>
+        <p:style>
+          <a:lnRef idx="1">
+            <a:schemeClr val="accent1"/>
+          </a:lnRef>
+          <a:fillRef idx="3">
+            <a:schemeClr val="accent1"/>
+          </a:fillRef>
+          <a:effectRef idx="2">
+            <a:schemeClr val="accent1"/>
+          </a:effectRef>
+          <a:fontRef idx="minor">
+            <a:schemeClr val="lt1"/>
+          </a:fontRef>
+        </p:style>
+        <p:txBody>
+          <a:bodyPr rtlCol="0" anchor="ctr"/>
+          <a:lstStyle/>
+          <a:p>
+            <a:pPr algn="ctr"/>
+          </a:p>
+        </p:txBody>
+      </p:sp>
+      <p:sp>
+        <p:nvSpPr>
+          <p:cNvPr id="14" name="Rectangle 13"/>
+          <p:cNvSpPr/>
+          <p:nvPr/>
+        </p:nvSpPr>
+        <p:spPr>
+          <a:xfrm>
+            <a:off x="6037783" y="2135777"/>
+            <a:ext cx="516636" cy="590441"/>
+          </a:xfrm>
+          <a:prstGeom prst="rect">
+            <a:avLst/>
+          </a:prstGeom>
+          <a:solidFill>
+            <a:srgbClr val="FFFFFF"/>
+          </a:solidFill>
+          <a:ln w="12700">
+            <a:solidFill>
+              <a:srgbClr val="E5E7EB"/>
+            </a:solidFill>
+          </a:ln>
+          <a:effectLst/>
+        </p:spPr>
+        <p:style>
+          <a:lnRef idx="1">
+            <a:schemeClr val="accent1"/>
+          </a:lnRef>
+          <a:fillRef idx="3">
+            <a:schemeClr val="accent1"/>
+          </a:fillRef>
+          <a:effectRef idx="2">
+            <a:schemeClr val="accent1"/>
+          </a:effectRef>
+          <a:fontRef idx="minor">
+            <a:schemeClr val="lt1"/>
+          </a:fontRef>
+        </p:style>
+        <p:txBody>
+          <a:bodyPr rtlCol="0" anchor="ctr"/>
+          <a:lstStyle/>
+          <a:p>
+            <a:pPr algn="ctr"/>
+          </a:p>
+        </p:txBody>
+      </p:sp>
+      <p:sp>
+        <p:nvSpPr>
+          <p:cNvPr id="15" name="Rectangle 14"/>
+          <p:cNvSpPr/>
+          <p:nvPr/>
+        </p:nvSpPr>
+        <p:spPr>
+          <a:xfrm>
+            <a:off x="6554419" y="2135777"/>
+            <a:ext cx="516636" cy="590441"/>
+          </a:xfrm>
+          <a:prstGeom prst="rect">
+            <a:avLst/>
+          </a:prstGeom>
+          <a:solidFill>
+            <a:srgbClr val="FFFFFF"/>
+          </a:solidFill>
+          <a:ln w="12700">
+            <a:solidFill>
+              <a:srgbClr val="E5E7EB"/>
+            </a:solidFill>
+          </a:ln>
+          <a:effectLst/>
+        </p:spPr>
+        <p:style>
+          <a:lnRef idx="1">
+            <a:schemeClr val="accent1"/>
+          </a:lnRef>
+          <a:fillRef idx="3">
+            <a:schemeClr val="accent1"/>
+          </a:fillRef>
+          <a:effectRef idx="2">
+            <a:schemeClr val="accent1"/>
+          </a:effectRef>
+          <a:fontRef idx="minor">
+            <a:schemeClr val="lt1"/>
+          </a:fontRef>
+        </p:style>
+        <p:txBody>
+          <a:bodyPr rtlCol="0" anchor="ctr"/>
+          <a:lstStyle/>
+          <a:p>
+            <a:pPr algn="ctr"/>
+          </a:p>
+        </p:txBody>
+      </p:sp>
+      <p:sp>
+        <p:nvSpPr>
+          <p:cNvPr id="16" name="Rectangle 15"/>
+          <p:cNvSpPr/>
+          <p:nvPr/>
+        </p:nvSpPr>
+        <p:spPr>
+          <a:xfrm>
+            <a:off x="7071055" y="2135777"/>
+            <a:ext cx="516636" cy="590441"/>
+          </a:xfrm>
+          <a:prstGeom prst="rect">
+            <a:avLst/>
+          </a:prstGeom>
+          <a:solidFill>
+            <a:srgbClr val="FFFFFF"/>
+          </a:solidFill>
+          <a:ln w="12700">
+            <a:solidFill>
+              <a:srgbClr val="E5E7EB"/>
+            </a:solidFill>
+          </a:ln>
+          <a:effectLst/>
+        </p:spPr>
+        <p:style>
+          <a:lnRef idx="1">
+            <a:schemeClr val="accent1"/>
+          </a:lnRef>
+          <a:fillRef idx="3">
+            <a:schemeClr val="accent1"/>
+          </a:fillRef>
+          <a:effectRef idx="2">
+            <a:schemeClr val="accent1"/>
+          </a:effectRef>
+          <a:fontRef idx="minor">
+            <a:schemeClr val="lt1"/>
+          </a:fontRef>
+        </p:style>
+        <p:txBody>
+          <a:bodyPr rtlCol="0" anchor="ctr"/>
+          <a:lstStyle/>
+          <a:p>
+            <a:pPr algn="ctr"/>
+          </a:p>
+        </p:txBody>
+      </p:sp>
+      <p:sp>
+        <p:nvSpPr>
+          <p:cNvPr id="17" name="Rectangle 16"/>
+          <p:cNvSpPr/>
+          <p:nvPr/>
+        </p:nvSpPr>
+        <p:spPr>
+          <a:xfrm>
+            <a:off x="7587691" y="2135777"/>
+            <a:ext cx="516636" cy="590441"/>
+          </a:xfrm>
+          <a:prstGeom prst="rect">
+            <a:avLst/>
+          </a:prstGeom>
+          <a:solidFill>
+            <a:srgbClr val="FFFFFF"/>
+          </a:solidFill>
+          <a:ln w="12700">
+            <a:solidFill>
+              <a:srgbClr val="E5E7EB"/>
+            </a:solidFill>
+          </a:ln>
+          <a:effectLst/>
+        </p:spPr>
+        <p:style>
+          <a:lnRef idx="1">
+            <a:schemeClr val="accent1"/>
+          </a:lnRef>
+          <a:fillRef idx="3">
+            <a:schemeClr val="accent1"/>
+          </a:fillRef>
+          <a:effectRef idx="2">
+            <a:schemeClr val="accent1"/>
+          </a:effectRef>
+          <a:fontRef idx="minor">
+            <a:schemeClr val="lt1"/>
+          </a:fontRef>
+        </p:style>
+        <p:txBody>
+          <a:bodyPr rtlCol="0" anchor="ctr"/>
+          <a:lstStyle/>
+          <a:p>
+            <a:pPr algn="ctr"/>
+          </a:p>
+        </p:txBody>
+      </p:sp>
+      <p:sp>
+        <p:nvSpPr>
+          <p:cNvPr id="18" name="Rectangle 17"/>
+          <p:cNvSpPr/>
+          <p:nvPr/>
+        </p:nvSpPr>
+        <p:spPr>
+          <a:xfrm>
+            <a:off x="6037783" y="2726218"/>
+            <a:ext cx="516636" cy="590441"/>
+          </a:xfrm>
+          <a:prstGeom prst="rect">
+            <a:avLst/>
+          </a:prstGeom>
+          <a:solidFill>
+            <a:srgbClr val="FFFFFF"/>
+          </a:solidFill>
+          <a:ln w="12700">
+            <a:solidFill>
+              <a:srgbClr val="E5E7EB"/>
+            </a:solidFill>
+          </a:ln>
+          <a:effectLst/>
+        </p:spPr>
+        <p:style>
+          <a:lnRef idx="1">
+            <a:schemeClr val="accent1"/>
+          </a:lnRef>
+          <a:fillRef idx="3">
+            <a:schemeClr val="accent1"/>
+          </a:fillRef>
+          <a:effectRef idx="2">
+            <a:schemeClr val="accent1"/>
+          </a:effectRef>
+          <a:fontRef idx="minor">
+            <a:schemeClr val="lt1"/>
+          </a:fontRef>
+        </p:style>
+        <p:txBody>
+          <a:bodyPr rtlCol="0" anchor="ctr"/>
+          <a:lstStyle/>
+          <a:p>
+            <a:pPr algn="ctr"/>
+          </a:p>
+        </p:txBody>
+      </p:sp>
+      <p:sp>
+        <p:nvSpPr>
+          <p:cNvPr id="19" name="Rectangle 18"/>
+          <p:cNvSpPr/>
+          <p:nvPr/>
+        </p:nvSpPr>
+        <p:spPr>
+          <a:xfrm>
+            <a:off x="6554419" y="2726218"/>
+            <a:ext cx="516636" cy="590441"/>
+          </a:xfrm>
+          <a:prstGeom prst="rect">
+            <a:avLst/>
+          </a:prstGeom>
+          <a:solidFill>
+            <a:srgbClr val="0D9488"/>
+          </a:solidFill>
+          <a:ln w="12700">
+            <a:solidFill>
+              <a:srgbClr val="E5E7EB"/>
+            </a:solidFill>
+          </a:ln>
+          <a:effectLst/>
+        </p:spPr>
+        <p:style>
+          <a:lnRef idx="1">
+            <a:schemeClr val="accent1"/>
+          </a:lnRef>
+          <a:fillRef idx="3">
+            <a:schemeClr val="accent1"/>
+          </a:fillRef>
+          <a:effectRef idx="2">
+            <a:schemeClr val="accent1"/>
+          </a:effectRef>
+          <a:fontRef idx="minor">
+            <a:schemeClr val="lt1"/>
+          </a:fontRef>
+        </p:style>
+        <p:txBody>
+          <a:bodyPr rtlCol="0" anchor="ctr"/>
+          <a:lstStyle/>
+          <a:p>
+            <a:pPr algn="ctr"/>
+          </a:p>
+        </p:txBody>
+      </p:sp>
+      <p:sp>
+        <p:nvSpPr>
+          <p:cNvPr id="20" name="Rectangle 19"/>
+          <p:cNvSpPr/>
+          <p:nvPr/>
+        </p:nvSpPr>
+        <p:spPr>
+          <a:xfrm>
+            <a:off x="7071055" y="2726218"/>
+            <a:ext cx="516636" cy="590441"/>
+          </a:xfrm>
+          <a:prstGeom prst="rect">
+            <a:avLst/>
+          </a:prstGeom>
+          <a:solidFill>
+            <a:srgbClr val="FFFFFF"/>
+          </a:solidFill>
+          <a:ln w="12700">
+            <a:solidFill>
+              <a:srgbClr val="E5E7EB"/>
+            </a:solidFill>
+          </a:ln>
+          <a:effectLst/>
+        </p:spPr>
+        <p:style>
+          <a:lnRef idx="1">
+            <a:schemeClr val="accent1"/>
+          </a:lnRef>
+          <a:fillRef idx="3">
+            <a:schemeClr val="accent1"/>
+          </a:fillRef>
+          <a:effectRef idx="2">
+            <a:schemeClr val="accent1"/>
+          </a:effectRef>
+          <a:fontRef idx="minor">
+            <a:schemeClr val="lt1"/>
+          </a:fontRef>
+        </p:style>
+        <p:txBody>
+          <a:bodyPr rtlCol="0" anchor="ctr"/>
+          <a:lstStyle/>
+          <a:p>
+            <a:pPr algn="ctr"/>
+          </a:p>
+        </p:txBody>
+      </p:sp>
+      <p:sp>
+        <p:nvSpPr>
+          <p:cNvPr id="21" name="Rectangle 20"/>
+          <p:cNvSpPr/>
+          <p:nvPr/>
+        </p:nvSpPr>
+        <p:spPr>
+          <a:xfrm>
+            <a:off x="7587691" y="2726218"/>
+            <a:ext cx="516636" cy="590441"/>
+          </a:xfrm>
+          <a:prstGeom prst="rect">
+            <a:avLst/>
+          </a:prstGeom>
+          <a:solidFill>
+            <a:srgbClr val="FFFFFF"/>
+          </a:solidFill>
+          <a:ln w="12700">
+            <a:solidFill>
+              <a:srgbClr val="E5E7EB"/>
+            </a:solidFill>
+          </a:ln>
+          <a:effectLst/>
+        </p:spPr>
+        <p:style>
+          <a:lnRef idx="1">
+            <a:schemeClr val="accent1"/>
+          </a:lnRef>
+          <a:fillRef idx="3">
+            <a:schemeClr val="accent1"/>
+          </a:fillRef>
+          <a:effectRef idx="2">
+            <a:schemeClr val="accent1"/>
+          </a:effectRef>
+          <a:fontRef idx="minor">
+            <a:schemeClr val="lt1"/>
+          </a:fontRef>
+        </p:style>
+        <p:txBody>
+          <a:bodyPr rtlCol="0" anchor="ctr"/>
+          <a:lstStyle/>
+          <a:p>
+            <a:pPr algn="ctr"/>
+          </a:p>
+        </p:txBody>
+      </p:sp>
+      <p:sp>
+        <p:nvSpPr>
+          <p:cNvPr id="22" name="Rectangle 21"/>
+          <p:cNvSpPr/>
+          <p:nvPr/>
+        </p:nvSpPr>
+        <p:spPr>
+          <a:xfrm>
+            <a:off x="6037783" y="3316659"/>
+            <a:ext cx="516636" cy="590441"/>
+          </a:xfrm>
+          <a:prstGeom prst="rect">
+            <a:avLst/>
+          </a:prstGeom>
+          <a:solidFill>
+            <a:srgbClr val="FFFFFF"/>
+          </a:solidFill>
+          <a:ln w="12700">
+            <a:solidFill>
+              <a:srgbClr val="E5E7EB"/>
+            </a:solidFill>
+          </a:ln>
+          <a:effectLst/>
+        </p:spPr>
+        <p:style>
+          <a:lnRef idx="1">
+            <a:schemeClr val="accent1"/>
+          </a:lnRef>
+          <a:fillRef idx="3">
+            <a:schemeClr val="accent1"/>
+          </a:fillRef>
+          <a:effectRef idx="2">
+            <a:schemeClr val="accent1"/>
+          </a:effectRef>
+          <a:fontRef idx="minor">
+            <a:schemeClr val="lt1"/>
+          </a:fontRef>
+        </p:style>
+        <p:txBody>
+          <a:bodyPr rtlCol="0" anchor="ctr"/>
+          <a:lstStyle/>
+          <a:p>
+            <a:pPr algn="ctr"/>
+          </a:p>
+        </p:txBody>
+      </p:sp>
+      <p:sp>
+        <p:nvSpPr>
+          <p:cNvPr id="23" name="Rectangle 22"/>
+          <p:cNvSpPr/>
+          <p:nvPr/>
+        </p:nvSpPr>
+        <p:spPr>
+          <a:xfrm>
+            <a:off x="6554419" y="3316659"/>
+            <a:ext cx="516636" cy="590441"/>
+          </a:xfrm>
+          <a:prstGeom prst="rect">
+            <a:avLst/>
+          </a:prstGeom>
+          <a:solidFill>
+            <a:srgbClr val="FFFFFF"/>
+          </a:solidFill>
+          <a:ln w="12700">
+            <a:solidFill>
+              <a:srgbClr val="E5E7EB"/>
+            </a:solidFill>
+          </a:ln>
+          <a:effectLst/>
+        </p:spPr>
+        <p:style>
+          <a:lnRef idx="1">
+            <a:schemeClr val="accent1"/>
+          </a:lnRef>
+          <a:fillRef idx="3">
+            <a:schemeClr val="accent1"/>
+          </a:fillRef>
+          <a:effectRef idx="2">
+            <a:schemeClr val="accent1"/>
+          </a:effectRef>
+          <a:fontRef idx="minor">
+            <a:schemeClr val="lt1"/>
+          </a:fontRef>
+        </p:style>
+        <p:txBody>
+          <a:bodyPr rtlCol="0" anchor="ctr"/>
+          <a:lstStyle/>
+          <a:p>
+            <a:pPr algn="ctr"/>
+          </a:p>
+        </p:txBody>
+      </p:sp>
+      <p:sp>
+        <p:nvSpPr>
+          <p:cNvPr id="24" name="Rectangle 23"/>
+          <p:cNvSpPr/>
+          <p:nvPr/>
+        </p:nvSpPr>
+        <p:spPr>
+          <a:xfrm>
+            <a:off x="7071055" y="3316659"/>
+            <a:ext cx="516636" cy="590441"/>
+          </a:xfrm>
+          <a:prstGeom prst="rect">
+            <a:avLst/>
+          </a:prstGeom>
+          <a:solidFill>
+            <a:srgbClr val="FFFFFF"/>
+          </a:solidFill>
+          <a:ln w="12700">
+            <a:solidFill>
+              <a:srgbClr val="E5E7EB"/>
+            </a:solidFill>
+          </a:ln>
+          <a:effectLst/>
+        </p:spPr>
+        <p:style>
+          <a:lnRef idx="1">
+            <a:schemeClr val="accent1"/>
+          </a:lnRef>
+          <a:fillRef idx="3">
+            <a:schemeClr val="accent1"/>
+          </a:fillRef>
+          <a:effectRef idx="2">
+            <a:schemeClr val="accent1"/>
+          </a:effectRef>
+          <a:fontRef idx="minor">
+            <a:schemeClr val="lt1"/>
+          </a:fontRef>
+        </p:style>
+        <p:txBody>
+          <a:bodyPr rtlCol="0" anchor="ctr"/>
+          <a:lstStyle/>
+          <a:p>
+            <a:pPr algn="ctr"/>
+          </a:p>
+        </p:txBody>
+      </p:sp>
+      <p:sp>
+        <p:nvSpPr>
+          <p:cNvPr id="25" name="Rectangle 24"/>
+          <p:cNvSpPr/>
+          <p:nvPr/>
+        </p:nvSpPr>
+        <p:spPr>
+          <a:xfrm>
+            <a:off x="7587691" y="3316659"/>
+            <a:ext cx="516636" cy="590441"/>
+          </a:xfrm>
+          <a:prstGeom prst="rect">
+            <a:avLst/>
+          </a:prstGeom>
+          <a:solidFill>
+            <a:srgbClr val="FFFFFF"/>
+          </a:solidFill>
+          <a:ln w="12700">
+            <a:solidFill>
+              <a:srgbClr val="E5E7EB"/>
+            </a:solidFill>
+          </a:ln>
+          <a:effectLst/>
+        </p:spPr>
+        <p:style>
+          <a:lnRef idx="1">
+            <a:schemeClr val="accent1"/>
+          </a:lnRef>
+          <a:fillRef idx="3">
+            <a:schemeClr val="accent1"/>
+          </a:fillRef>
+          <a:effectRef idx="2">
+            <a:schemeClr val="accent1"/>
+          </a:effectRef>
+          <a:fontRef idx="minor">
+            <a:schemeClr val="lt1"/>
+          </a:fontRef>
+        </p:style>
+        <p:txBody>
+          <a:bodyPr rtlCol="0" anchor="ctr"/>
+          <a:lstStyle/>
+          <a:p>
+            <a:pPr algn="ctr"/>
+          </a:p>
+        </p:txBody>
+      </p:sp>
+      <p:sp>
+        <p:nvSpPr>
+          <p:cNvPr id="26" name="Rectangle 25"/>
+          <p:cNvSpPr/>
+          <p:nvPr/>
+        </p:nvSpPr>
+        <p:spPr>
+          <a:xfrm>
+            <a:off x="6037783" y="3907100"/>
+            <a:ext cx="516636" cy="590441"/>
+          </a:xfrm>
+          <a:prstGeom prst="rect">
+            <a:avLst/>
+          </a:prstGeom>
+          <a:solidFill>
+            <a:srgbClr val="FFFFFF"/>
+          </a:solidFill>
+          <a:ln w="12700">
+            <a:solidFill>
+              <a:srgbClr val="E5E7EB"/>
+            </a:solidFill>
+          </a:ln>
+          <a:effectLst/>
+        </p:spPr>
+        <p:style>
+          <a:lnRef idx="1">
+            <a:schemeClr val="accent1"/>
+          </a:lnRef>
+          <a:fillRef idx="3">
+            <a:schemeClr val="accent1"/>
+          </a:fillRef>
+          <a:effectRef idx="2">
+            <a:schemeClr val="accent1"/>
+          </a:effectRef>
+          <a:fontRef idx="minor">
+            <a:schemeClr val="lt1"/>
+          </a:fontRef>
+        </p:style>
+        <p:txBody>
+          <a:bodyPr rtlCol="0" anchor="ctr"/>
+          <a:lstStyle/>
+          <a:p>
+            <a:pPr algn="ctr"/>
+          </a:p>
+        </p:txBody>
+      </p:sp>
+      <p:sp>
+        <p:nvSpPr>
+          <p:cNvPr id="27" name="Rectangle 26"/>
+          <p:cNvSpPr/>
+          <p:nvPr/>
+        </p:nvSpPr>
+        <p:spPr>
+          <a:xfrm>
+            <a:off x="6554419" y="3907100"/>
+            <a:ext cx="516636" cy="590441"/>
+          </a:xfrm>
+          <a:prstGeom prst="rect">
+            <a:avLst/>
+          </a:prstGeom>
+          <a:solidFill>
+            <a:srgbClr val="FFFFFF"/>
+          </a:solidFill>
+          <a:ln w="12700">
+            <a:solidFill>
+              <a:srgbClr val="E5E7EB"/>
+            </a:solidFill>
+          </a:ln>
+          <a:effectLst/>
+        </p:spPr>
+        <p:style>
+          <a:lnRef idx="1">
+            <a:schemeClr val="accent1"/>
+          </a:lnRef>
+          <a:fillRef idx="3">
+            <a:schemeClr val="accent1"/>
+          </a:fillRef>
+          <a:effectRef idx="2">
+            <a:schemeClr val="accent1"/>
+          </a:effectRef>
+          <a:fontRef idx="minor">
+            <a:schemeClr val="lt1"/>
+          </a:fontRef>
+        </p:style>
+        <p:txBody>
+          <a:bodyPr rtlCol="0" anchor="ctr"/>
+          <a:lstStyle/>
+          <a:p>
+            <a:pPr algn="ctr"/>
+          </a:p>
+        </p:txBody>
+      </p:sp>
+      <p:sp>
+        <p:nvSpPr>
+          <p:cNvPr id="28" name="Rectangle 27"/>
+          <p:cNvSpPr/>
+          <p:nvPr/>
+        </p:nvSpPr>
+        <p:spPr>
+          <a:xfrm>
+            <a:off x="7071055" y="3907100"/>
+            <a:ext cx="516636" cy="590441"/>
+          </a:xfrm>
+          <a:prstGeom prst="rect">
+            <a:avLst/>
+          </a:prstGeom>
+          <a:solidFill>
+            <a:srgbClr val="FFFFFF"/>
+          </a:solidFill>
+          <a:ln w="12700">
+            <a:solidFill>
+              <a:srgbClr val="E5E7EB"/>
+            </a:solidFill>
+          </a:ln>
+          <a:effectLst/>
+        </p:spPr>
+        <p:style>
+          <a:lnRef idx="1">
+            <a:schemeClr val="accent1"/>
+          </a:lnRef>
+          <a:fillRef idx="3">
+            <a:schemeClr val="accent1"/>
+          </a:fillRef>
+          <a:effectRef idx="2">
+            <a:schemeClr val="accent1"/>
+          </a:effectRef>
+          <a:fontRef idx="minor">
+            <a:schemeClr val="lt1"/>
+          </a:fontRef>
+        </p:style>
+        <p:txBody>
+          <a:bodyPr rtlCol="0" anchor="ctr"/>
+          <a:lstStyle/>
+          <a:p>
+            <a:pPr algn="ctr"/>
+          </a:p>
+        </p:txBody>
+      </p:sp>
+      <p:sp>
+        <p:nvSpPr>
+          <p:cNvPr id="29" name="Rectangle 28"/>
+          <p:cNvSpPr/>
+          <p:nvPr/>
+        </p:nvSpPr>
+        <p:spPr>
+          <a:xfrm>
+            <a:off x="7587691" y="3907100"/>
+            <a:ext cx="516636" cy="590441"/>
+          </a:xfrm>
+          <a:prstGeom prst="rect">
+            <a:avLst/>
+          </a:prstGeom>
+          <a:solidFill>
+            <a:srgbClr val="FFFFFF"/>
+          </a:solidFill>
+          <a:ln w="12700">
+            <a:solidFill>
+              <a:srgbClr val="E5E7EB"/>
+            </a:solidFill>
+          </a:ln>
+          <a:effectLst/>
+        </p:spPr>
+        <p:style>
+          <a:lnRef idx="1">
+            <a:schemeClr val="accent1"/>
+          </a:lnRef>
+          <a:fillRef idx="3">
+            <a:schemeClr val="accent1"/>
+          </a:fillRef>
+          <a:effectRef idx="2">
+            <a:schemeClr val="accent1"/>
+          </a:effectRef>
+          <a:fontRef idx="minor">
+            <a:schemeClr val="lt1"/>
+          </a:fontRef>
+        </p:style>
+        <p:txBody>
+          <a:bodyPr rtlCol="0" anchor="ctr"/>
+          <a:lstStyle/>
+          <a:p>
+            <a:pPr algn="ctr"/>
+          </a:p>
+        </p:txBody>
+      </p:sp>
+      <p:sp>
+        <p:nvSpPr>
+          <p:cNvPr id="30" name="Rectangle 29"/>
+          <p:cNvSpPr/>
+          <p:nvPr/>
+        </p:nvSpPr>
+        <p:spPr>
+          <a:xfrm>
+            <a:off x="6037783" y="4497541"/>
+            <a:ext cx="516636" cy="590441"/>
+          </a:xfrm>
+          <a:prstGeom prst="rect">
+            <a:avLst/>
+          </a:prstGeom>
+          <a:solidFill>
+            <a:srgbClr val="FFFFFF"/>
+          </a:solidFill>
+          <a:ln w="12700">
+            <a:solidFill>
+              <a:srgbClr val="E5E7EB"/>
+            </a:solidFill>
+          </a:ln>
+          <a:effectLst/>
+        </p:spPr>
+        <p:style>
+          <a:lnRef idx="1">
+            <a:schemeClr val="accent1"/>
+          </a:lnRef>
+          <a:fillRef idx="3">
+            <a:schemeClr val="accent1"/>
+          </a:fillRef>
+          <a:effectRef idx="2">
+            <a:schemeClr val="accent1"/>
+          </a:effectRef>
+          <a:fontRef idx="minor">
+            <a:schemeClr val="lt1"/>
+          </a:fontRef>
+        </p:style>
+        <p:txBody>
+          <a:bodyPr rtlCol="0" anchor="ctr"/>
+          <a:lstStyle/>
+          <a:p>
+            <a:pPr algn="ctr"/>
+          </a:p>
+        </p:txBody>
+      </p:sp>
+      <p:sp>
+        <p:nvSpPr>
+          <p:cNvPr id="31" name="Rectangle 30"/>
+          <p:cNvSpPr/>
+          <p:nvPr/>
+        </p:nvSpPr>
+        <p:spPr>
+          <a:xfrm>
+            <a:off x="6554419" y="4497541"/>
+            <a:ext cx="516636" cy="590441"/>
+          </a:xfrm>
+          <a:prstGeom prst="rect">
+            <a:avLst/>
+          </a:prstGeom>
+          <a:solidFill>
+            <a:srgbClr val="FFFFFF"/>
+          </a:solidFill>
+          <a:ln w="12700">
+            <a:solidFill>
+              <a:srgbClr val="E5E7EB"/>
+            </a:solidFill>
+          </a:ln>
+          <a:effectLst/>
+        </p:spPr>
+        <p:style>
+          <a:lnRef idx="1">
+            <a:schemeClr val="accent1"/>
+          </a:lnRef>
+          <a:fillRef idx="3">
+            <a:schemeClr val="accent1"/>
+          </a:fillRef>
+          <a:effectRef idx="2">
+            <a:schemeClr val="accent1"/>
+          </a:effectRef>
+          <a:fontRef idx="minor">
+            <a:schemeClr val="lt1"/>
+          </a:fontRef>
+        </p:style>
+        <p:txBody>
+          <a:bodyPr rtlCol="0" anchor="ctr"/>
+          <a:lstStyle/>
+          <a:p>
+            <a:pPr algn="ctr"/>
+          </a:p>
+        </p:txBody>
+      </p:sp>
+      <p:sp>
+        <p:nvSpPr>
+          <p:cNvPr id="32" name="Rectangle 31"/>
+          <p:cNvSpPr/>
+          <p:nvPr/>
+        </p:nvSpPr>
+        <p:spPr>
+          <a:xfrm>
+            <a:off x="7071055" y="4497541"/>
+            <a:ext cx="516636" cy="590441"/>
+          </a:xfrm>
+          <a:prstGeom prst="rect">
+            <a:avLst/>
+          </a:prstGeom>
+          <a:solidFill>
+            <a:srgbClr val="FFFFFF"/>
+          </a:solidFill>
+          <a:ln w="12700">
+            <a:solidFill>
+              <a:srgbClr val="E5E7EB"/>
+            </a:solidFill>
+          </a:ln>
+          <a:effectLst/>
+        </p:spPr>
+        <p:style>
+          <a:lnRef idx="1">
+            <a:schemeClr val="accent1"/>
+          </a:lnRef>
+          <a:fillRef idx="3">
+            <a:schemeClr val="accent1"/>
+          </a:fillRef>
+          <a:effectRef idx="2">
+            <a:schemeClr val="accent1"/>
+          </a:effectRef>
+          <a:fontRef idx="minor">
+            <a:schemeClr val="lt1"/>
+          </a:fontRef>
+        </p:style>
+        <p:txBody>
+          <a:bodyPr rtlCol="0" anchor="ctr"/>
+          <a:lstStyle/>
+          <a:p>
+            <a:pPr algn="ctr"/>
+          </a:p>
+        </p:txBody>
+      </p:sp>
+      <p:sp>
+        <p:nvSpPr>
+          <p:cNvPr id="33" name="Rectangle 32"/>
+          <p:cNvSpPr/>
+          <p:nvPr/>
+        </p:nvSpPr>
+        <p:spPr>
+          <a:xfrm>
+            <a:off x="7587691" y="4497541"/>
+            <a:ext cx="516636" cy="590441"/>
+          </a:xfrm>
+          <a:prstGeom prst="rect">
+            <a:avLst/>
+          </a:prstGeom>
+          <a:solidFill>
+            <a:srgbClr val="FFFFFF"/>
+          </a:solidFill>
+          <a:ln w="12700">
+            <a:solidFill>
+              <a:srgbClr val="E5E7EB"/>
+            </a:solidFill>
+          </a:ln>
+          <a:effectLst/>
+        </p:spPr>
+        <p:style>
+          <a:lnRef idx="1">
+            <a:schemeClr val="accent1"/>
+          </a:lnRef>
+          <a:fillRef idx="3">
+            <a:schemeClr val="accent1"/>
+          </a:fillRef>
+          <a:effectRef idx="2">
+            <a:schemeClr val="accent1"/>
+          </a:effectRef>
+          <a:fontRef idx="minor">
+            <a:schemeClr val="lt1"/>
+          </a:fontRef>
+        </p:style>
+        <p:txBody>
+          <a:bodyPr rtlCol="0" anchor="ctr"/>
+          <a:lstStyle/>
+          <a:p>
+            <a:pPr algn="ctr"/>
+          </a:p>
+        </p:txBody>
+      </p:sp>
+      <p:sp>
+        <p:nvSpPr>
+          <p:cNvPr id="34" name="Rectangle 33"/>
+          <p:cNvSpPr/>
+          <p:nvPr/>
+        </p:nvSpPr>
+        <p:spPr>
+          <a:xfrm>
+            <a:off x="6037783" y="5087982"/>
+            <a:ext cx="516636" cy="590441"/>
+          </a:xfrm>
+          <a:prstGeom prst="rect">
+            <a:avLst/>
+          </a:prstGeom>
+          <a:solidFill>
+            <a:srgbClr val="FFFFFF"/>
+          </a:solidFill>
+          <a:ln w="12700">
+            <a:solidFill>
+              <a:srgbClr val="E5E7EB"/>
+            </a:solidFill>
+          </a:ln>
+          <a:effectLst/>
+        </p:spPr>
+        <p:style>
+          <a:lnRef idx="1">
+            <a:schemeClr val="accent1"/>
+          </a:lnRef>
+          <a:fillRef idx="3">
+            <a:schemeClr val="accent1"/>
+          </a:fillRef>
+          <a:effectRef idx="2">
+            <a:schemeClr val="accent1"/>
+          </a:effectRef>
+          <a:fontRef idx="minor">
+            <a:schemeClr val="lt1"/>
+          </a:fontRef>
+        </p:style>
+        <p:txBody>
+          <a:bodyPr rtlCol="0" anchor="ctr"/>
+          <a:lstStyle/>
+          <a:p>
+            <a:pPr algn="ctr"/>
+          </a:p>
+        </p:txBody>
+      </p:sp>
+      <p:sp>
+        <p:nvSpPr>
+          <p:cNvPr id="35" name="Rectangle 34"/>
+          <p:cNvSpPr/>
+          <p:nvPr/>
+        </p:nvSpPr>
+        <p:spPr>
+          <a:xfrm>
+            <a:off x="6554419" y="5087982"/>
+            <a:ext cx="516636" cy="590441"/>
+          </a:xfrm>
+          <a:prstGeom prst="rect">
+            <a:avLst/>
+          </a:prstGeom>
+          <a:solidFill>
+            <a:srgbClr val="FFFFFF"/>
+          </a:solidFill>
+          <a:ln w="12700">
+            <a:solidFill>
+              <a:srgbClr val="E5E7EB"/>
+            </a:solidFill>
+          </a:ln>
+          <a:effectLst/>
+        </p:spPr>
+        <p:style>
+          <a:lnRef idx="1">
+            <a:schemeClr val="accent1"/>
+          </a:lnRef>
+          <a:fillRef idx="3">
+            <a:schemeClr val="accent1"/>
+          </a:fillRef>
+          <a:effectRef idx="2">
+            <a:schemeClr val="accent1"/>
+          </a:effectRef>
+          <a:fontRef idx="minor">
+            <a:schemeClr val="lt1"/>
+          </a:fontRef>
+        </p:style>
+        <p:txBody>
+          <a:bodyPr rtlCol="0" anchor="ctr"/>
+          <a:lstStyle/>
+          <a:p>
+            <a:pPr algn="ctr"/>
+          </a:p>
+        </p:txBody>
+      </p:sp>
+      <p:sp>
+        <p:nvSpPr>
+          <p:cNvPr id="36" name="Rectangle 35"/>
+          <p:cNvSpPr/>
+          <p:nvPr/>
+        </p:nvSpPr>
+        <p:spPr>
+          <a:xfrm>
+            <a:off x="7071055" y="5087982"/>
+            <a:ext cx="516636" cy="590441"/>
+          </a:xfrm>
+          <a:prstGeom prst="rect">
+            <a:avLst/>
+          </a:prstGeom>
+          <a:solidFill>
+            <a:srgbClr val="FFFFFF"/>
+          </a:solidFill>
+          <a:ln w="12700">
+            <a:solidFill>
+              <a:srgbClr val="E5E7EB"/>
+            </a:solidFill>
+          </a:ln>
+          <a:effectLst/>
+        </p:spPr>
+        <p:style>
+          <a:lnRef idx="1">
+            <a:schemeClr val="accent1"/>
+          </a:lnRef>
+          <a:fillRef idx="3">
+            <a:schemeClr val="accent1"/>
+          </a:fillRef>
+          <a:effectRef idx="2">
+            <a:schemeClr val="accent1"/>
+          </a:effectRef>
+          <a:fontRef idx="minor">
+            <a:schemeClr val="lt1"/>
+          </a:fontRef>
+        </p:style>
+        <p:txBody>
+          <a:bodyPr rtlCol="0" anchor="ctr"/>
+          <a:lstStyle/>
+          <a:p>
+            <a:pPr algn="ctr"/>
+          </a:p>
+        </p:txBody>
+      </p:sp>
+      <p:sp>
+        <p:nvSpPr>
+          <p:cNvPr id="37" name="Rectangle 36"/>
+          <p:cNvSpPr/>
+          <p:nvPr/>
+        </p:nvSpPr>
+        <p:spPr>
+          <a:xfrm>
+            <a:off x="7587691" y="5087982"/>
+            <a:ext cx="516636" cy="590441"/>
+          </a:xfrm>
+          <a:prstGeom prst="rect">
+            <a:avLst/>
+          </a:prstGeom>
+          <a:solidFill>
+            <a:srgbClr val="FFFFFF"/>
+          </a:solidFill>
+          <a:ln w="12700">
+            <a:solidFill>
+              <a:srgbClr val="E5E7EB"/>
+            </a:solidFill>
+          </a:ln>
+          <a:effectLst/>
+        </p:spPr>
+        <p:style>
+          <a:lnRef idx="1">
+            <a:schemeClr val="accent1"/>
+          </a:lnRef>
+          <a:fillRef idx="3">
+            <a:schemeClr val="accent1"/>
+          </a:fillRef>
+          <a:effectRef idx="2">
+            <a:schemeClr val="accent1"/>
+          </a:effectRef>
+          <a:fontRef idx="minor">
+            <a:schemeClr val="lt1"/>
+          </a:fontRef>
+        </p:style>
+        <p:txBody>
+          <a:bodyPr rtlCol="0" anchor="ctr"/>
+          <a:lstStyle/>
+          <a:p>
+            <a:pPr algn="ctr"/>
+          </a:p>
+        </p:txBody>
+      </p:sp>
+      <p:sp>
+        <p:nvSpPr>
+          <p:cNvPr id="38" name="Rectangle 37"/>
+          <p:cNvSpPr/>
+          <p:nvPr/>
+        </p:nvSpPr>
+        <p:spPr>
+          <a:xfrm>
+            <a:off x="7071055" y="3008738"/>
+            <a:ext cx="1874520" cy="25400"/>
+          </a:xfrm>
+          <a:prstGeom prst="rect">
+            <a:avLst/>
+          </a:prstGeom>
+          <a:solidFill>
+            <a:srgbClr val="6B7280"/>
+          </a:solidFill>
+          <a:ln>
+            <a:noFill/>
+          </a:ln>
+          <a:effectLst/>
+        </p:spPr>
+        <p:style>
+          <a:lnRef idx="1">
+            <a:schemeClr val="accent1"/>
+          </a:lnRef>
+          <a:fillRef idx="3">
+            <a:schemeClr val="accent1"/>
+          </a:fillRef>
+          <a:effectRef idx="2">
+            <a:schemeClr val="accent1"/>
+          </a:effectRef>
+          <a:fontRef idx="minor">
+            <a:schemeClr val="lt1"/>
+          </a:fontRef>
+        </p:style>
+        <p:txBody>
+          <a:bodyPr rtlCol="0" anchor="ctr"/>
+          <a:lstStyle/>
+          <a:p>
+            <a:pPr algn="ctr"/>
+          </a:p>
+        </p:txBody>
+      </p:sp>
+      <p:sp>
+        <p:nvSpPr>
+          <p:cNvPr id="39" name="Rectangle 38"/>
+          <p:cNvSpPr/>
+          <p:nvPr/>
+        </p:nvSpPr>
+        <p:spPr>
+          <a:xfrm>
+            <a:off x="9037015" y="1783080"/>
+            <a:ext cx="1280160" cy="1280160"/>
+          </a:xfrm>
+          <a:prstGeom prst="rect">
+            <a:avLst/>
+          </a:prstGeom>
+          <a:solidFill>
+            <a:srgbClr val="CCFBF1"/>
+          </a:solidFill>
+          <a:ln w="25400">
+            <a:solidFill>
+              <a:srgbClr val="FFFFFF"/>
+            </a:solidFill>
+          </a:ln>
+          <a:effectLst/>
+        </p:spPr>
+        <p:style>
+          <a:lnRef idx="1">
+            <a:schemeClr val="accent1"/>
+          </a:lnRef>
+          <a:fillRef idx="3">
+            <a:schemeClr val="accent1"/>
+          </a:fillRef>
+          <a:effectRef idx="2">
+            <a:schemeClr val="accent1"/>
+          </a:effectRef>
+          <a:fontRef idx="minor">
+            <a:schemeClr val="lt1"/>
+          </a:fontRef>
+        </p:style>
+        <p:txBody>
+          <a:bodyPr rtlCol="0" anchor="ctr"/>
+          <a:lstStyle/>
+          <a:p>
+            <a:pPr algn="ctr"/>
+          </a:p>
+        </p:txBody>
+      </p:sp>
+      <p:sp>
+        <p:nvSpPr>
+          <p:cNvPr id="40" name="Rectangle 39"/>
+          <p:cNvSpPr/>
+          <p:nvPr/>
+        </p:nvSpPr>
+        <p:spPr>
+          <a:xfrm>
+            <a:off x="9311335" y="2057400"/>
+            <a:ext cx="1280160" cy="1280160"/>
+          </a:xfrm>
+          <a:prstGeom prst="rect">
+            <a:avLst/>
+          </a:prstGeom>
+          <a:solidFill>
+            <a:srgbClr val="5EEAD4"/>
+          </a:solidFill>
+          <a:ln w="25400">
+            <a:solidFill>
+              <a:srgbClr val="FFFFFF"/>
+            </a:solidFill>
+          </a:ln>
+          <a:effectLst/>
+        </p:spPr>
+        <p:style>
+          <a:lnRef idx="1">
+            <a:schemeClr val="accent1"/>
+          </a:lnRef>
+          <a:fillRef idx="3">
+            <a:schemeClr val="accent1"/>
+          </a:fillRef>
+          <a:effectRef idx="2">
+            <a:schemeClr val="accent1"/>
+          </a:effectRef>
+          <a:fontRef idx="minor">
+            <a:schemeClr val="lt1"/>
+          </a:fontRef>
+        </p:style>
+        <p:txBody>
+          <a:bodyPr rtlCol="0" anchor="ctr"/>
+          <a:lstStyle/>
+          <a:p>
+            <a:pPr algn="ctr"/>
+          </a:p>
+        </p:txBody>
+      </p:sp>
+      <p:sp>
+        <p:nvSpPr>
+          <p:cNvPr id="41" name="Rectangle 40"/>
+          <p:cNvSpPr/>
+          <p:nvPr/>
+        </p:nvSpPr>
+        <p:spPr>
+          <a:xfrm>
+            <a:off x="9585655" y="2331720"/>
+            <a:ext cx="1280160" cy="1280160"/>
+          </a:xfrm>
+          <a:prstGeom prst="rect">
+            <a:avLst/>
+          </a:prstGeom>
+          <a:solidFill>
+            <a:srgbClr val="0D9488"/>
+          </a:solidFill>
+          <a:ln w="25400">
+            <a:solidFill>
+              <a:srgbClr val="FFFFFF"/>
+            </a:solidFill>
+          </a:ln>
+          <a:effectLst/>
+        </p:spPr>
+        <p:style>
+          <a:lnRef idx="1">
+            <a:schemeClr val="accent1"/>
+          </a:lnRef>
+          <a:fillRef idx="3">
+            <a:schemeClr val="accent1"/>
+          </a:fillRef>
+          <a:effectRef idx="2">
+            <a:schemeClr val="accent1"/>
+          </a:effectRef>
+          <a:fontRef idx="minor">
+            <a:schemeClr val="lt1"/>
+          </a:fontRef>
+        </p:style>
+        <p:txBody>
+          <a:bodyPr rtlCol="0" anchor="ctr"/>
+          <a:lstStyle/>
+          <a:p>
+            <a:pPr algn="ctr"/>
+          </a:p>
+        </p:txBody>
+      </p:sp>
+      <p:sp>
+        <p:nvSpPr>
+          <p:cNvPr id="42" name="TextBox 41"/>
           <p:cNvSpPr txBox="1"/>
           <p:nvPr/>
         </p:nvSpPr>
         <p:spPr>
           <a:xfrm>
+            <a:off x="8854135" y="1325880"/>
+            <a:ext cx="2377440" cy="365760"/>
+          </a:xfrm>
+          <a:prstGeom prst="rect">
+            <a:avLst/>
+          </a:prstGeom>
+          <a:noFill/>
+        </p:spPr>
+        <p:txBody>
+          <a:bodyPr wrap="square" anchor="ctr" lIns="0" rIns="0" tIns="0" bIns="0">
+            <a:spAutoFit/>
+          </a:bodyPr>
+          <a:lstStyle/>
+          <a:p>
+            <a:r>
+              <a:rPr sz="1500" b="1" i="0">
+                <a:solidFill>
+                  <a:srgbClr val="1F2937"/>
+                </a:solidFill>
+                <a:latin typeface="Calibri"/>
+              </a:rPr>
+              <a:t>1 tile ampliado</a:t>
+            </a:r>
+          </a:p>
+        </p:txBody>
+      </p:sp>
+      <p:sp>
+        <p:nvSpPr>
+          <p:cNvPr id="43" name="TextBox 42"/>
+          <p:cNvSpPr txBox="1"/>
+          <p:nvPr/>
+        </p:nvSpPr>
+        <p:spPr>
+          <a:xfrm>
+            <a:off x="8854135" y="3749040"/>
+            <a:ext cx="2834640" cy="1097280"/>
+          </a:xfrm>
+          <a:prstGeom prst="rect">
+            <a:avLst/>
+          </a:prstGeom>
+          <a:noFill/>
+        </p:spPr>
+        <p:txBody>
+          <a:bodyPr wrap="square" anchor="t" lIns="0" rIns="0" tIns="0" bIns="0">
+            <a:spAutoFit/>
+          </a:bodyPr>
+          <a:lstStyle/>
+          <a:p>
+            <a:r>
+              <a:rPr sz="1500" b="0" i="0">
+                <a:solidFill>
+                  <a:srgbClr val="1F2937"/>
+                </a:solidFill>
+                <a:latin typeface="Calibri"/>
+              </a:rPr>
+              <a:t>Partículas superpuestas: el mismo píxel se pinta 3 veces (overdraw)</a:t>
+            </a:r>
+          </a:p>
+        </p:txBody>
+      </p:sp>
+      <p:sp>
+        <p:nvSpPr>
+          <p:cNvPr id="44" name="TextBox 43"/>
+          <p:cNvSpPr txBox="1"/>
+          <p:nvPr/>
+        </p:nvSpPr>
+        <p:spPr>
+          <a:xfrm>
             <a:off x="502920" y="1234440"/>
-            <a:ext cx="6979615" cy="4754880"/>
+            <a:ext cx="5059375" cy="4754880"/>
           </a:xfrm>
           <a:prstGeom prst="rect">
             <a:avLst/>
@@ -6762,26 +8655,27 @@
       </p:sp>
       <p:sp>
         <p:nvSpPr>
-          <p:cNvPr id="13" name="Rectangle 12"/>
+          <p:cNvPr id="13" name="Rounded Rectangle 12"/>
           <p:cNvSpPr/>
           <p:nvPr/>
         </p:nvSpPr>
         <p:spPr>
           <a:xfrm>
-            <a:off x="7756855" y="1234440"/>
-            <a:ext cx="3931920" cy="3657600"/>
-          </a:xfrm>
-          <a:prstGeom prst="rect">
-            <a:avLst/>
+            <a:off x="7116775" y="1234440"/>
+            <a:ext cx="4572000" cy="550926"/>
+          </a:xfrm>
+          <a:prstGeom prst="roundRect">
+            <a:avLst>
+              <a:gd name="adj" fmla="val 20000"/>
+            </a:avLst>
           </a:prstGeom>
           <a:solidFill>
             <a:srgbClr val="F3F4F6"/>
           </a:solidFill>
-          <a:ln>
+          <a:ln w="25400">
             <a:solidFill>
-              <a:srgbClr val="6B7280"/>
+              <a:srgbClr val="0D9488"/>
             </a:solidFill>
-            <a:prstDash val="dash"/>
           </a:ln>
           <a:effectLst/>
         </p:spPr>
@@ -6800,44 +8694,370 @@
           </a:fontRef>
         </p:style>
         <p:txBody>
-          <a:bodyPr rtlCol="0" anchor="ctr" wrap="square" lIns="182880" rIns="182880"/>
+          <a:bodyPr rtlCol="0" anchor="ctr" wrap="square"/>
           <a:lstStyle/>
           <a:p>
             <a:pPr algn="ctr"/>
             <a:r>
-              <a:rPr sz="1300" b="1" i="0">
+              <a:rPr sz="1700" b="1" i="0">
+                <a:solidFill>
+                  <a:srgbClr val="1F2937"/>
+                </a:solidFill>
+                <a:latin typeface="Calibri"/>
+              </a:rPr>
+              <a:t>Uso intenso del chip</a:t>
+            </a:r>
+          </a:p>
+        </p:txBody>
+      </p:sp>
+      <p:sp>
+        <p:nvSpPr>
+          <p:cNvPr id="14" name="Down Arrow 13"/>
+          <p:cNvSpPr/>
+          <p:nvPr/>
+        </p:nvSpPr>
+        <p:spPr>
+          <a:xfrm>
+            <a:off x="9201607" y="1821942"/>
+            <a:ext cx="402336" cy="274320"/>
+          </a:xfrm>
+          <a:prstGeom prst="downArrow">
+            <a:avLst/>
+          </a:prstGeom>
+          <a:solidFill>
+            <a:srgbClr val="6B7280"/>
+          </a:solidFill>
+          <a:ln>
+            <a:noFill/>
+          </a:ln>
+          <a:effectLst/>
+        </p:spPr>
+        <p:style>
+          <a:lnRef idx="1">
+            <a:schemeClr val="accent1"/>
+          </a:lnRef>
+          <a:fillRef idx="3">
+            <a:schemeClr val="accent1"/>
+          </a:fillRef>
+          <a:effectRef idx="2">
+            <a:schemeClr val="accent1"/>
+          </a:effectRef>
+          <a:fontRef idx="minor">
+            <a:schemeClr val="lt1"/>
+          </a:fontRef>
+        </p:style>
+        <p:txBody>
+          <a:bodyPr rtlCol="0" anchor="ctr"/>
+          <a:lstStyle/>
+          <a:p>
+            <a:pPr algn="ctr"/>
+          </a:p>
+        </p:txBody>
+      </p:sp>
+      <p:sp>
+        <p:nvSpPr>
+          <p:cNvPr id="15" name="Rounded Rectangle 14"/>
+          <p:cNvSpPr/>
+          <p:nvPr/>
+        </p:nvSpPr>
+        <p:spPr>
+          <a:xfrm>
+            <a:off x="7116775" y="2132838"/>
+            <a:ext cx="4572000" cy="550926"/>
+          </a:xfrm>
+          <a:prstGeom prst="roundRect">
+            <a:avLst>
+              <a:gd name="adj" fmla="val 20000"/>
+            </a:avLst>
+          </a:prstGeom>
+          <a:solidFill>
+            <a:srgbClr val="F3F4F6"/>
+          </a:solidFill>
+          <a:ln w="25400">
+            <a:solidFill>
+              <a:srgbClr val="D97706"/>
+            </a:solidFill>
+          </a:ln>
+          <a:effectLst/>
+        </p:spPr>
+        <p:style>
+          <a:lnRef idx="1">
+            <a:schemeClr val="accent1"/>
+          </a:lnRef>
+          <a:fillRef idx="3">
+            <a:schemeClr val="accent1"/>
+          </a:fillRef>
+          <a:effectRef idx="2">
+            <a:schemeClr val="accent1"/>
+          </a:effectRef>
+          <a:fontRef idx="minor">
+            <a:schemeClr val="lt1"/>
+          </a:fontRef>
+        </p:style>
+        <p:txBody>
+          <a:bodyPr rtlCol="0" anchor="ctr" wrap="square"/>
+          <a:lstStyle/>
+          <a:p>
+            <a:pPr algn="ctr"/>
+            <a:r>
+              <a:rPr sz="1700" b="1" i="0">
+                <a:solidFill>
+                  <a:srgbClr val="1F2937"/>
+                </a:solidFill>
+                <a:latin typeface="Calibri"/>
+              </a:rPr>
+              <a:t>Sube la temperatura</a:t>
+            </a:r>
+          </a:p>
+        </p:txBody>
+      </p:sp>
+      <p:sp>
+        <p:nvSpPr>
+          <p:cNvPr id="16" name="Down Arrow 15"/>
+          <p:cNvSpPr/>
+          <p:nvPr/>
+        </p:nvSpPr>
+        <p:spPr>
+          <a:xfrm>
+            <a:off x="9201607" y="2720340"/>
+            <a:ext cx="402336" cy="274320"/>
+          </a:xfrm>
+          <a:prstGeom prst="downArrow">
+            <a:avLst/>
+          </a:prstGeom>
+          <a:solidFill>
+            <a:srgbClr val="6B7280"/>
+          </a:solidFill>
+          <a:ln>
+            <a:noFill/>
+          </a:ln>
+          <a:effectLst/>
+        </p:spPr>
+        <p:style>
+          <a:lnRef idx="1">
+            <a:schemeClr val="accent1"/>
+          </a:lnRef>
+          <a:fillRef idx="3">
+            <a:schemeClr val="accent1"/>
+          </a:fillRef>
+          <a:effectRef idx="2">
+            <a:schemeClr val="accent1"/>
+          </a:effectRef>
+          <a:fontRef idx="minor">
+            <a:schemeClr val="lt1"/>
+          </a:fontRef>
+        </p:style>
+        <p:txBody>
+          <a:bodyPr rtlCol="0" anchor="ctr"/>
+          <a:lstStyle/>
+          <a:p>
+            <a:pPr algn="ctr"/>
+          </a:p>
+        </p:txBody>
+      </p:sp>
+      <p:sp>
+        <p:nvSpPr>
+          <p:cNvPr id="17" name="Rounded Rectangle 16"/>
+          <p:cNvSpPr/>
+          <p:nvPr/>
+        </p:nvSpPr>
+        <p:spPr>
+          <a:xfrm>
+            <a:off x="7116775" y="3031236"/>
+            <a:ext cx="4572000" cy="550926"/>
+          </a:xfrm>
+          <a:prstGeom prst="roundRect">
+            <a:avLst>
+              <a:gd name="adj" fmla="val 20000"/>
+            </a:avLst>
+          </a:prstGeom>
+          <a:solidFill>
+            <a:srgbClr val="F3F4F6"/>
+          </a:solidFill>
+          <a:ln w="25400">
+            <a:solidFill>
+              <a:srgbClr val="DC2626"/>
+            </a:solidFill>
+          </a:ln>
+          <a:effectLst/>
+        </p:spPr>
+        <p:style>
+          <a:lnRef idx="1">
+            <a:schemeClr val="accent1"/>
+          </a:lnRef>
+          <a:fillRef idx="3">
+            <a:schemeClr val="accent1"/>
+          </a:fillRef>
+          <a:effectRef idx="2">
+            <a:schemeClr val="accent1"/>
+          </a:effectRef>
+          <a:fontRef idx="minor">
+            <a:schemeClr val="lt1"/>
+          </a:fontRef>
+        </p:style>
+        <p:txBody>
+          <a:bodyPr rtlCol="0" anchor="ctr" wrap="square"/>
+          <a:lstStyle/>
+          <a:p>
+            <a:pPr algn="ctr"/>
+            <a:r>
+              <a:rPr sz="1700" b="1" i="0">
+                <a:solidFill>
+                  <a:srgbClr val="1F2937"/>
+                </a:solidFill>
+                <a:latin typeface="Calibri"/>
+              </a:rPr>
+              <a:t>Throttling: baja la frecuencia</a:t>
+            </a:r>
+          </a:p>
+        </p:txBody>
+      </p:sp>
+      <p:sp>
+        <p:nvSpPr>
+          <p:cNvPr id="18" name="Down Arrow 17"/>
+          <p:cNvSpPr/>
+          <p:nvPr/>
+        </p:nvSpPr>
+        <p:spPr>
+          <a:xfrm>
+            <a:off x="9201607" y="3618738"/>
+            <a:ext cx="402336" cy="274320"/>
+          </a:xfrm>
+          <a:prstGeom prst="downArrow">
+            <a:avLst/>
+          </a:prstGeom>
+          <a:solidFill>
+            <a:srgbClr val="6B7280"/>
+          </a:solidFill>
+          <a:ln>
+            <a:noFill/>
+          </a:ln>
+          <a:effectLst/>
+        </p:spPr>
+        <p:style>
+          <a:lnRef idx="1">
+            <a:schemeClr val="accent1"/>
+          </a:lnRef>
+          <a:fillRef idx="3">
+            <a:schemeClr val="accent1"/>
+          </a:fillRef>
+          <a:effectRef idx="2">
+            <a:schemeClr val="accent1"/>
+          </a:effectRef>
+          <a:fontRef idx="minor">
+            <a:schemeClr val="lt1"/>
+          </a:fontRef>
+        </p:style>
+        <p:txBody>
+          <a:bodyPr rtlCol="0" anchor="ctr"/>
+          <a:lstStyle/>
+          <a:p>
+            <a:pPr algn="ctr"/>
+          </a:p>
+        </p:txBody>
+      </p:sp>
+      <p:sp>
+        <p:nvSpPr>
+          <p:cNvPr id="19" name="Rounded Rectangle 18"/>
+          <p:cNvSpPr/>
+          <p:nvPr/>
+        </p:nvSpPr>
+        <p:spPr>
+          <a:xfrm>
+            <a:off x="7116775" y="3929634"/>
+            <a:ext cx="4572000" cy="550926"/>
+          </a:xfrm>
+          <a:prstGeom prst="roundRect">
+            <a:avLst>
+              <a:gd name="adj" fmla="val 20000"/>
+            </a:avLst>
+          </a:prstGeom>
+          <a:solidFill>
+            <a:srgbClr val="F3F4F6"/>
+          </a:solidFill>
+          <a:ln w="25400">
+            <a:solidFill>
+              <a:srgbClr val="1F2A44"/>
+            </a:solidFill>
+          </a:ln>
+          <a:effectLst/>
+        </p:spPr>
+        <p:style>
+          <a:lnRef idx="1">
+            <a:schemeClr val="accent1"/>
+          </a:lnRef>
+          <a:fillRef idx="3">
+            <a:schemeClr val="accent1"/>
+          </a:fillRef>
+          <a:effectRef idx="2">
+            <a:schemeClr val="accent1"/>
+          </a:effectRef>
+          <a:fontRef idx="minor">
+            <a:schemeClr val="lt1"/>
+          </a:fontRef>
+        </p:style>
+        <p:txBody>
+          <a:bodyPr rtlCol="0" anchor="ctr" wrap="square"/>
+          <a:lstStyle/>
+          <a:p>
+            <a:pPr algn="ctr"/>
+            <a:r>
+              <a:rPr sz="1700" b="1" i="0">
+                <a:solidFill>
+                  <a:srgbClr val="1F2937"/>
+                </a:solidFill>
+                <a:latin typeface="Calibri"/>
+              </a:rPr>
+              <a:t>Caen los fps</a:t>
+            </a:r>
+          </a:p>
+        </p:txBody>
+      </p:sp>
+      <p:sp>
+        <p:nvSpPr>
+          <p:cNvPr id="20" name="TextBox 19"/>
+          <p:cNvSpPr txBox="1"/>
+          <p:nvPr/>
+        </p:nvSpPr>
+        <p:spPr>
+          <a:xfrm>
+            <a:off x="7116775" y="4572000"/>
+            <a:ext cx="4572000" cy="320040"/>
+          </a:xfrm>
+          <a:prstGeom prst="rect">
+            <a:avLst/>
+          </a:prstGeom>
+          <a:noFill/>
+        </p:spPr>
+        <p:txBody>
+          <a:bodyPr wrap="square" anchor="ctr" lIns="0" rIns="0" tIns="0" bIns="0">
+            <a:spAutoFit/>
+          </a:bodyPr>
+          <a:lstStyle/>
+          <a:p>
+            <a:pPr algn="ctr"/>
+            <a:r>
+              <a:rPr sz="1300" b="0" i="1">
                 <a:solidFill>
                   <a:srgbClr val="6B7280"/>
                 </a:solidFill>
                 <a:latin typeface="Calibri"/>
               </a:rPr>
-              <a:t>[IMAGEN SUGERIDA]</a:t>
-            </a:r>
-          </a:p>
-          <a:p>
-            <a:pPr algn="ctr"/>
-            <a:r>
-              <a:rPr sz="1300" b="0" i="1">
-                <a:solidFill>
-                  <a:srgbClr val="6B7280"/>
-                </a:solidFill>
-                <a:latin typeface="Calibri"/>
-              </a:rPr>
-              <a:t>Gráfico de fps en el tiempo que cae a los 8 minutos, superpuesto a una curva de temperatura que sube.</a:t>
-            </a:r>
-          </a:p>
-        </p:txBody>
-      </p:sp>
-      <p:sp>
-        <p:nvSpPr>
-          <p:cNvPr id="14" name="TextBox 13"/>
+              <a:t>Por eso importa el fps del minuto 10</a:t>
+            </a:r>
+          </a:p>
+        </p:txBody>
+      </p:sp>
+      <p:sp>
+        <p:nvSpPr>
+          <p:cNvPr id="21" name="TextBox 20"/>
           <p:cNvSpPr txBox="1"/>
           <p:nvPr/>
         </p:nvSpPr>
         <p:spPr>
           <a:xfrm>
             <a:off x="502920" y="1234440"/>
-            <a:ext cx="6979615" cy="3657600"/>
+            <a:ext cx="6339535" cy="3657600"/>
           </a:xfrm>
           <a:prstGeom prst="rect">
             <a:avLst/>
@@ -7674,26 +9894,27 @@
       </p:sp>
       <p:sp>
         <p:nvSpPr>
-          <p:cNvPr id="9" name="Rectangle 8"/>
+          <p:cNvPr id="9" name="Rounded Rectangle 8"/>
           <p:cNvSpPr/>
           <p:nvPr/>
         </p:nvSpPr>
         <p:spPr>
           <a:xfrm>
-            <a:off x="7756855" y="1234440"/>
-            <a:ext cx="3931920" cy="4754880"/>
-          </a:xfrm>
-          <a:prstGeom prst="rect">
-            <a:avLst/>
+            <a:off x="7116775" y="1513332"/>
+            <a:ext cx="4572000" cy="685800"/>
+          </a:xfrm>
+          <a:prstGeom prst="roundRect">
+            <a:avLst>
+              <a:gd name="adj" fmla="val 20000"/>
+            </a:avLst>
           </a:prstGeom>
           <a:solidFill>
             <a:srgbClr val="F3F4F6"/>
           </a:solidFill>
-          <a:ln>
+          <a:ln w="25400">
             <a:solidFill>
-              <a:srgbClr val="6B7280"/>
+              <a:srgbClr val="0D9488"/>
             </a:solidFill>
-            <a:prstDash val="dash"/>
           </a:ln>
           <a:effectLst/>
         </p:spPr>
@@ -7712,44 +9933,370 @@
           </a:fontRef>
         </p:style>
         <p:txBody>
-          <a:bodyPr rtlCol="0" anchor="ctr" wrap="square" lIns="182880" rIns="182880"/>
+          <a:bodyPr rtlCol="0" anchor="ctr" wrap="square"/>
           <a:lstStyle/>
           <a:p>
             <a:pPr algn="ctr"/>
             <a:r>
-              <a:rPr sz="1300" b="1" i="0">
+              <a:rPr sz="1700" b="1" i="0">
+                <a:solidFill>
+                  <a:srgbClr val="1F2937"/>
+                </a:solidFill>
+                <a:latin typeface="Calibri"/>
+              </a:rPr>
+              <a:t>Jugando</a:t>
+            </a:r>
+          </a:p>
+        </p:txBody>
+      </p:sp>
+      <p:sp>
+        <p:nvSpPr>
+          <p:cNvPr id="10" name="Down Arrow 9"/>
+          <p:cNvSpPr/>
+          <p:nvPr/>
+        </p:nvSpPr>
+        <p:spPr>
+          <a:xfrm>
+            <a:off x="9201607" y="2235708"/>
+            <a:ext cx="402336" cy="274320"/>
+          </a:xfrm>
+          <a:prstGeom prst="downArrow">
+            <a:avLst/>
+          </a:prstGeom>
+          <a:solidFill>
+            <a:srgbClr val="6B7280"/>
+          </a:solidFill>
+          <a:ln>
+            <a:noFill/>
+          </a:ln>
+          <a:effectLst/>
+        </p:spPr>
+        <p:style>
+          <a:lnRef idx="1">
+            <a:schemeClr val="accent1"/>
+          </a:lnRef>
+          <a:fillRef idx="3">
+            <a:schemeClr val="accent1"/>
+          </a:fillRef>
+          <a:effectRef idx="2">
+            <a:schemeClr val="accent1"/>
+          </a:effectRef>
+          <a:fontRef idx="minor">
+            <a:schemeClr val="lt1"/>
+          </a:fontRef>
+        </p:style>
+        <p:txBody>
+          <a:bodyPr rtlCol="0" anchor="ctr"/>
+          <a:lstStyle/>
+          <a:p>
+            <a:pPr algn="ctr"/>
+          </a:p>
+        </p:txBody>
+      </p:sp>
+      <p:sp>
+        <p:nvSpPr>
+          <p:cNvPr id="11" name="Rounded Rectangle 10"/>
+          <p:cNvSpPr/>
+          <p:nvPr/>
+        </p:nvSpPr>
+        <p:spPr>
+          <a:xfrm>
+            <a:off x="7116775" y="2546604"/>
+            <a:ext cx="4572000" cy="685800"/>
+          </a:xfrm>
+          <a:prstGeom prst="roundRect">
+            <a:avLst>
+              <a:gd name="adj" fmla="val 20000"/>
+            </a:avLst>
+          </a:prstGeom>
+          <a:solidFill>
+            <a:srgbClr val="F3F4F6"/>
+          </a:solidFill>
+          <a:ln w="25400">
+            <a:solidFill>
+              <a:srgbClr val="D97706"/>
+            </a:solidFill>
+          </a:ln>
+          <a:effectLst/>
+        </p:spPr>
+        <p:style>
+          <a:lnRef idx="1">
+            <a:schemeClr val="accent1"/>
+          </a:lnRef>
+          <a:fillRef idx="3">
+            <a:schemeClr val="accent1"/>
+          </a:fillRef>
+          <a:effectRef idx="2">
+            <a:schemeClr val="accent1"/>
+          </a:effectRef>
+          <a:fontRef idx="minor">
+            <a:schemeClr val="lt1"/>
+          </a:fontRef>
+        </p:style>
+        <p:txBody>
+          <a:bodyPr rtlCol="0" anchor="ctr" wrap="square"/>
+          <a:lstStyle/>
+          <a:p>
+            <a:pPr algn="ctr"/>
+            <a:r>
+              <a:rPr sz="1700" b="1" i="0">
+                <a:solidFill>
+                  <a:srgbClr val="1F2937"/>
+                </a:solidFill>
+                <a:latin typeface="Calibri"/>
+              </a:rPr>
+              <a:t>Llamada o cambio de app</a:t>
+            </a:r>
+          </a:p>
+        </p:txBody>
+      </p:sp>
+      <p:sp>
+        <p:nvSpPr>
+          <p:cNvPr id="12" name="Down Arrow 11"/>
+          <p:cNvSpPr/>
+          <p:nvPr/>
+        </p:nvSpPr>
+        <p:spPr>
+          <a:xfrm>
+            <a:off x="9201607" y="3268980"/>
+            <a:ext cx="402336" cy="274320"/>
+          </a:xfrm>
+          <a:prstGeom prst="downArrow">
+            <a:avLst/>
+          </a:prstGeom>
+          <a:solidFill>
+            <a:srgbClr val="6B7280"/>
+          </a:solidFill>
+          <a:ln>
+            <a:noFill/>
+          </a:ln>
+          <a:effectLst/>
+        </p:spPr>
+        <p:style>
+          <a:lnRef idx="1">
+            <a:schemeClr val="accent1"/>
+          </a:lnRef>
+          <a:fillRef idx="3">
+            <a:schemeClr val="accent1"/>
+          </a:fillRef>
+          <a:effectRef idx="2">
+            <a:schemeClr val="accent1"/>
+          </a:effectRef>
+          <a:fontRef idx="minor">
+            <a:schemeClr val="lt1"/>
+          </a:fontRef>
+        </p:style>
+        <p:txBody>
+          <a:bodyPr rtlCol="0" anchor="ctr"/>
+          <a:lstStyle/>
+          <a:p>
+            <a:pPr algn="ctr"/>
+          </a:p>
+        </p:txBody>
+      </p:sp>
+      <p:sp>
+        <p:nvSpPr>
+          <p:cNvPr id="13" name="Rounded Rectangle 12"/>
+          <p:cNvSpPr/>
+          <p:nvPr/>
+        </p:nvSpPr>
+        <p:spPr>
+          <a:xfrm>
+            <a:off x="7116775" y="3579876"/>
+            <a:ext cx="4572000" cy="685800"/>
+          </a:xfrm>
+          <a:prstGeom prst="roundRect">
+            <a:avLst>
+              <a:gd name="adj" fmla="val 20000"/>
+            </a:avLst>
+          </a:prstGeom>
+          <a:solidFill>
+            <a:srgbClr val="F3F4F6"/>
+          </a:solidFill>
+          <a:ln w="25400">
+            <a:solidFill>
+              <a:srgbClr val="DC2626"/>
+            </a:solidFill>
+          </a:ln>
+          <a:effectLst/>
+        </p:spPr>
+        <p:style>
+          <a:lnRef idx="1">
+            <a:schemeClr val="accent1"/>
+          </a:lnRef>
+          <a:fillRef idx="3">
+            <a:schemeClr val="accent1"/>
+          </a:fillRef>
+          <a:effectRef idx="2">
+            <a:schemeClr val="accent1"/>
+          </a:effectRef>
+          <a:fontRef idx="minor">
+            <a:schemeClr val="lt1"/>
+          </a:fontRef>
+        </p:style>
+        <p:txBody>
+          <a:bodyPr rtlCol="0" anchor="ctr" wrap="square"/>
+          <a:lstStyle/>
+          <a:p>
+            <a:pPr algn="ctr"/>
+            <a:r>
+              <a:rPr sz="1700" b="1" i="0">
+                <a:solidFill>
+                  <a:srgbClr val="1F2937"/>
+                </a:solidFill>
+                <a:latin typeface="Calibri"/>
+              </a:rPr>
+              <a:t>Segundo plano</a:t>
+            </a:r>
+          </a:p>
+        </p:txBody>
+      </p:sp>
+      <p:sp>
+        <p:nvSpPr>
+          <p:cNvPr id="14" name="Down Arrow 13"/>
+          <p:cNvSpPr/>
+          <p:nvPr/>
+        </p:nvSpPr>
+        <p:spPr>
+          <a:xfrm>
+            <a:off x="9201607" y="4302252"/>
+            <a:ext cx="402336" cy="274320"/>
+          </a:xfrm>
+          <a:prstGeom prst="downArrow">
+            <a:avLst/>
+          </a:prstGeom>
+          <a:solidFill>
+            <a:srgbClr val="6B7280"/>
+          </a:solidFill>
+          <a:ln>
+            <a:noFill/>
+          </a:ln>
+          <a:effectLst/>
+        </p:spPr>
+        <p:style>
+          <a:lnRef idx="1">
+            <a:schemeClr val="accent1"/>
+          </a:lnRef>
+          <a:fillRef idx="3">
+            <a:schemeClr val="accent1"/>
+          </a:fillRef>
+          <a:effectRef idx="2">
+            <a:schemeClr val="accent1"/>
+          </a:effectRef>
+          <a:fontRef idx="minor">
+            <a:schemeClr val="lt1"/>
+          </a:fontRef>
+        </p:style>
+        <p:txBody>
+          <a:bodyPr rtlCol="0" anchor="ctr"/>
+          <a:lstStyle/>
+          <a:p>
+            <a:pPr algn="ctr"/>
+          </a:p>
+        </p:txBody>
+      </p:sp>
+      <p:sp>
+        <p:nvSpPr>
+          <p:cNvPr id="15" name="Rounded Rectangle 14"/>
+          <p:cNvSpPr/>
+          <p:nvPr/>
+        </p:nvSpPr>
+        <p:spPr>
+          <a:xfrm>
+            <a:off x="7116775" y="4613148"/>
+            <a:ext cx="4572000" cy="685800"/>
+          </a:xfrm>
+          <a:prstGeom prst="roundRect">
+            <a:avLst>
+              <a:gd name="adj" fmla="val 20000"/>
+            </a:avLst>
+          </a:prstGeom>
+          <a:solidFill>
+            <a:srgbClr val="F3F4F6"/>
+          </a:solidFill>
+          <a:ln w="25400">
+            <a:solidFill>
+              <a:srgbClr val="1F2A44"/>
+            </a:solidFill>
+          </a:ln>
+          <a:effectLst/>
+        </p:spPr>
+        <p:style>
+          <a:lnRef idx="1">
+            <a:schemeClr val="accent1"/>
+          </a:lnRef>
+          <a:fillRef idx="3">
+            <a:schemeClr val="accent1"/>
+          </a:fillRef>
+          <a:effectRef idx="2">
+            <a:schemeClr val="accent1"/>
+          </a:effectRef>
+          <a:fontRef idx="minor">
+            <a:schemeClr val="lt1"/>
+          </a:fontRef>
+        </p:style>
+        <p:txBody>
+          <a:bodyPr rtlCol="0" anchor="ctr" wrap="square"/>
+          <a:lstStyle/>
+          <a:p>
+            <a:pPr algn="ctr"/>
+            <a:r>
+              <a:rPr sz="1700" b="1" i="0">
+                <a:solidFill>
+                  <a:srgbClr val="1F2937"/>
+                </a:solidFill>
+                <a:latin typeface="Calibri"/>
+              </a:rPr>
+              <a:t>Falta memoria: el sistema cierra el juego</a:t>
+            </a:r>
+          </a:p>
+        </p:txBody>
+      </p:sp>
+      <p:sp>
+        <p:nvSpPr>
+          <p:cNvPr id="16" name="TextBox 15"/>
+          <p:cNvSpPr txBox="1"/>
+          <p:nvPr/>
+        </p:nvSpPr>
+        <p:spPr>
+          <a:xfrm>
+            <a:off x="7116775" y="5390388"/>
+            <a:ext cx="4572000" cy="320040"/>
+          </a:xfrm>
+          <a:prstGeom prst="rect">
+            <a:avLst/>
+          </a:prstGeom>
+          <a:noFill/>
+        </p:spPr>
+        <p:txBody>
+          <a:bodyPr wrap="square" anchor="ctr" lIns="0" rIns="0" tIns="0" bIns="0">
+            <a:spAutoFit/>
+          </a:bodyPr>
+          <a:lstStyle/>
+          <a:p>
+            <a:pPr algn="ctr"/>
+            <a:r>
+              <a:rPr sz="1300" b="0" i="1">
                 <a:solidFill>
                   <a:srgbClr val="6B7280"/>
                 </a:solidFill>
                 <a:latin typeface="Calibri"/>
               </a:rPr>
-              <a:t>[IMAGEN SUGERIDA]</a:t>
-            </a:r>
-          </a:p>
-          <a:p>
-            <a:pPr algn="ctr"/>
-            <a:r>
-              <a:rPr sz="1300" b="0" i="1">
-                <a:solidFill>
-                  <a:srgbClr val="6B7280"/>
-                </a:solidFill>
-                <a:latin typeface="Calibri"/>
-              </a:rPr>
-              <a:t>Diagrama de estados: activa → segundo plano → terminada, con una llamada entrante como disparador.</a:t>
-            </a:r>
-          </a:p>
-        </p:txBody>
-      </p:sp>
-      <p:sp>
-        <p:nvSpPr>
-          <p:cNvPr id="10" name="TextBox 9"/>
+              <a:t>Si no se guardó el estado, la partida se pierde</a:t>
+            </a:r>
+          </a:p>
+        </p:txBody>
+      </p:sp>
+      <p:sp>
+        <p:nvSpPr>
+          <p:cNvPr id="17" name="TextBox 16"/>
           <p:cNvSpPr txBox="1"/>
           <p:nvPr/>
         </p:nvSpPr>
         <p:spPr>
           <a:xfrm>
             <a:off x="502920" y="1234440"/>
-            <a:ext cx="6979615" cy="4754880"/>
+            <a:ext cx="6339535" cy="4754880"/>
           </a:xfrm>
           <a:prstGeom prst="rect">
             <a:avLst/>
@@ -9681,82 +12228,14 @@
       </p:sp>
       <p:sp>
         <p:nvSpPr>
-          <p:cNvPr id="9" name="Rectangle 8"/>
-          <p:cNvSpPr/>
-          <p:nvPr/>
-        </p:nvSpPr>
-        <p:spPr>
-          <a:xfrm>
-            <a:off x="7756855" y="1234440"/>
-            <a:ext cx="3931920" cy="4754880"/>
-          </a:xfrm>
-          <a:prstGeom prst="rect">
-            <a:avLst/>
-          </a:prstGeom>
-          <a:solidFill>
-            <a:srgbClr val="F3F4F6"/>
-          </a:solidFill>
-          <a:ln>
-            <a:solidFill>
-              <a:srgbClr val="6B7280"/>
-            </a:solidFill>
-            <a:prstDash val="dash"/>
-          </a:ln>
-          <a:effectLst/>
-        </p:spPr>
-        <p:style>
-          <a:lnRef idx="1">
-            <a:schemeClr val="accent1"/>
-          </a:lnRef>
-          <a:fillRef idx="3">
-            <a:schemeClr val="accent1"/>
-          </a:fillRef>
-          <a:effectRef idx="2">
-            <a:schemeClr val="accent1"/>
-          </a:effectRef>
-          <a:fontRef idx="minor">
-            <a:schemeClr val="lt1"/>
-          </a:fontRef>
-        </p:style>
-        <p:txBody>
-          <a:bodyPr rtlCol="0" anchor="ctr" wrap="square" lIns="182880" rIns="182880"/>
-          <a:lstStyle/>
-          <a:p>
-            <a:pPr algn="ctr"/>
-            <a:r>
-              <a:rPr sz="1300" b="1" i="0">
-                <a:solidFill>
-                  <a:srgbClr val="6B7280"/>
-                </a:solidFill>
-                <a:latin typeface="Calibri"/>
-              </a:rPr>
-              <a:t>[IMAGEN SUGERIDA]</a:t>
-            </a:r>
-          </a:p>
-          <a:p>
-            <a:pPr algn="ctr"/>
-            <a:r>
-              <a:rPr sz="1300" b="0" i="1">
-                <a:solidFill>
-                  <a:srgbClr val="6B7280"/>
-                </a:solidFill>
-                <a:latin typeface="Calibri"/>
-              </a:rPr>
-              <a:t>Device Simulator con Asteroides en vertical y los asteroides apareciendo fuera de pantalla.</a:t>
-            </a:r>
-          </a:p>
-        </p:txBody>
-      </p:sp>
-      <p:sp>
-        <p:nvSpPr>
-          <p:cNvPr id="10" name="TextBox 9"/>
+          <p:cNvPr id="9" name="TextBox 8"/>
           <p:cNvSpPr txBox="1"/>
           <p:nvPr/>
         </p:nvSpPr>
         <p:spPr>
           <a:xfrm>
             <a:off x="502920" y="1234440"/>
-            <a:ext cx="6979615" cy="4754880"/>
+            <a:ext cx="11185855" cy="4754880"/>
           </a:xfrm>
           <a:prstGeom prst="rect">
             <a:avLst/>
@@ -10259,26 +12738,59 @@
       </p:sp>
       <p:sp>
         <p:nvSpPr>
-          <p:cNvPr id="10" name="Rectangle 9"/>
+          <p:cNvPr id="10" name="TextBox 9"/>
+          <p:cNvSpPr txBox="1"/>
+          <p:nvPr/>
+        </p:nvSpPr>
+        <p:spPr>
+          <a:xfrm>
+            <a:off x="5653735" y="1234440"/>
+            <a:ext cx="6035040" cy="320040"/>
+          </a:xfrm>
+          <a:prstGeom prst="rect">
+            <a:avLst/>
+          </a:prstGeom>
+          <a:noFill/>
+        </p:spPr>
+        <p:txBody>
+          <a:bodyPr wrap="square" anchor="ctr" lIns="0" rIns="0" tIns="0" bIns="0">
+            <a:spAutoFit/>
+          </a:bodyPr>
+          <a:lstStyle/>
+          <a:p>
+            <a:r>
+              <a:rPr sz="1200" b="1" i="0">
+                <a:solidFill>
+                  <a:srgbClr val="6B7280"/>
+                </a:solidFill>
+                <a:latin typeface="Calibri"/>
+              </a:rPr>
+              <a:t>Ship.cs  ·  líneas 61–73</a:t>
+            </a:r>
+          </a:p>
+        </p:txBody>
+      </p:sp>
+      <p:sp>
+        <p:nvSpPr>
+          <p:cNvPr id="11" name="Rounded Rectangle 10"/>
           <p:cNvSpPr/>
           <p:nvPr/>
         </p:nvSpPr>
         <p:spPr>
           <a:xfrm>
-            <a:off x="7756855" y="1234440"/>
-            <a:ext cx="3931920" cy="4206240"/>
-          </a:xfrm>
-          <a:prstGeom prst="rect">
-            <a:avLst/>
+            <a:off x="5653735" y="1600200"/>
+            <a:ext cx="6035040" cy="3840480"/>
+          </a:xfrm>
+          <a:prstGeom prst="roundRect">
+            <a:avLst>
+              <a:gd name="adj" fmla="val 4000"/>
+            </a:avLst>
           </a:prstGeom>
           <a:solidFill>
-            <a:srgbClr val="F3F4F6"/>
+            <a:srgbClr val="0F172A"/>
           </a:solidFill>
           <a:ln>
-            <a:solidFill>
-              <a:srgbClr val="6B7280"/>
-            </a:solidFill>
-            <a:prstDash val="dash"/>
+            <a:noFill/>
           </a:ln>
           <a:effectLst/>
         </p:spPr>
@@ -10297,44 +12809,293 @@
           </a:fontRef>
         </p:style>
         <p:txBody>
-          <a:bodyPr rtlCol="0" anchor="ctr" wrap="square" lIns="182880" rIns="182880"/>
-          <a:lstStyle/>
-          <a:p>
-            <a:pPr algn="ctr"/>
-            <a:r>
-              <a:rPr sz="1300" b="1" i="0">
-                <a:solidFill>
-                  <a:srgbClr val="6B7280"/>
-                </a:solidFill>
-                <a:latin typeface="Calibri"/>
-              </a:rPr>
-              <a:t>[IMAGEN SUGERIDA]</a:t>
-            </a:r>
-          </a:p>
-          <a:p>
-            <a:pPr algn="ctr"/>
-            <a:r>
-              <a:rPr sz="1300" b="0" i="1">
-                <a:solidFill>
-                  <a:srgbClr val="6B7280"/>
-                </a:solidFill>
-                <a:latin typeface="Calibri"/>
-              </a:rPr>
-              <a:t>Fragmento de Ship.cs 61–73 con las tres llamadas a Input.GetKey resaltadas.</a:t>
-            </a:r>
-          </a:p>
-        </p:txBody>
-      </p:sp>
-      <p:sp>
-        <p:nvSpPr>
-          <p:cNvPr id="11" name="TextBox 10"/>
+          <a:bodyPr rtlCol="0" anchor="ctr" wrap="none" lIns="228600"/>
+          <a:lstStyle/>
+          <a:p>
+            <a:pPr algn="l"/>
+            <a:r>
+              <a:rPr sz="1500" b="0" i="0">
+                <a:solidFill>
+                  <a:srgbClr val="64748B"/>
+                </a:solidFill>
+                <a:latin typeface="Consolas"/>
+              </a:rPr>
+              <a:t> 61  </a:t>
+            </a:r>
+            <a:r>
+              <a:rPr sz="1500" b="1" i="0">
+                <a:solidFill>
+                  <a:srgbClr val="D97706"/>
+                </a:solidFill>
+                <a:latin typeface="Consolas"/>
+              </a:rPr>
+              <a:t>if (Input.GetKey(KeyCode.Space) &amp;&amp; canShoot)</a:t>
+            </a:r>
+          </a:p>
+          <a:p>
+            <a:pPr algn="l"/>
+            <a:r>
+              <a:rPr sz="1500" b="0" i="0">
+                <a:solidFill>
+                  <a:srgbClr val="64748B"/>
+                </a:solidFill>
+                <a:latin typeface="Consolas"/>
+              </a:rPr>
+              <a:t> 62  </a:t>
+            </a:r>
+            <a:r>
+              <a:rPr sz="1500" b="0" i="0">
+                <a:solidFill>
+                  <a:srgbClr val="E2E8F0"/>
+                </a:solidFill>
+                <a:latin typeface="Consolas"/>
+              </a:rPr>
+              <a:t>{</a:t>
+            </a:r>
+          </a:p>
+          <a:p>
+            <a:pPr algn="l"/>
+            <a:r>
+              <a:rPr sz="1500" b="0" i="0">
+                <a:solidFill>
+                  <a:srgbClr val="64748B"/>
+                </a:solidFill>
+                <a:latin typeface="Consolas"/>
+              </a:rPr>
+              <a:t> 63  </a:t>
+            </a:r>
+            <a:r>
+              <a:rPr sz="1500" b="0" i="0">
+                <a:solidFill>
+                  <a:srgbClr val="E2E8F0"/>
+                </a:solidFill>
+                <a:latin typeface="Consolas"/>
+              </a:rPr>
+              <a:t>    ShootLaser();</a:t>
+            </a:r>
+          </a:p>
+          <a:p>
+            <a:pPr algn="l"/>
+            <a:r>
+              <a:rPr sz="1500" b="0" i="0">
+                <a:solidFill>
+                  <a:srgbClr val="64748B"/>
+                </a:solidFill>
+                <a:latin typeface="Consolas"/>
+              </a:rPr>
+              <a:t> 64  </a:t>
+            </a:r>
+            <a:r>
+              <a:rPr sz="1500" b="0" i="0">
+                <a:solidFill>
+                  <a:srgbClr val="E2E8F0"/>
+                </a:solidFill>
+                <a:latin typeface="Consolas"/>
+              </a:rPr>
+              <a:t>}</a:t>
+            </a:r>
+          </a:p>
+          <a:p>
+            <a:pPr algn="l"/>
+            <a:r>
+              <a:rPr sz="1500" b="0" i="0">
+                <a:solidFill>
+                  <a:srgbClr val="64748B"/>
+                </a:solidFill>
+                <a:latin typeface="Consolas"/>
+              </a:rPr>
+              <a:t> 65  </a:t>
+            </a:r>
+            <a:r>
+              <a:rPr sz="1500" b="0" i="0">
+                <a:solidFill>
+                  <a:srgbClr val="E2E8F0"/>
+                </a:solidFill>
+                <a:latin typeface="Consolas"/>
+              </a:rPr>
+              <a:t> </a:t>
+            </a:r>
+          </a:p>
+          <a:p>
+            <a:pPr algn="l"/>
+            <a:r>
+              <a:rPr sz="1500" b="0" i="0">
+                <a:solidFill>
+                  <a:srgbClr val="64748B"/>
+                </a:solidFill>
+                <a:latin typeface="Consolas"/>
+              </a:rPr>
+              <a:t> 66  </a:t>
+            </a:r>
+            <a:r>
+              <a:rPr sz="1500" b="1" i="0">
+                <a:solidFill>
+                  <a:srgbClr val="D97706"/>
+                </a:solidFill>
+                <a:latin typeface="Consolas"/>
+              </a:rPr>
+              <a:t>if (Input.GetKey(KeyCode.LeftArrow))</a:t>
+            </a:r>
+          </a:p>
+          <a:p>
+            <a:pPr algn="l"/>
+            <a:r>
+              <a:rPr sz="1500" b="0" i="0">
+                <a:solidFill>
+                  <a:srgbClr val="64748B"/>
+                </a:solidFill>
+                <a:latin typeface="Consolas"/>
+              </a:rPr>
+              <a:t> 67  </a:t>
+            </a:r>
+            <a:r>
+              <a:rPr sz="1500" b="0" i="0">
+                <a:solidFill>
+                  <a:srgbClr val="E2E8F0"/>
+                </a:solidFill>
+                <a:latin typeface="Consolas"/>
+              </a:rPr>
+              <a:t>{</a:t>
+            </a:r>
+          </a:p>
+          <a:p>
+            <a:pPr algn="l"/>
+            <a:r>
+              <a:rPr sz="1500" b="0" i="0">
+                <a:solidFill>
+                  <a:srgbClr val="64748B"/>
+                </a:solidFill>
+                <a:latin typeface="Consolas"/>
+              </a:rPr>
+              <a:t> 68  </a:t>
+            </a:r>
+            <a:r>
+              <a:rPr sz="1500" b="0" i="0">
+                <a:solidFill>
+                  <a:srgbClr val="E2E8F0"/>
+                </a:solidFill>
+                <a:latin typeface="Consolas"/>
+              </a:rPr>
+              <a:t>    MoveLeft();</a:t>
+            </a:r>
+          </a:p>
+          <a:p>
+            <a:pPr algn="l"/>
+            <a:r>
+              <a:rPr sz="1500" b="0" i="0">
+                <a:solidFill>
+                  <a:srgbClr val="64748B"/>
+                </a:solidFill>
+                <a:latin typeface="Consolas"/>
+              </a:rPr>
+              <a:t> 69  </a:t>
+            </a:r>
+            <a:r>
+              <a:rPr sz="1500" b="0" i="0">
+                <a:solidFill>
+                  <a:srgbClr val="E2E8F0"/>
+                </a:solidFill>
+                <a:latin typeface="Consolas"/>
+              </a:rPr>
+              <a:t>}</a:t>
+            </a:r>
+          </a:p>
+          <a:p>
+            <a:pPr algn="l"/>
+            <a:r>
+              <a:rPr sz="1500" b="0" i="0">
+                <a:solidFill>
+                  <a:srgbClr val="64748B"/>
+                </a:solidFill>
+                <a:latin typeface="Consolas"/>
+              </a:rPr>
+              <a:t> 70  </a:t>
+            </a:r>
+            <a:r>
+              <a:rPr sz="1500" b="0" i="0">
+                <a:solidFill>
+                  <a:srgbClr val="E2E8F0"/>
+                </a:solidFill>
+                <a:latin typeface="Consolas"/>
+              </a:rPr>
+              <a:t> </a:t>
+            </a:r>
+          </a:p>
+          <a:p>
+            <a:pPr algn="l"/>
+            <a:r>
+              <a:rPr sz="1500" b="0" i="0">
+                <a:solidFill>
+                  <a:srgbClr val="64748B"/>
+                </a:solidFill>
+                <a:latin typeface="Consolas"/>
+              </a:rPr>
+              <a:t> 71  </a:t>
+            </a:r>
+            <a:r>
+              <a:rPr sz="1500" b="1" i="0">
+                <a:solidFill>
+                  <a:srgbClr val="D97706"/>
+                </a:solidFill>
+                <a:latin typeface="Consolas"/>
+              </a:rPr>
+              <a:t>if (Input.GetKey(KeyCode.RightArrow))</a:t>
+            </a:r>
+          </a:p>
+          <a:p>
+            <a:pPr algn="l"/>
+            <a:r>
+              <a:rPr sz="1500" b="0" i="0">
+                <a:solidFill>
+                  <a:srgbClr val="64748B"/>
+                </a:solidFill>
+                <a:latin typeface="Consolas"/>
+              </a:rPr>
+              <a:t> 72  </a:t>
+            </a:r>
+            <a:r>
+              <a:rPr sz="1500" b="0" i="0">
+                <a:solidFill>
+                  <a:srgbClr val="E2E8F0"/>
+                </a:solidFill>
+                <a:latin typeface="Consolas"/>
+              </a:rPr>
+              <a:t>{</a:t>
+            </a:r>
+          </a:p>
+          <a:p>
+            <a:pPr algn="l"/>
+            <a:r>
+              <a:rPr sz="1500" b="0" i="0">
+                <a:solidFill>
+                  <a:srgbClr val="64748B"/>
+                </a:solidFill>
+                <a:latin typeface="Consolas"/>
+              </a:rPr>
+              <a:t> 73  </a:t>
+            </a:r>
+            <a:r>
+              <a:rPr sz="1500" b="0" i="0">
+                <a:solidFill>
+                  <a:srgbClr val="E2E8F0"/>
+                </a:solidFill>
+                <a:latin typeface="Consolas"/>
+              </a:rPr>
+              <a:t>    MoveRight();</a:t>
+            </a:r>
+          </a:p>
+        </p:txBody>
+      </p:sp>
+      <p:sp>
+        <p:nvSpPr>
+          <p:cNvPr id="12" name="TextBox 11"/>
           <p:cNvSpPr txBox="1"/>
           <p:nvPr/>
         </p:nvSpPr>
         <p:spPr>
           <a:xfrm>
             <a:off x="502920" y="1234440"/>
-            <a:ext cx="6979615" cy="4206240"/>
+            <a:ext cx="4876495" cy="4206240"/>
           </a:xfrm>
           <a:prstGeom prst="rect">
             <a:avLst/>
@@ -10780,8 +13541,8 @@
         </p:nvSpPr>
         <p:spPr>
           <a:xfrm>
-            <a:off x="7756855" y="1234440"/>
-            <a:ext cx="3931920" cy="4754880"/>
+            <a:off x="5013655" y="1920240"/>
+            <a:ext cx="3271393" cy="1840159"/>
           </a:xfrm>
           <a:prstGeom prst="rect">
             <a:avLst/>
@@ -10789,11 +13550,10 @@
           <a:solidFill>
             <a:srgbClr val="F3F4F6"/>
           </a:solidFill>
-          <a:ln>
+          <a:ln w="31750">
             <a:solidFill>
-              <a:srgbClr val="6B7280"/>
+              <a:srgbClr val="1F2A44"/>
             </a:solidFill>
-            <a:prstDash val="dash"/>
           </a:ln>
           <a:effectLst/>
         </p:spPr>
@@ -10812,44 +13572,531 @@
           </a:fontRef>
         </p:style>
         <p:txBody>
-          <a:bodyPr rtlCol="0" anchor="ctr" wrap="square" lIns="182880" rIns="182880"/>
+          <a:bodyPr rtlCol="0" anchor="ctr"/>
           <a:lstStyle/>
           <a:p>
             <a:pPr algn="ctr"/>
-            <a:r>
-              <a:rPr sz="1300" b="1" i="0">
+          </a:p>
+        </p:txBody>
+      </p:sp>
+      <p:sp>
+        <p:nvSpPr>
+          <p:cNvPr id="10" name="Rectangle 9"/>
+          <p:cNvSpPr/>
+          <p:nvPr/>
+        </p:nvSpPr>
+        <p:spPr>
+          <a:xfrm>
+            <a:off x="5177224" y="1627632"/>
+            <a:ext cx="2944255" cy="164592"/>
+          </a:xfrm>
+          <a:prstGeom prst="rect">
+            <a:avLst/>
+          </a:prstGeom>
+          <a:solidFill>
+            <a:srgbClr val="0D9488"/>
+          </a:solidFill>
+          <a:ln>
+            <a:noFill/>
+          </a:ln>
+          <a:effectLst/>
+        </p:spPr>
+        <p:style>
+          <a:lnRef idx="1">
+            <a:schemeClr val="accent1"/>
+          </a:lnRef>
+          <a:fillRef idx="3">
+            <a:schemeClr val="accent1"/>
+          </a:fillRef>
+          <a:effectRef idx="2">
+            <a:schemeClr val="accent1"/>
+          </a:effectRef>
+          <a:fontRef idx="minor">
+            <a:schemeClr val="lt1"/>
+          </a:fontRef>
+        </p:style>
+        <p:txBody>
+          <a:bodyPr rtlCol="0" anchor="ctr"/>
+          <a:lstStyle/>
+          <a:p>
+            <a:pPr algn="ctr"/>
+          </a:p>
+        </p:txBody>
+      </p:sp>
+      <p:sp>
+        <p:nvSpPr>
+          <p:cNvPr id="11" name="TextBox 10"/>
+          <p:cNvSpPr txBox="1"/>
+          <p:nvPr/>
+        </p:nvSpPr>
+        <p:spPr>
+          <a:xfrm>
+            <a:off x="5186311" y="3833551"/>
+            <a:ext cx="2926080" cy="548640"/>
+          </a:xfrm>
+          <a:prstGeom prst="rect">
+            <a:avLst/>
+          </a:prstGeom>
+          <a:noFill/>
+        </p:spPr>
+        <p:txBody>
+          <a:bodyPr wrap="square" anchor="t" lIns="0" rIns="0" tIns="0" bIns="0">
+            <a:spAutoFit/>
+          </a:bodyPr>
+          <a:lstStyle/>
+          <a:p>
+            <a:pPr algn="ctr"/>
+            <a:r>
+              <a:rPr sz="1500" b="1" i="0">
+                <a:solidFill>
+                  <a:srgbClr val="1F2937"/>
+                </a:solidFill>
+                <a:latin typeface="Calibri"/>
+              </a:rPr>
+              <a:t>16:9</a:t>
+            </a:r>
+          </a:p>
+          <a:p>
+            <a:pPr algn="ctr"/>
+            <a:r>
+              <a:rPr sz="1300" b="0" i="0">
                 <a:solidFill>
                   <a:srgbClr val="6B7280"/>
                 </a:solidFill>
                 <a:latin typeface="Calibri"/>
               </a:rPr>
-              <a:t>[IMAGEN SUGERIDA]</a:t>
-            </a:r>
-          </a:p>
+              <a:t>se ven ±8,9 unidades</a:t>
+            </a:r>
+          </a:p>
+        </p:txBody>
+      </p:sp>
+      <p:sp>
+        <p:nvSpPr>
+          <p:cNvPr id="12" name="Rectangle 11"/>
+          <p:cNvSpPr/>
+          <p:nvPr/>
+        </p:nvSpPr>
+        <p:spPr>
+          <a:xfrm>
+            <a:off x="9607663" y="1920240"/>
+            <a:ext cx="1035089" cy="1840159"/>
+          </a:xfrm>
+          <a:prstGeom prst="rect">
+            <a:avLst/>
+          </a:prstGeom>
+          <a:solidFill>
+            <a:srgbClr val="F3F4F6"/>
+          </a:solidFill>
+          <a:ln w="31750">
+            <a:solidFill>
+              <a:srgbClr val="1F2A44"/>
+            </a:solidFill>
+          </a:ln>
+          <a:effectLst/>
+        </p:spPr>
+        <p:style>
+          <a:lnRef idx="1">
+            <a:schemeClr val="accent1"/>
+          </a:lnRef>
+          <a:fillRef idx="3">
+            <a:schemeClr val="accent1"/>
+          </a:fillRef>
+          <a:effectRef idx="2">
+            <a:schemeClr val="accent1"/>
+          </a:effectRef>
+          <a:fontRef idx="minor">
+            <a:schemeClr val="lt1"/>
+          </a:fontRef>
+        </p:style>
+        <p:txBody>
+          <a:bodyPr rtlCol="0" anchor="ctr"/>
+          <a:lstStyle/>
           <a:p>
             <a:pPr algn="ctr"/>
-            <a:r>
-              <a:rPr sz="1300" b="0" i="1">
+          </a:p>
+        </p:txBody>
+      </p:sp>
+      <p:sp>
+        <p:nvSpPr>
+          <p:cNvPr id="13" name="Rectangle 12"/>
+          <p:cNvSpPr/>
+          <p:nvPr/>
+        </p:nvSpPr>
+        <p:spPr>
+          <a:xfrm>
+            <a:off x="8653080" y="1627632"/>
+            <a:ext cx="954583" cy="164592"/>
+          </a:xfrm>
+          <a:prstGeom prst="rect">
+            <a:avLst/>
+          </a:prstGeom>
+          <a:solidFill>
+            <a:srgbClr val="DC2626"/>
+          </a:solidFill>
+          <a:ln>
+            <a:solidFill>
+              <a:srgbClr val="FFFFFF"/>
+            </a:solidFill>
+          </a:ln>
+          <a:effectLst/>
+        </p:spPr>
+        <p:style>
+          <a:lnRef idx="1">
+            <a:schemeClr val="accent1"/>
+          </a:lnRef>
+          <a:fillRef idx="3">
+            <a:schemeClr val="accent1"/>
+          </a:fillRef>
+          <a:effectRef idx="2">
+            <a:schemeClr val="accent1"/>
+          </a:effectRef>
+          <a:fontRef idx="minor">
+            <a:schemeClr val="lt1"/>
+          </a:fontRef>
+        </p:style>
+        <p:txBody>
+          <a:bodyPr rtlCol="0" anchor="ctr"/>
+          <a:lstStyle/>
+          <a:p>
+            <a:pPr algn="ctr"/>
+          </a:p>
+        </p:txBody>
+      </p:sp>
+      <p:sp>
+        <p:nvSpPr>
+          <p:cNvPr id="14" name="Rectangle 13"/>
+          <p:cNvSpPr/>
+          <p:nvPr/>
+        </p:nvSpPr>
+        <p:spPr>
+          <a:xfrm>
+            <a:off x="9607663" y="1627632"/>
+            <a:ext cx="1035089" cy="164592"/>
+          </a:xfrm>
+          <a:prstGeom prst="rect">
+            <a:avLst/>
+          </a:prstGeom>
+          <a:solidFill>
+            <a:srgbClr val="0D9488"/>
+          </a:solidFill>
+          <a:ln>
+            <a:noFill/>
+          </a:ln>
+          <a:effectLst/>
+        </p:spPr>
+        <p:style>
+          <a:lnRef idx="1">
+            <a:schemeClr val="accent1"/>
+          </a:lnRef>
+          <a:fillRef idx="3">
+            <a:schemeClr val="accent1"/>
+          </a:fillRef>
+          <a:effectRef idx="2">
+            <a:schemeClr val="accent1"/>
+          </a:effectRef>
+          <a:fontRef idx="minor">
+            <a:schemeClr val="lt1"/>
+          </a:fontRef>
+        </p:style>
+        <p:txBody>
+          <a:bodyPr rtlCol="0" anchor="ctr"/>
+          <a:lstStyle/>
+          <a:p>
+            <a:pPr algn="ctr"/>
+          </a:p>
+        </p:txBody>
+      </p:sp>
+      <p:sp>
+        <p:nvSpPr>
+          <p:cNvPr id="15" name="Rectangle 14"/>
+          <p:cNvSpPr/>
+          <p:nvPr/>
+        </p:nvSpPr>
+        <p:spPr>
+          <a:xfrm>
+            <a:off x="10642752" y="1627632"/>
+            <a:ext cx="954583" cy="164592"/>
+          </a:xfrm>
+          <a:prstGeom prst="rect">
+            <a:avLst/>
+          </a:prstGeom>
+          <a:solidFill>
+            <a:srgbClr val="DC2626"/>
+          </a:solidFill>
+          <a:ln>
+            <a:noFill/>
+          </a:ln>
+          <a:effectLst/>
+        </p:spPr>
+        <p:style>
+          <a:lnRef idx="1">
+            <a:schemeClr val="accent1"/>
+          </a:lnRef>
+          <a:fillRef idx="3">
+            <a:schemeClr val="accent1"/>
+          </a:fillRef>
+          <a:effectRef idx="2">
+            <a:schemeClr val="accent1"/>
+          </a:effectRef>
+          <a:fontRef idx="minor">
+            <a:schemeClr val="lt1"/>
+          </a:fontRef>
+        </p:style>
+        <p:txBody>
+          <a:bodyPr rtlCol="0" anchor="ctr"/>
+          <a:lstStyle/>
+          <a:p>
+            <a:pPr algn="ctr"/>
+          </a:p>
+        </p:txBody>
+      </p:sp>
+      <p:sp>
+        <p:nvSpPr>
+          <p:cNvPr id="16" name="TextBox 15"/>
+          <p:cNvSpPr txBox="1"/>
+          <p:nvPr/>
+        </p:nvSpPr>
+        <p:spPr>
+          <a:xfrm>
+            <a:off x="8662167" y="3833551"/>
+            <a:ext cx="2926080" cy="548640"/>
+          </a:xfrm>
+          <a:prstGeom prst="rect">
+            <a:avLst/>
+          </a:prstGeom>
+          <a:noFill/>
+        </p:spPr>
+        <p:txBody>
+          <a:bodyPr wrap="square" anchor="t" lIns="0" rIns="0" tIns="0" bIns="0">
+            <a:spAutoFit/>
+          </a:bodyPr>
+          <a:lstStyle/>
+          <a:p>
+            <a:pPr algn="ctr"/>
+            <a:r>
+              <a:rPr sz="1500" b="1" i="0">
+                <a:solidFill>
+                  <a:srgbClr val="1F2937"/>
+                </a:solidFill>
+                <a:latin typeface="Calibri"/>
+              </a:rPr>
+              <a:t>9:16</a:t>
+            </a:r>
+          </a:p>
+          <a:p>
+            <a:pPr algn="ctr"/>
+            <a:r>
+              <a:rPr sz="1300" b="0" i="0">
                 <a:solidFill>
                   <a:srgbClr val="6B7280"/>
                 </a:solidFill>
                 <a:latin typeface="Calibri"/>
               </a:rPr>
-              <a:t>Dos capturas lado a lado, 16:9 y 9:16, con el rango de spawn [−8, 8] marcado sobre cada una.</a:t>
-            </a:r>
-          </a:p>
-        </p:txBody>
-      </p:sp>
-      <p:sp>
-        <p:nvSpPr>
-          <p:cNvPr id="10" name="TextBox 9"/>
+              <a:t>se ven ±2,8 unidades</a:t>
+            </a:r>
+          </a:p>
+        </p:txBody>
+      </p:sp>
+      <p:sp>
+        <p:nvSpPr>
+          <p:cNvPr id="17" name="Rectangle 16"/>
+          <p:cNvSpPr/>
+          <p:nvPr/>
+        </p:nvSpPr>
+        <p:spPr>
+          <a:xfrm>
+            <a:off x="5013655" y="5404104"/>
+            <a:ext cx="320040" cy="164592"/>
+          </a:xfrm>
+          <a:prstGeom prst="rect">
+            <a:avLst/>
+          </a:prstGeom>
+          <a:solidFill>
+            <a:srgbClr val="0D9488"/>
+          </a:solidFill>
+          <a:ln>
+            <a:noFill/>
+          </a:ln>
+          <a:effectLst/>
+        </p:spPr>
+        <p:style>
+          <a:lnRef idx="1">
+            <a:schemeClr val="accent1"/>
+          </a:lnRef>
+          <a:fillRef idx="3">
+            <a:schemeClr val="accent1"/>
+          </a:fillRef>
+          <a:effectRef idx="2">
+            <a:schemeClr val="accent1"/>
+          </a:effectRef>
+          <a:fontRef idx="minor">
+            <a:schemeClr val="lt1"/>
+          </a:fontRef>
+        </p:style>
+        <p:txBody>
+          <a:bodyPr rtlCol="0" anchor="ctr"/>
+          <a:lstStyle/>
+          <a:p>
+            <a:pPr algn="ctr"/>
+          </a:p>
+        </p:txBody>
+      </p:sp>
+      <p:sp>
+        <p:nvSpPr>
+          <p:cNvPr id="18" name="TextBox 17"/>
           <p:cNvSpPr txBox="1"/>
           <p:nvPr/>
         </p:nvSpPr>
         <p:spPr>
           <a:xfrm>
+            <a:off x="5425135" y="5349240"/>
+            <a:ext cx="2926080" cy="274320"/>
+          </a:xfrm>
+          <a:prstGeom prst="rect">
+            <a:avLst/>
+          </a:prstGeom>
+          <a:noFill/>
+        </p:spPr>
+        <p:txBody>
+          <a:bodyPr wrap="square" anchor="ctr" lIns="0" rIns="0" tIns="0" bIns="0">
+            <a:spAutoFit/>
+          </a:bodyPr>
+          <a:lstStyle/>
+          <a:p>
+            <a:r>
+              <a:rPr sz="1300" b="0" i="0">
+                <a:solidFill>
+                  <a:srgbClr val="1F2937"/>
+                </a:solidFill>
+                <a:latin typeface="Calibri"/>
+              </a:rPr>
+              <a:t>spawn dentro de la pantalla</a:t>
+            </a:r>
+          </a:p>
+        </p:txBody>
+      </p:sp>
+      <p:sp>
+        <p:nvSpPr>
+          <p:cNvPr id="19" name="Rectangle 18"/>
+          <p:cNvSpPr/>
+          <p:nvPr/>
+        </p:nvSpPr>
+        <p:spPr>
+          <a:xfrm>
+            <a:off x="8214055" y="5404104"/>
+            <a:ext cx="320040" cy="164592"/>
+          </a:xfrm>
+          <a:prstGeom prst="rect">
+            <a:avLst/>
+          </a:prstGeom>
+          <a:solidFill>
+            <a:srgbClr val="DC2626"/>
+          </a:solidFill>
+          <a:ln>
+            <a:noFill/>
+          </a:ln>
+          <a:effectLst/>
+        </p:spPr>
+        <p:style>
+          <a:lnRef idx="1">
+            <a:schemeClr val="accent1"/>
+          </a:lnRef>
+          <a:fillRef idx="3">
+            <a:schemeClr val="accent1"/>
+          </a:fillRef>
+          <a:effectRef idx="2">
+            <a:schemeClr val="accent1"/>
+          </a:effectRef>
+          <a:fontRef idx="minor">
+            <a:schemeClr val="lt1"/>
+          </a:fontRef>
+        </p:style>
+        <p:txBody>
+          <a:bodyPr rtlCol="0" anchor="ctr"/>
+          <a:lstStyle/>
+          <a:p>
+            <a:pPr algn="ctr"/>
+          </a:p>
+        </p:txBody>
+      </p:sp>
+      <p:sp>
+        <p:nvSpPr>
+          <p:cNvPr id="20" name="TextBox 19"/>
+          <p:cNvSpPr txBox="1"/>
+          <p:nvPr/>
+        </p:nvSpPr>
+        <p:spPr>
+          <a:xfrm>
+            <a:off x="8625535" y="5349240"/>
+            <a:ext cx="2926080" cy="274320"/>
+          </a:xfrm>
+          <a:prstGeom prst="rect">
+            <a:avLst/>
+          </a:prstGeom>
+          <a:noFill/>
+        </p:spPr>
+        <p:txBody>
+          <a:bodyPr wrap="square" anchor="ctr" lIns="0" rIns="0" tIns="0" bIns="0">
+            <a:spAutoFit/>
+          </a:bodyPr>
+          <a:lstStyle/>
+          <a:p>
+            <a:r>
+              <a:rPr sz="1300" b="0" i="0">
+                <a:solidFill>
+                  <a:srgbClr val="1F2937"/>
+                </a:solidFill>
+                <a:latin typeface="Calibri"/>
+              </a:rPr>
+              <a:t>spawn fuera de la pantalla</a:t>
+            </a:r>
+          </a:p>
+        </p:txBody>
+      </p:sp>
+      <p:sp>
+        <p:nvSpPr>
+          <p:cNvPr id="21" name="TextBox 20"/>
+          <p:cNvSpPr txBox="1"/>
+          <p:nvPr/>
+        </p:nvSpPr>
+        <p:spPr>
+          <a:xfrm>
+            <a:off x="5013655" y="5669280"/>
+            <a:ext cx="6766560" cy="274320"/>
+          </a:xfrm>
+          <a:prstGeom prst="rect">
+            <a:avLst/>
+          </a:prstGeom>
+          <a:noFill/>
+        </p:spPr>
+        <p:txBody>
+          <a:bodyPr wrap="square" anchor="ctr" lIns="0" rIns="0" tIns="0" bIns="0">
+            <a:spAutoFit/>
+          </a:bodyPr>
+          <a:lstStyle/>
+          <a:p>
+            <a:r>
+              <a:rPr sz="1100" b="0" i="1">
+                <a:solidFill>
+                  <a:srgbClr val="6B7280"/>
+                </a:solidFill>
+                <a:latin typeface="Calibri"/>
+              </a:rPr>
+              <a:t>Escala real: cámara ortográfica de tamaño 5; spawn en x ∈ [-8, 8]</a:t>
+            </a:r>
+          </a:p>
+        </p:txBody>
+      </p:sp>
+      <p:sp>
+        <p:nvSpPr>
+          <p:cNvPr id="22" name="TextBox 21"/>
+          <p:cNvSpPr txBox="1"/>
+          <p:nvPr/>
+        </p:nvSpPr>
+        <p:spPr>
+          <a:xfrm>
             <a:off x="502920" y="1234440"/>
-            <a:ext cx="6979615" cy="4754880"/>
+            <a:ext cx="4144975" cy="4754880"/>
           </a:xfrm>
           <a:prstGeom prst="rect">
             <a:avLst/>
@@ -11930,82 +15177,14 @@
       </p:sp>
       <p:sp>
         <p:nvSpPr>
-          <p:cNvPr id="10" name="Rectangle 9"/>
-          <p:cNvSpPr/>
-          <p:nvPr/>
-        </p:nvSpPr>
-        <p:spPr>
-          <a:xfrm>
-            <a:off x="7756855" y="1234440"/>
-            <a:ext cx="3931920" cy="4206240"/>
-          </a:xfrm>
-          <a:prstGeom prst="rect">
-            <a:avLst/>
-          </a:prstGeom>
-          <a:solidFill>
-            <a:srgbClr val="F3F4F6"/>
-          </a:solidFill>
-          <a:ln>
-            <a:solidFill>
-              <a:srgbClr val="6B7280"/>
-            </a:solidFill>
-            <a:prstDash val="dash"/>
-          </a:ln>
-          <a:effectLst/>
-        </p:spPr>
-        <p:style>
-          <a:lnRef idx="1">
-            <a:schemeClr val="accent1"/>
-          </a:lnRef>
-          <a:fillRef idx="3">
-            <a:schemeClr val="accent1"/>
-          </a:fillRef>
-          <a:effectRef idx="2">
-            <a:schemeClr val="accent1"/>
-          </a:effectRef>
-          <a:fontRef idx="minor">
-            <a:schemeClr val="lt1"/>
-          </a:fontRef>
-        </p:style>
-        <p:txBody>
-          <a:bodyPr rtlCol="0" anchor="ctr" wrap="square" lIns="182880" rIns="182880"/>
-          <a:lstStyle/>
-          <a:p>
-            <a:pPr algn="ctr"/>
-            <a:r>
-              <a:rPr sz="1300" b="1" i="0">
-                <a:solidFill>
-                  <a:srgbClr val="6B7280"/>
-                </a:solidFill>
-                <a:latin typeface="Calibri"/>
-              </a:rPr>
-              <a:t>[IMAGEN SUGERIDA]</a:t>
-            </a:r>
-          </a:p>
-          <a:p>
-            <a:pPr algn="ctr"/>
-            <a:r>
-              <a:rPr sz="1300" b="0" i="1">
-                <a:solidFill>
-                  <a:srgbClr val="6B7280"/>
-                </a:solidFill>
-                <a:latin typeface="Calibri"/>
-              </a:rPr>
-              <a:t>Captura del juego con tres íconos superpuestos: termómetro, batería baja y llamada entrante.</a:t>
-            </a:r>
-          </a:p>
-        </p:txBody>
-      </p:sp>
-      <p:sp>
-        <p:nvSpPr>
-          <p:cNvPr id="11" name="TextBox 10"/>
+          <p:cNvPr id="10" name="TextBox 9"/>
           <p:cNvSpPr txBox="1"/>
           <p:nvPr/>
         </p:nvSpPr>
         <p:spPr>
           <a:xfrm>
             <a:off x="502920" y="1234440"/>
-            <a:ext cx="6979615" cy="4206240"/>
+            <a:ext cx="11185855" cy="4206240"/>
           </a:xfrm>
           <a:prstGeom prst="rect">
             <a:avLst/>
@@ -13064,7 +16243,7 @@
                 </a:solidFill>
                 <a:latin typeface="Calibri"/>
               </a:rPr>
-              <a:t>Eso se mide en su teléfono (Clase 4)</a:t>
+              <a:t>Eso se mide en su teléfono</a:t>
             </a:r>
           </a:p>
           <a:p>
@@ -19783,26 +22962,62 @@
       </p:sp>
       <p:sp>
         <p:nvSpPr>
-          <p:cNvPr id="9" name="Rectangle 8"/>
+          <p:cNvPr id="9" name="TextBox 8"/>
+          <p:cNvSpPr txBox="1"/>
+          <p:nvPr/>
+        </p:nvSpPr>
+        <p:spPr>
+          <a:xfrm>
+            <a:off x="6019495" y="1234440"/>
+            <a:ext cx="2697480" cy="411480"/>
+          </a:xfrm>
+          <a:prstGeom prst="rect">
+            <a:avLst/>
+          </a:prstGeom>
+          <a:noFill/>
+        </p:spPr>
+        <p:txBody>
+          <a:bodyPr wrap="square" anchor="ctr" lIns="0" rIns="0" tIns="0" bIns="0">
+            <a:spAutoFit/>
+          </a:bodyPr>
+          <a:lstStyle/>
+          <a:p>
+            <a:pPr algn="ctr"/>
+            <a:r>
+              <a:rPr sz="1600" b="1" i="0">
+                <a:solidFill>
+                  <a:srgbClr val="0D9488"/>
+                </a:solidFill>
+                <a:latin typeface="Calibri"/>
+              </a:rPr>
+              <a:t>TELÉFONO</a:t>
+            </a:r>
+          </a:p>
+        </p:txBody>
+      </p:sp>
+      <p:sp>
+        <p:nvSpPr>
+          <p:cNvPr id="10" name="Rounded Rectangle 9"/>
           <p:cNvSpPr/>
           <p:nvPr/>
         </p:nvSpPr>
         <p:spPr>
           <a:xfrm>
-            <a:off x="7756855" y="1234440"/>
-            <a:ext cx="3931920" cy="4754880"/>
-          </a:xfrm>
-          <a:prstGeom prst="rect">
-            <a:avLst/>
+            <a:off x="6019495" y="1737360"/>
+            <a:ext cx="2697480" cy="3520440"/>
+          </a:xfrm>
+          <a:prstGeom prst="roundRect">
+            <a:avLst>
+              <a:gd name="adj" fmla="val 8000"/>
+            </a:avLst>
           </a:prstGeom>
           <a:solidFill>
             <a:srgbClr val="F3F4F6"/>
           </a:solidFill>
-          <a:ln>
+          <a:ln w="31750">
             <a:solidFill>
-              <a:srgbClr val="6B7280"/>
+              <a:srgbClr val="0D9488"/>
             </a:solidFill>
-            <a:prstDash val="dash"/>
           </a:ln>
           <a:effectLst/>
         </p:spPr>
@@ -19821,44 +23036,446 @@
           </a:fontRef>
         </p:style>
         <p:txBody>
-          <a:bodyPr rtlCol="0" anchor="ctr" wrap="square" lIns="182880" rIns="182880"/>
+          <a:bodyPr rtlCol="0" anchor="ctr"/>
           <a:lstStyle/>
           <a:p>
             <a:pPr algn="ctr"/>
-            <a:r>
-              <a:rPr sz="1300" b="1" i="0">
-                <a:solidFill>
-                  <a:srgbClr val="6B7280"/>
-                </a:solidFill>
-                <a:latin typeface="Calibri"/>
-              </a:rPr>
-              <a:t>[IMAGEN SUGERIDA]</a:t>
-            </a:r>
-          </a:p>
+          </a:p>
+        </p:txBody>
+      </p:sp>
+      <p:sp>
+        <p:nvSpPr>
+          <p:cNvPr id="11" name="Rounded Rectangle 10"/>
+          <p:cNvSpPr/>
+          <p:nvPr/>
+        </p:nvSpPr>
+        <p:spPr>
+          <a:xfrm>
+            <a:off x="6293815" y="2670048"/>
+            <a:ext cx="2148840" cy="502920"/>
+          </a:xfrm>
+          <a:prstGeom prst="roundRect">
+            <a:avLst/>
+          </a:prstGeom>
+          <a:solidFill>
+            <a:srgbClr val="0D9488"/>
+          </a:solidFill>
+          <a:ln>
+            <a:noFill/>
+          </a:ln>
+          <a:effectLst/>
+        </p:spPr>
+        <p:style>
+          <a:lnRef idx="1">
+            <a:schemeClr val="accent1"/>
+          </a:lnRef>
+          <a:fillRef idx="3">
+            <a:schemeClr val="accent1"/>
+          </a:fillRef>
+          <a:effectRef idx="2">
+            <a:schemeClr val="accent1"/>
+          </a:effectRef>
+          <a:fontRef idx="minor">
+            <a:schemeClr val="lt1"/>
+          </a:fontRef>
+        </p:style>
+        <p:txBody>
+          <a:bodyPr rtlCol="0" anchor="ctr"/>
+          <a:lstStyle/>
           <a:p>
             <a:pPr algn="ctr"/>
             <a:r>
-              <a:rPr sz="1300" b="0" i="1">
-                <a:solidFill>
-                  <a:srgbClr val="6B7280"/>
-                </a:solidFill>
-                <a:latin typeface="Calibri"/>
-              </a:rPr>
-              <a:t>Diagrama de bloques: SoC del teléfono (CPU+GPU+memoria juntos) vs. PC (CPU, GPU dedicada y RAM separadas, con ventiladores).</a:t>
-            </a:r>
-          </a:p>
-        </p:txBody>
-      </p:sp>
-      <p:sp>
-        <p:nvSpPr>
-          <p:cNvPr id="10" name="TextBox 9"/>
+              <a:rPr sz="1500" b="1" i="0">
+                <a:solidFill>
+                  <a:srgbClr val="FFFFFF"/>
+                </a:solidFill>
+                <a:latin typeface="Calibri"/>
+              </a:rPr>
+              <a:t>CPU</a:t>
+            </a:r>
+          </a:p>
+        </p:txBody>
+      </p:sp>
+      <p:sp>
+        <p:nvSpPr>
+          <p:cNvPr id="12" name="Rounded Rectangle 11"/>
+          <p:cNvSpPr/>
+          <p:nvPr/>
+        </p:nvSpPr>
+        <p:spPr>
+          <a:xfrm>
+            <a:off x="6293815" y="3246120"/>
+            <a:ext cx="2148840" cy="502920"/>
+          </a:xfrm>
+          <a:prstGeom prst="roundRect">
+            <a:avLst/>
+          </a:prstGeom>
+          <a:solidFill>
+            <a:srgbClr val="0D9488"/>
+          </a:solidFill>
+          <a:ln>
+            <a:noFill/>
+          </a:ln>
+          <a:effectLst/>
+        </p:spPr>
+        <p:style>
+          <a:lnRef idx="1">
+            <a:schemeClr val="accent1"/>
+          </a:lnRef>
+          <a:fillRef idx="3">
+            <a:schemeClr val="accent1"/>
+          </a:fillRef>
+          <a:effectRef idx="2">
+            <a:schemeClr val="accent1"/>
+          </a:effectRef>
+          <a:fontRef idx="minor">
+            <a:schemeClr val="lt1"/>
+          </a:fontRef>
+        </p:style>
+        <p:txBody>
+          <a:bodyPr rtlCol="0" anchor="ctr"/>
+          <a:lstStyle/>
+          <a:p>
+            <a:pPr algn="ctr"/>
+            <a:r>
+              <a:rPr sz="1500" b="1" i="0">
+                <a:solidFill>
+                  <a:srgbClr val="FFFFFF"/>
+                </a:solidFill>
+                <a:latin typeface="Calibri"/>
+              </a:rPr>
+              <a:t>GPU</a:t>
+            </a:r>
+          </a:p>
+        </p:txBody>
+      </p:sp>
+      <p:sp>
+        <p:nvSpPr>
+          <p:cNvPr id="13" name="Rounded Rectangle 12"/>
+          <p:cNvSpPr/>
+          <p:nvPr/>
+        </p:nvSpPr>
+        <p:spPr>
+          <a:xfrm>
+            <a:off x="6293815" y="3822192"/>
+            <a:ext cx="2148840" cy="502920"/>
+          </a:xfrm>
+          <a:prstGeom prst="roundRect">
+            <a:avLst/>
+          </a:prstGeom>
+          <a:solidFill>
+            <a:srgbClr val="0D9488"/>
+          </a:solidFill>
+          <a:ln>
+            <a:noFill/>
+          </a:ln>
+          <a:effectLst/>
+        </p:spPr>
+        <p:style>
+          <a:lnRef idx="1">
+            <a:schemeClr val="accent1"/>
+          </a:lnRef>
+          <a:fillRef idx="3">
+            <a:schemeClr val="accent1"/>
+          </a:fillRef>
+          <a:effectRef idx="2">
+            <a:schemeClr val="accent1"/>
+          </a:effectRef>
+          <a:fontRef idx="minor">
+            <a:schemeClr val="lt1"/>
+          </a:fontRef>
+        </p:style>
+        <p:txBody>
+          <a:bodyPr rtlCol="0" anchor="ctr"/>
+          <a:lstStyle/>
+          <a:p>
+            <a:pPr algn="ctr"/>
+            <a:r>
+              <a:rPr sz="1500" b="1" i="0">
+                <a:solidFill>
+                  <a:srgbClr val="FFFFFF"/>
+                </a:solidFill>
+                <a:latin typeface="Calibri"/>
+              </a:rPr>
+              <a:t>Memoria</a:t>
+            </a:r>
+          </a:p>
+        </p:txBody>
+      </p:sp>
+      <p:sp>
+        <p:nvSpPr>
+          <p:cNvPr id="14" name="TextBox 13"/>
           <p:cNvSpPr txBox="1"/>
           <p:nvPr/>
         </p:nvSpPr>
         <p:spPr>
           <a:xfrm>
+            <a:off x="6019495" y="5349240"/>
+            <a:ext cx="2697480" cy="640080"/>
+          </a:xfrm>
+          <a:prstGeom prst="rect">
+            <a:avLst/>
+          </a:prstGeom>
+          <a:noFill/>
+        </p:spPr>
+        <p:txBody>
+          <a:bodyPr wrap="square" anchor="t" lIns="0" rIns="0" tIns="0" bIns="0">
+            <a:spAutoFit/>
+          </a:bodyPr>
+          <a:lstStyle/>
+          <a:p>
+            <a:pPr algn="ctr"/>
+            <a:r>
+              <a:rPr sz="1400" b="0" i="0">
+                <a:solidFill>
+                  <a:srgbClr val="1F2937"/>
+                </a:solidFill>
+                <a:latin typeface="Calibri"/>
+              </a:rPr>
+              <a:t>Un solo chip (SoC), sin ventilador</a:t>
+            </a:r>
+          </a:p>
+        </p:txBody>
+      </p:sp>
+      <p:sp>
+        <p:nvSpPr>
+          <p:cNvPr id="15" name="TextBox 14"/>
+          <p:cNvSpPr txBox="1"/>
+          <p:nvPr/>
+        </p:nvSpPr>
+        <p:spPr>
+          <a:xfrm>
+            <a:off x="8991295" y="1234440"/>
+            <a:ext cx="2697480" cy="411480"/>
+          </a:xfrm>
+          <a:prstGeom prst="rect">
+            <a:avLst/>
+          </a:prstGeom>
+          <a:noFill/>
+        </p:spPr>
+        <p:txBody>
+          <a:bodyPr wrap="square" anchor="ctr" lIns="0" rIns="0" tIns="0" bIns="0">
+            <a:spAutoFit/>
+          </a:bodyPr>
+          <a:lstStyle/>
+          <a:p>
+            <a:pPr algn="ctr"/>
+            <a:r>
+              <a:rPr sz="1600" b="1" i="0">
+                <a:solidFill>
+                  <a:srgbClr val="1F2A44"/>
+                </a:solidFill>
+                <a:latin typeface="Calibri"/>
+              </a:rPr>
+              <a:t>PC</a:t>
+            </a:r>
+          </a:p>
+        </p:txBody>
+      </p:sp>
+      <p:sp>
+        <p:nvSpPr>
+          <p:cNvPr id="16" name="Rounded Rectangle 15"/>
+          <p:cNvSpPr/>
+          <p:nvPr/>
+        </p:nvSpPr>
+        <p:spPr>
+          <a:xfrm>
+            <a:off x="9265615" y="2423160"/>
+            <a:ext cx="2148840" cy="502920"/>
+          </a:xfrm>
+          <a:prstGeom prst="roundRect">
+            <a:avLst/>
+          </a:prstGeom>
+          <a:solidFill>
+            <a:srgbClr val="1F2A44"/>
+          </a:solidFill>
+          <a:ln>
+            <a:noFill/>
+          </a:ln>
+          <a:effectLst/>
+        </p:spPr>
+        <p:style>
+          <a:lnRef idx="1">
+            <a:schemeClr val="accent1"/>
+          </a:lnRef>
+          <a:fillRef idx="3">
+            <a:schemeClr val="accent1"/>
+          </a:fillRef>
+          <a:effectRef idx="2">
+            <a:schemeClr val="accent1"/>
+          </a:effectRef>
+          <a:fontRef idx="minor">
+            <a:schemeClr val="lt1"/>
+          </a:fontRef>
+        </p:style>
+        <p:txBody>
+          <a:bodyPr rtlCol="0" anchor="ctr"/>
+          <a:lstStyle/>
+          <a:p>
+            <a:pPr algn="ctr"/>
+            <a:r>
+              <a:rPr sz="1500" b="1" i="0">
+                <a:solidFill>
+                  <a:srgbClr val="FFFFFF"/>
+                </a:solidFill>
+                <a:latin typeface="Calibri"/>
+              </a:rPr>
+              <a:t>CPU</a:t>
+            </a:r>
+          </a:p>
+        </p:txBody>
+      </p:sp>
+      <p:sp>
+        <p:nvSpPr>
+          <p:cNvPr id="17" name="Rounded Rectangle 16"/>
+          <p:cNvSpPr/>
+          <p:nvPr/>
+        </p:nvSpPr>
+        <p:spPr>
+          <a:xfrm>
+            <a:off x="9265615" y="3246120"/>
+            <a:ext cx="2148840" cy="502920"/>
+          </a:xfrm>
+          <a:prstGeom prst="roundRect">
+            <a:avLst/>
+          </a:prstGeom>
+          <a:solidFill>
+            <a:srgbClr val="1F2A44"/>
+          </a:solidFill>
+          <a:ln>
+            <a:noFill/>
+          </a:ln>
+          <a:effectLst/>
+        </p:spPr>
+        <p:style>
+          <a:lnRef idx="1">
+            <a:schemeClr val="accent1"/>
+          </a:lnRef>
+          <a:fillRef idx="3">
+            <a:schemeClr val="accent1"/>
+          </a:fillRef>
+          <a:effectRef idx="2">
+            <a:schemeClr val="accent1"/>
+          </a:effectRef>
+          <a:fontRef idx="minor">
+            <a:schemeClr val="lt1"/>
+          </a:fontRef>
+        </p:style>
+        <p:txBody>
+          <a:bodyPr rtlCol="0" anchor="ctr"/>
+          <a:lstStyle/>
+          <a:p>
+            <a:pPr algn="ctr"/>
+            <a:r>
+              <a:rPr sz="1500" b="1" i="0">
+                <a:solidFill>
+                  <a:srgbClr val="FFFFFF"/>
+                </a:solidFill>
+                <a:latin typeface="Calibri"/>
+              </a:rPr>
+              <a:t>GPU dedicada</a:t>
+            </a:r>
+          </a:p>
+        </p:txBody>
+      </p:sp>
+      <p:sp>
+        <p:nvSpPr>
+          <p:cNvPr id="18" name="Rounded Rectangle 17"/>
+          <p:cNvSpPr/>
+          <p:nvPr/>
+        </p:nvSpPr>
+        <p:spPr>
+          <a:xfrm>
+            <a:off x="9265615" y="4069080"/>
+            <a:ext cx="2148840" cy="502920"/>
+          </a:xfrm>
+          <a:prstGeom prst="roundRect">
+            <a:avLst/>
+          </a:prstGeom>
+          <a:solidFill>
+            <a:srgbClr val="1F2A44"/>
+          </a:solidFill>
+          <a:ln>
+            <a:noFill/>
+          </a:ln>
+          <a:effectLst/>
+        </p:spPr>
+        <p:style>
+          <a:lnRef idx="1">
+            <a:schemeClr val="accent1"/>
+          </a:lnRef>
+          <a:fillRef idx="3">
+            <a:schemeClr val="accent1"/>
+          </a:fillRef>
+          <a:effectRef idx="2">
+            <a:schemeClr val="accent1"/>
+          </a:effectRef>
+          <a:fontRef idx="minor">
+            <a:schemeClr val="lt1"/>
+          </a:fontRef>
+        </p:style>
+        <p:txBody>
+          <a:bodyPr rtlCol="0" anchor="ctr"/>
+          <a:lstStyle/>
+          <a:p>
+            <a:pPr algn="ctr"/>
+            <a:r>
+              <a:rPr sz="1500" b="1" i="0">
+                <a:solidFill>
+                  <a:srgbClr val="FFFFFF"/>
+                </a:solidFill>
+                <a:latin typeface="Calibri"/>
+              </a:rPr>
+              <a:t>RAM</a:t>
+            </a:r>
+          </a:p>
+        </p:txBody>
+      </p:sp>
+      <p:sp>
+        <p:nvSpPr>
+          <p:cNvPr id="19" name="TextBox 18"/>
+          <p:cNvSpPr txBox="1"/>
+          <p:nvPr/>
+        </p:nvSpPr>
+        <p:spPr>
+          <a:xfrm>
+            <a:off x="8991295" y="5349240"/>
+            <a:ext cx="2697480" cy="640080"/>
+          </a:xfrm>
+          <a:prstGeom prst="rect">
+            <a:avLst/>
+          </a:prstGeom>
+          <a:noFill/>
+        </p:spPr>
+        <p:txBody>
+          <a:bodyPr wrap="square" anchor="t" lIns="0" rIns="0" tIns="0" bIns="0">
+            <a:spAutoFit/>
+          </a:bodyPr>
+          <a:lstStyle/>
+          <a:p>
+            <a:pPr algn="ctr"/>
+            <a:r>
+              <a:rPr sz="1400" b="0" i="0">
+                <a:solidFill>
+                  <a:srgbClr val="1F2937"/>
+                </a:solidFill>
+                <a:latin typeface="Calibri"/>
+              </a:rPr>
+              <a:t>Componentes separados, con ventiladores</a:t>
+            </a:r>
+          </a:p>
+        </p:txBody>
+      </p:sp>
+      <p:sp>
+        <p:nvSpPr>
+          <p:cNvPr id="20" name="TextBox 19"/>
+          <p:cNvSpPr txBox="1"/>
+          <p:nvPr/>
+        </p:nvSpPr>
+        <p:spPr>
+          <a:xfrm>
             <a:off x="502920" y="1234440"/>
-            <a:ext cx="6979615" cy="4754880"/>
+            <a:ext cx="5242255" cy="4754880"/>
           </a:xfrm>
           <a:prstGeom prst="rect">
             <a:avLst/>

</xml_diff>